<commit_message>
Revise first three concept slides with formal treatment (T/F 1-3)
Co-Authored-By: Claude Opus 5.5 <noreply@anthropic.com>
Claude-Session: https://claude.ai/code/session_012Yma3oVhULpXzSWwtpL6B6
</commit_message>
<xml_diff>
--- a/Sec3A_5-Stock_Demo_Concept_Slides.pptx
+++ b/Sec3A_5-Stock_Demo_Concept_Slides.pptx
@@ -8,16 +8,6 @@
     <p:sldId id="256" r:id="rId7"/>
     <p:sldId id="257" r:id="rId8"/>
     <p:sldId id="258" r:id="rId9"/>
-    <p:sldId id="259" r:id="rId10"/>
-    <p:sldId id="260" r:id="rId11"/>
-    <p:sldId id="261" r:id="rId12"/>
-    <p:sldId id="262" r:id="rId13"/>
-    <p:sldId id="263" r:id="rId14"/>
-    <p:sldId id="264" r:id="rId15"/>
-    <p:sldId id="265" r:id="rId16"/>
-    <p:sldId id="266" r:id="rId17"/>
-    <p:sldId id="267" r:id="rId18"/>
-    <p:sldId id="268" r:id="rId19"/>
   </p:sldIdLst>
   <p:sldSz cx="12191695" cy="6858000" type="screen4x3"/>
   <p:notesSz cx="6858000" cy="9144000"/>
@@ -3108,7 +3098,75 @@
         </p:nvSpPr>
         <p:spPr>
           <a:xfrm>
-            <a:off x="548640" y="320040"/>
+            <a:off x="548640" y="274320"/>
+            <a:ext cx="11091672" cy="365760"/>
+          </a:xfrm>
+          <a:prstGeom prst="rect">
+            <a:avLst/>
+          </a:prstGeom>
+          <a:noFill/>
+        </p:spPr>
+        <p:txBody>
+          <a:bodyPr wrap="square">
+            <a:spAutoFit/>
+          </a:bodyPr>
+          <a:lstStyle/>
+          <a:p>
+            <a:r>
+              <a:rPr sz="1600" b="0" i="0">
+                <a:solidFill>
+                  <a:srgbClr val="595959"/>
+                </a:solidFill>
+                <a:latin typeface="Calibri"/>
+              </a:rPr>
+              <a:t>T/F 1</a:t>
+            </a:r>
+          </a:p>
+        </p:txBody>
+      </p:sp>
+      <p:sp>
+        <p:nvSpPr>
+          <p:cNvPr id="3" name="TextBox 2"/>
+          <p:cNvSpPr txBox="1"/>
+          <p:nvPr/>
+        </p:nvSpPr>
+        <p:spPr>
+          <a:xfrm>
+            <a:off x="548640" y="594360"/>
+            <a:ext cx="11091672" cy="640080"/>
+          </a:xfrm>
+          <a:prstGeom prst="rect">
+            <a:avLst/>
+          </a:prstGeom>
+          <a:noFill/>
+        </p:spPr>
+        <p:txBody>
+          <a:bodyPr wrap="square">
+            <a:spAutoFit/>
+          </a:bodyPr>
+          <a:lstStyle/>
+          <a:p>
+            <a:r>
+              <a:rPr sz="3000" b="1" i="0">
+                <a:solidFill>
+                  <a:srgbClr val="000000"/>
+                </a:solidFill>
+                <a:latin typeface="Calibri"/>
+              </a:rPr>
+              <a:t>Portfolio Constraints and the Investment Opportunity Set</a:t>
+            </a:r>
+          </a:p>
+        </p:txBody>
+      </p:sp>
+      <p:sp>
+        <p:nvSpPr>
+          <p:cNvPr id="4" name="TextBox 3"/>
+          <p:cNvSpPr txBox="1"/>
+          <p:nvPr/>
+        </p:nvSpPr>
+        <p:spPr>
+          <a:xfrm>
+            <a:off x="548640" y="1234440"/>
             <a:ext cx="11091672" cy="457200"/>
           </a:xfrm>
           <a:prstGeom prst="rect">
@@ -3123,27 +3181,27 @@
           <a:lstStyle/>
           <a:p>
             <a:r>
-              <a:rPr sz="2000" b="0" i="0">
+              <a:rPr sz="1800" b="0" i="1">
                 <a:solidFill>
                   <a:srgbClr val="595959"/>
                 </a:solidFill>
                 <a:latin typeface="Calibri"/>
               </a:rPr>
-              <a:t>T/F 1</a:t>
-            </a:r>
-          </a:p>
-        </p:txBody>
-      </p:sp>
-      <p:sp>
-        <p:nvSpPr>
-          <p:cNvPr id="3" name="TextBox 2"/>
+              <a:t>Relaxing a constraint enlarges the feasible set, so the optimum cannot deteriorate.</a:t>
+            </a:r>
+          </a:p>
+        </p:txBody>
+      </p:sp>
+      <p:sp>
+        <p:nvSpPr>
+          <p:cNvPr id="5" name="TextBox 4"/>
           <p:cNvSpPr txBox="1"/>
           <p:nvPr/>
         </p:nvSpPr>
         <p:spPr>
           <a:xfrm>
-            <a:off x="548640" y="731520"/>
-            <a:ext cx="11091672" cy="777240"/>
+            <a:off x="548640" y="1920240"/>
+            <a:ext cx="7223760" cy="4206240"/>
           </a:xfrm>
           <a:prstGeom prst="rect">
             <a:avLst/>
@@ -3156,98 +3214,201 @@
           </a:bodyPr>
           <a:lstStyle/>
           <a:p>
-            <a:r>
-              <a:rPr sz="3600" b="1" i="0">
+            <a:pPr marL="274320" indent="-274320">
+              <a:spcAft>
+                <a:spcPts val="1400"/>
+              </a:spcAft>
+              <a:buFont typeface="Arial"/>
+              <a:buChar char="•"/>
+            </a:pPr>
+            <a:r>
+              <a:rPr sz="1700">
                 <a:solidFill>
                   <a:srgbClr val="000000"/>
                 </a:solidFill>
                 <a:latin typeface="Calibri"/>
               </a:rPr>
-              <a:t>Adding choices can't hurt</a:t>
-            </a:r>
-          </a:p>
-        </p:txBody>
-      </p:sp>
-      <p:sp>
-        <p:nvSpPr>
-          <p:cNvPr id="4" name="TextBox 3"/>
-          <p:cNvSpPr txBox="1"/>
+              <a:t>The investment opportunity set is the set of all attainable (σp, E[rp]) combinations. The no-short-sale constraint (wᵢ ≥ 0) restricts it to a subset of the set available when weights may be negative.</a:t>
+            </a:r>
+          </a:p>
+          <a:p>
+            <a:pPr marL="274320" indent="-274320">
+              <a:spcAft>
+                <a:spcPts val="1400"/>
+              </a:spcAft>
+              <a:buFont typeface="Arial"/>
+              <a:buChar char="•"/>
+            </a:pPr>
+            <a:r>
+              <a:rPr sz="1700">
+                <a:solidFill>
+                  <a:srgbClr val="000000"/>
+                </a:solidFill>
+                <a:latin typeface="Calibri"/>
+              </a:rPr>
+              <a:t>Every portfolio feasible under the constraint remains feasible without it. Hence, at each target E[rp], the minimum attainable σp is weakly lower when short sales are permitted, and the maximum attainable Sharpe ratio is weakly higher.</a:t>
+            </a:r>
+          </a:p>
+          <a:p>
+            <a:pPr marL="274320" indent="-274320">
+              <a:spcAft>
+                <a:spcPts val="1400"/>
+              </a:spcAft>
+              <a:buFont typeface="Arial"/>
+              <a:buChar char="•"/>
+            </a:pPr>
+            <a:r>
+              <a:rPr sz="1700">
+                <a:solidFill>
+                  <a:srgbClr val="000000"/>
+                </a:solidFill>
+                <a:latin typeface="Calibri"/>
+              </a:rPr>
+              <a:t>The improvement is strict only when the constraint is binding. In Steps 7–9, several weights sit at the zero bound (e.g., VNQ in Steps 7 and 9); in Step 10, the optimizer exploits negative weights.</a:t>
+            </a:r>
+          </a:p>
+        </p:txBody>
+      </p:sp>
+      <p:sp>
+        <p:nvSpPr>
+          <p:cNvPr id="6" name="Rectangle 5"/>
+          <p:cNvSpPr/>
           <p:nvPr/>
         </p:nvSpPr>
         <p:spPr>
           <a:xfrm>
-            <a:off x="548640" y="1828800"/>
-            <a:ext cx="11091672" cy="3931920"/>
+            <a:off x="8092440" y="1920240"/>
+            <a:ext cx="3547872" cy="2514600"/>
           </a:xfrm>
           <a:prstGeom prst="rect">
             <a:avLst/>
           </a:prstGeom>
-          <a:noFill/>
+          <a:solidFill>
+            <a:srgbClr val="F2F2F2"/>
+          </a:solidFill>
+          <a:ln>
+            <a:noFill/>
+          </a:ln>
+          <a:effectLst/>
         </p:spPr>
-        <p:txBody>
-          <a:bodyPr wrap="square">
-            <a:spAutoFit/>
-          </a:bodyPr>
-          <a:lstStyle/>
-          <a:p>
-            <a:pPr marL="411480" indent="-411480">
+        <p:style>
+          <a:lnRef idx="1">
+            <a:schemeClr val="accent1"/>
+          </a:lnRef>
+          <a:fillRef idx="3">
+            <a:schemeClr val="accent1"/>
+          </a:fillRef>
+          <a:effectRef idx="2">
+            <a:schemeClr val="accent1"/>
+          </a:effectRef>
+          <a:fontRef idx="minor">
+            <a:schemeClr val="lt1"/>
+          </a:fontRef>
+        </p:style>
+        <p:txBody>
+          <a:bodyPr rtlCol="0" anchor="t" wrap="square" lIns="182880" rIns="182880" tIns="182880"/>
+          <a:lstStyle/>
+          <a:p>
+            <a:pPr algn="l">
               <a:spcAft>
-                <a:spcPts val="2400"/>
+                <a:spcPts val="1000"/>
               </a:spcAft>
-              <a:buFont typeface="Arial"/>
-              <a:buChar char="•"/>
             </a:pPr>
             <a:r>
-              <a:rPr sz="2800">
+              <a:rPr sz="1600" b="1">
                 <a:solidFill>
                   <a:srgbClr val="000000"/>
                 </a:solidFill>
                 <a:latin typeface="Calibri"/>
               </a:rPr>
-              <a:t>No shorting means every weight must be ≥ 0; shorting removes that limit</a:t>
-            </a:r>
-          </a:p>
-          <a:p>
-            <a:pPr marL="411480" indent="-411480">
+              <a:t>Formal statement</a:t>
+            </a:r>
+          </a:p>
+          <a:p>
+            <a:pPr>
               <a:spcAft>
-                <a:spcPts val="2400"/>
+                <a:spcPts val="600"/>
               </a:spcAft>
-              <a:buFont typeface="Arial"/>
-              <a:buChar char="•"/>
             </a:pPr>
             <a:r>
-              <a:rPr sz="2800">
+              <a:rPr sz="1500">
                 <a:solidFill>
                   <a:srgbClr val="000000"/>
                 </a:solidFill>
-                <a:latin typeface="Calibri"/>
+                <a:latin typeface="Cambria"/>
               </a:rPr>
-              <a:t>Every no-short portfolio is still available when shorting is allowed</a:t>
-            </a:r>
-          </a:p>
-          <a:p>
-            <a:pPr marL="411480" indent="-411480">
+              <a:t>F_NS = { w : Σwᵢ = 1,  wᵢ ≥ 0 }</a:t>
+            </a:r>
+          </a:p>
+          <a:p>
+            <a:pPr>
               <a:spcAft>
-                <a:spcPts val="2400"/>
+                <a:spcPts val="600"/>
               </a:spcAft>
-              <a:buFont typeface="Arial"/>
-              <a:buChar char="•"/>
             </a:pPr>
             <a:r>
-              <a:rPr sz="2800">
+              <a:rPr sz="1500">
                 <a:solidFill>
                   <a:srgbClr val="000000"/>
                 </a:solidFill>
-                <a:latin typeface="Calibri"/>
+                <a:latin typeface="Cambria"/>
               </a:rPr>
-              <a:t>A bigger menu can only match or beat the best option on a smaller menu</a:t>
-            </a:r>
-          </a:p>
-        </p:txBody>
-      </p:sp>
-      <p:sp>
-        <p:nvSpPr>
-          <p:cNvPr id="5" name="TextBox 4"/>
+              <a:t>F_S  = { w : Σwᵢ = 1 }</a:t>
+            </a:r>
+          </a:p>
+          <a:p>
+            <a:pPr>
+              <a:spcAft>
+                <a:spcPts val="600"/>
+              </a:spcAft>
+            </a:pPr>
+            <a:r>
+              <a:rPr sz="1500">
+                <a:solidFill>
+                  <a:srgbClr val="000000"/>
+                </a:solidFill>
+                <a:latin typeface="Cambria"/>
+              </a:rPr>
+              <a:t>F_NS ⊆ F_S  ⇒</a:t>
+            </a:r>
+          </a:p>
+          <a:p>
+            <a:pPr>
+              <a:spcAft>
+                <a:spcPts val="600"/>
+              </a:spcAft>
+            </a:pPr>
+            <a:r>
+              <a:rPr sz="1500">
+                <a:solidFill>
+                  <a:srgbClr val="000000"/>
+                </a:solidFill>
+                <a:latin typeface="Cambria"/>
+              </a:rPr>
+              <a:t>min σp(m | F_S) ≤ min σp(m | F_NS)</a:t>
+            </a:r>
+          </a:p>
+          <a:p>
+            <a:pPr>
+              <a:spcAft>
+                <a:spcPts val="600"/>
+              </a:spcAft>
+            </a:pPr>
+            <a:r>
+              <a:rPr sz="1500">
+                <a:solidFill>
+                  <a:srgbClr val="000000"/>
+                </a:solidFill>
+                <a:latin typeface="Cambria"/>
+              </a:rPr>
+              <a:t>max Sp(F_S) ≥ max Sp(F_NS)</a:t>
+            </a:r>
+          </a:p>
+        </p:txBody>
+      </p:sp>
+      <p:sp>
+        <p:nvSpPr>
+          <p:cNvPr id="7" name="TextBox 6"/>
           <p:cNvSpPr txBox="1"/>
           <p:nvPr/>
         </p:nvSpPr>
@@ -3268,7 +3429,7 @@
           <a:lstStyle/>
           <a:p>
             <a:r>
-              <a:rPr sz="2200" b="0" i="0">
+              <a:rPr sz="1400" b="0" i="0">
                 <a:solidFill>
                   <a:srgbClr val="000000"/>
                 </a:solidFill>
@@ -3281,7 +3442,7 @@
       </p:sp>
       <p:sp>
         <p:nvSpPr>
-          <p:cNvPr id="6" name="TextBox 5"/>
+          <p:cNvPr id="8" name="TextBox 7"/>
           <p:cNvSpPr txBox="1"/>
           <p:nvPr/>
         </p:nvSpPr>
@@ -3303,941 +3464,13 @@
           <a:p>
             <a:pPr algn="r"/>
             <a:r>
-              <a:rPr sz="2200" b="0" i="0">
+              <a:rPr sz="1400" b="0" i="0">
                 <a:solidFill>
                   <a:srgbClr val="000000"/>
                 </a:solidFill>
                 <a:latin typeface="Calibri"/>
               </a:rPr>
               <a:t>Row 124</a:t>
-            </a:r>
-          </a:p>
-        </p:txBody>
-      </p:sp>
-    </p:spTree>
-  </p:cSld>
-  <p:clrMapOvr>
-    <a:masterClrMapping/>
-  </p:clrMapOvr>
-</p:sld>
-</file>
-
-<file path=ppt/slides/slide10.xml><?xml version="1.0" encoding="utf-8"?>
-<p:sld xmlns:a="http://schemas.openxmlformats.org/drawingml/2006/main" xmlns:p="http://schemas.openxmlformats.org/presentationml/2006/main" xmlns:r="http://schemas.openxmlformats.org/officeDocument/2006/relationships">
-  <p:cSld>
-    <p:spTree>
-      <p:nvGrpSpPr>
-        <p:cNvPr id="1" name=""/>
-        <p:cNvGrpSpPr/>
-        <p:nvPr/>
-      </p:nvGrpSpPr>
-      <p:grpSpPr/>
-      <p:sp>
-        <p:nvSpPr>
-          <p:cNvPr id="2" name="TextBox 1"/>
-          <p:cNvSpPr txBox="1"/>
-          <p:nvPr/>
-        </p:nvSpPr>
-        <p:spPr>
-          <a:xfrm>
-            <a:off x="548640" y="320040"/>
-            <a:ext cx="11091672" cy="457200"/>
-          </a:xfrm>
-          <a:prstGeom prst="rect">
-            <a:avLst/>
-          </a:prstGeom>
-          <a:noFill/>
-        </p:spPr>
-        <p:txBody>
-          <a:bodyPr wrap="square">
-            <a:spAutoFit/>
-          </a:bodyPr>
-          <a:lstStyle/>
-          <a:p>
-            <a:r>
-              <a:rPr sz="2000" b="0" i="0">
-                <a:solidFill>
-                  <a:srgbClr val="595959"/>
-                </a:solidFill>
-                <a:latin typeface="Calibri"/>
-              </a:rPr>
-              <a:t>T/F 10</a:t>
-            </a:r>
-          </a:p>
-        </p:txBody>
-      </p:sp>
-      <p:sp>
-        <p:nvSpPr>
-          <p:cNvPr id="3" name="TextBox 2"/>
-          <p:cNvSpPr txBox="1"/>
-          <p:nvPr/>
-        </p:nvSpPr>
-        <p:spPr>
-          <a:xfrm>
-            <a:off x="548640" y="731520"/>
-            <a:ext cx="11091672" cy="777240"/>
-          </a:xfrm>
-          <a:prstGeom prst="rect">
-            <a:avLst/>
-          </a:prstGeom>
-          <a:noFill/>
-        </p:spPr>
-        <p:txBody>
-          <a:bodyPr wrap="square">
-            <a:spAutoFit/>
-          </a:bodyPr>
-          <a:lstStyle/>
-          <a:p>
-            <a:r>
-              <a:rPr sz="3600" b="1" i="0">
-                <a:solidFill>
-                  <a:srgbClr val="000000"/>
-                </a:solidFill>
-                <a:latin typeface="Calibri"/>
-              </a:rPr>
-              <a:t>Lowest risk ≠ best reward per risk</a:t>
-            </a:r>
-          </a:p>
-        </p:txBody>
-      </p:sp>
-      <p:sp>
-        <p:nvSpPr>
-          <p:cNvPr id="4" name="TextBox 3"/>
-          <p:cNvSpPr txBox="1"/>
-          <p:nvPr/>
-        </p:nvSpPr>
-        <p:spPr>
-          <a:xfrm>
-            <a:off x="548640" y="1828800"/>
-            <a:ext cx="11091672" cy="3931920"/>
-          </a:xfrm>
-          <a:prstGeom prst="rect">
-            <a:avLst/>
-          </a:prstGeom>
-          <a:noFill/>
-        </p:spPr>
-        <p:txBody>
-          <a:bodyPr wrap="square">
-            <a:spAutoFit/>
-          </a:bodyPr>
-          <a:lstStyle/>
-          <a:p>
-            <a:pPr marL="411480" indent="-411480">
-              <a:spcAft>
-                <a:spcPts val="2400"/>
-              </a:spcAft>
-              <a:buFont typeface="Arial"/>
-              <a:buChar char="•"/>
-            </a:pPr>
-            <a:r>
-              <a:rPr sz="2800">
-                <a:solidFill>
-                  <a:srgbClr val="000000"/>
-                </a:solidFill>
-                <a:latin typeface="Calibri"/>
-              </a:rPr>
-              <a:t>The minimum-variance portfolio minimizes σp and ignores return</a:t>
-            </a:r>
-          </a:p>
-          <a:p>
-            <a:pPr marL="411480" indent="-411480">
-              <a:spcAft>
-                <a:spcPts val="2400"/>
-              </a:spcAft>
-              <a:buFont typeface="Arial"/>
-              <a:buChar char="•"/>
-            </a:pPr>
-            <a:r>
-              <a:rPr sz="2800">
-                <a:solidFill>
-                  <a:srgbClr val="000000"/>
-                </a:solidFill>
-                <a:latin typeface="Calibri"/>
-              </a:rPr>
-              <a:t>Sharpe = (E[rp] − rf) / σp: excess return per unit of risk</a:t>
-            </a:r>
-          </a:p>
-          <a:p>
-            <a:pPr marL="411480" indent="-411480">
-              <a:spcAft>
-                <a:spcPts val="2400"/>
-              </a:spcAft>
-              <a:buFont typeface="Arial"/>
-              <a:buChar char="•"/>
-            </a:pPr>
-            <a:r>
-              <a:rPr sz="2800">
-                <a:solidFill>
-                  <a:srgbClr val="000000"/>
-                </a:solidFill>
-                <a:latin typeface="Calibri"/>
-              </a:rPr>
-              <a:t>Check: Step 8's return (1.10%) versus rf (3%)</a:t>
-            </a:r>
-          </a:p>
-        </p:txBody>
-      </p:sp>
-      <p:sp>
-        <p:nvSpPr>
-          <p:cNvPr id="5" name="TextBox 4"/>
-          <p:cNvSpPr txBox="1"/>
-          <p:nvPr/>
-        </p:nvSpPr>
-        <p:spPr>
-          <a:xfrm>
-            <a:off x="548640" y="6263640"/>
-            <a:ext cx="8229600" cy="411480"/>
-          </a:xfrm>
-          <a:prstGeom prst="rect">
-            <a:avLst/>
-          </a:prstGeom>
-          <a:noFill/>
-        </p:spPr>
-        <p:txBody>
-          <a:bodyPr wrap="square">
-            <a:spAutoFit/>
-          </a:bodyPr>
-          <a:lstStyle/>
-          <a:p>
-            <a:r>
-              <a:rPr sz="2200" b="0" i="0">
-                <a:solidFill>
-                  <a:srgbClr val="000000"/>
-                </a:solidFill>
-                <a:latin typeface="Calibri"/>
-              </a:rPr>
-              <a:t>Sheet: Sec 3A - 5-Stock Demo</a:t>
-            </a:r>
-          </a:p>
-        </p:txBody>
-      </p:sp>
-      <p:sp>
-        <p:nvSpPr>
-          <p:cNvPr id="6" name="TextBox 5"/>
-          <p:cNvSpPr txBox="1"/>
-          <p:nvPr/>
-        </p:nvSpPr>
-        <p:spPr>
-          <a:xfrm>
-            <a:off x="9326880" y="6263640"/>
-            <a:ext cx="2313432" cy="411480"/>
-          </a:xfrm>
-          <a:prstGeom prst="rect">
-            <a:avLst/>
-          </a:prstGeom>
-          <a:noFill/>
-        </p:spPr>
-        <p:txBody>
-          <a:bodyPr wrap="square">
-            <a:spAutoFit/>
-          </a:bodyPr>
-          <a:lstStyle/>
-          <a:p>
-            <a:pPr algn="r"/>
-            <a:r>
-              <a:rPr sz="2200" b="0" i="0">
-                <a:solidFill>
-                  <a:srgbClr val="000000"/>
-                </a:solidFill>
-                <a:latin typeface="Calibri"/>
-              </a:rPr>
-              <a:t>Row 197</a:t>
-            </a:r>
-          </a:p>
-        </p:txBody>
-      </p:sp>
-    </p:spTree>
-  </p:cSld>
-  <p:clrMapOvr>
-    <a:masterClrMapping/>
-  </p:clrMapOvr>
-</p:sld>
-</file>
-
-<file path=ppt/slides/slide11.xml><?xml version="1.0" encoding="utf-8"?>
-<p:sld xmlns:a="http://schemas.openxmlformats.org/drawingml/2006/main" xmlns:p="http://schemas.openxmlformats.org/presentationml/2006/main" xmlns:r="http://schemas.openxmlformats.org/officeDocument/2006/relationships">
-  <p:cSld>
-    <p:spTree>
-      <p:nvGrpSpPr>
-        <p:cNvPr id="1" name=""/>
-        <p:cNvGrpSpPr/>
-        <p:nvPr/>
-      </p:nvGrpSpPr>
-      <p:grpSpPr/>
-      <p:sp>
-        <p:nvSpPr>
-          <p:cNvPr id="2" name="TextBox 1"/>
-          <p:cNvSpPr txBox="1"/>
-          <p:nvPr/>
-        </p:nvSpPr>
-        <p:spPr>
-          <a:xfrm>
-            <a:off x="548640" y="320040"/>
-            <a:ext cx="11091672" cy="457200"/>
-          </a:xfrm>
-          <a:prstGeom prst="rect">
-            <a:avLst/>
-          </a:prstGeom>
-          <a:noFill/>
-        </p:spPr>
-        <p:txBody>
-          <a:bodyPr wrap="square">
-            <a:spAutoFit/>
-          </a:bodyPr>
-          <a:lstStyle/>
-          <a:p>
-            <a:r>
-              <a:rPr sz="2000" b="0" i="0">
-                <a:solidFill>
-                  <a:srgbClr val="595959"/>
-                </a:solidFill>
-                <a:latin typeface="Calibri"/>
-              </a:rPr>
-              <a:t>T/F 11</a:t>
-            </a:r>
-          </a:p>
-        </p:txBody>
-      </p:sp>
-      <p:sp>
-        <p:nvSpPr>
-          <p:cNvPr id="3" name="TextBox 2"/>
-          <p:cNvSpPr txBox="1"/>
-          <p:nvPr/>
-        </p:nvSpPr>
-        <p:spPr>
-          <a:xfrm>
-            <a:off x="548640" y="731520"/>
-            <a:ext cx="11091672" cy="777240"/>
-          </a:xfrm>
-          <a:prstGeom prst="rect">
-            <a:avLst/>
-          </a:prstGeom>
-          <a:noFill/>
-        </p:spPr>
-        <p:txBody>
-          <a:bodyPr wrap="square">
-            <a:spAutoFit/>
-          </a:bodyPr>
-          <a:lstStyle/>
-          <a:p>
-            <a:r>
-              <a:rPr sz="3600" b="1" i="0">
-                <a:solidFill>
-                  <a:srgbClr val="000000"/>
-                </a:solidFill>
-                <a:latin typeface="Calibri"/>
-              </a:rPr>
-              <a:t>What a negative weight means</a:t>
-            </a:r>
-          </a:p>
-        </p:txBody>
-      </p:sp>
-      <p:sp>
-        <p:nvSpPr>
-          <p:cNvPr id="4" name="TextBox 3"/>
-          <p:cNvSpPr txBox="1"/>
-          <p:nvPr/>
-        </p:nvSpPr>
-        <p:spPr>
-          <a:xfrm>
-            <a:off x="548640" y="1828800"/>
-            <a:ext cx="11091672" cy="3931920"/>
-          </a:xfrm>
-          <a:prstGeom prst="rect">
-            <a:avLst/>
-          </a:prstGeom>
-          <a:noFill/>
-        </p:spPr>
-        <p:txBody>
-          <a:bodyPr wrap="square">
-            <a:spAutoFit/>
-          </a:bodyPr>
-          <a:lstStyle/>
-          <a:p>
-            <a:pPr marL="411480" indent="-411480">
-              <a:spcAft>
-                <a:spcPts val="2400"/>
-              </a:spcAft>
-              <a:buFont typeface="Arial"/>
-              <a:buChar char="•"/>
-            </a:pPr>
-            <a:r>
-              <a:rPr sz="2800">
-                <a:solidFill>
-                  <a:srgbClr val="000000"/>
-                </a:solidFill>
-                <a:latin typeface="Calibri"/>
-              </a:rPr>
-              <a:t>Weights are shares of your own money and sum to 100%</a:t>
-            </a:r>
-          </a:p>
-          <a:p>
-            <a:pPr marL="411480" indent="-411480">
-              <a:spcAft>
-                <a:spcPts val="2400"/>
-              </a:spcAft>
-              <a:buFont typeface="Arial"/>
-              <a:buChar char="•"/>
-            </a:pPr>
-            <a:r>
-              <a:rPr sz="2800">
-                <a:solidFill>
-                  <a:srgbClr val="000000"/>
-                </a:solidFill>
-                <a:latin typeface="Calibri"/>
-              </a:rPr>
-              <a:t>Negative weight: borrow the asset, sell it, and use the cash to buy others</a:t>
-            </a:r>
-          </a:p>
-          <a:p>
-            <a:pPr marL="411480" indent="-411480">
-              <a:spcAft>
-                <a:spcPts val="2400"/>
-              </a:spcAft>
-              <a:buFont typeface="Arial"/>
-              <a:buChar char="•"/>
-            </a:pPr>
-            <a:r>
-              <a:rPr sz="2800">
-                <a:solidFill>
-                  <a:srgbClr val="000000"/>
-                </a:solidFill>
-                <a:latin typeface="Calibri"/>
-              </a:rPr>
-              <a:t>$100 → short $119 VNQ and $110 AGG, buy $329 of AAPL, WMT and JPM</a:t>
-            </a:r>
-          </a:p>
-        </p:txBody>
-      </p:sp>
-      <p:sp>
-        <p:nvSpPr>
-          <p:cNvPr id="5" name="TextBox 4"/>
-          <p:cNvSpPr txBox="1"/>
-          <p:nvPr/>
-        </p:nvSpPr>
-        <p:spPr>
-          <a:xfrm>
-            <a:off x="548640" y="6263640"/>
-            <a:ext cx="8229600" cy="411480"/>
-          </a:xfrm>
-          <a:prstGeom prst="rect">
-            <a:avLst/>
-          </a:prstGeom>
-          <a:noFill/>
-        </p:spPr>
-        <p:txBody>
-          <a:bodyPr wrap="square">
-            <a:spAutoFit/>
-          </a:bodyPr>
-          <a:lstStyle/>
-          <a:p>
-            <a:r>
-              <a:rPr sz="2200" b="0" i="0">
-                <a:solidFill>
-                  <a:srgbClr val="000000"/>
-                </a:solidFill>
-                <a:latin typeface="Calibri"/>
-              </a:rPr>
-              <a:t>Sheet: Sec 3A - 5-Stock Demo</a:t>
-            </a:r>
-          </a:p>
-        </p:txBody>
-      </p:sp>
-      <p:sp>
-        <p:nvSpPr>
-          <p:cNvPr id="6" name="TextBox 5"/>
-          <p:cNvSpPr txBox="1"/>
-          <p:nvPr/>
-        </p:nvSpPr>
-        <p:spPr>
-          <a:xfrm>
-            <a:off x="9326880" y="6263640"/>
-            <a:ext cx="2313432" cy="411480"/>
-          </a:xfrm>
-          <a:prstGeom prst="rect">
-            <a:avLst/>
-          </a:prstGeom>
-          <a:noFill/>
-        </p:spPr>
-        <p:txBody>
-          <a:bodyPr wrap="square">
-            <a:spAutoFit/>
-          </a:bodyPr>
-          <a:lstStyle/>
-          <a:p>
-            <a:pPr algn="r"/>
-            <a:r>
-              <a:rPr sz="2200" b="0" i="0">
-                <a:solidFill>
-                  <a:srgbClr val="000000"/>
-                </a:solidFill>
-                <a:latin typeface="Calibri"/>
-              </a:rPr>
-              <a:t>Row 200</a:t>
-            </a:r>
-          </a:p>
-        </p:txBody>
-      </p:sp>
-    </p:spTree>
-  </p:cSld>
-  <p:clrMapOvr>
-    <a:masterClrMapping/>
-  </p:clrMapOvr>
-</p:sld>
-</file>
-
-<file path=ppt/slides/slide12.xml><?xml version="1.0" encoding="utf-8"?>
-<p:sld xmlns:a="http://schemas.openxmlformats.org/drawingml/2006/main" xmlns:p="http://schemas.openxmlformats.org/presentationml/2006/main" xmlns:r="http://schemas.openxmlformats.org/officeDocument/2006/relationships">
-  <p:cSld>
-    <p:spTree>
-      <p:nvGrpSpPr>
-        <p:cNvPr id="1" name=""/>
-        <p:cNvGrpSpPr/>
-        <p:nvPr/>
-      </p:nvGrpSpPr>
-      <p:grpSpPr/>
-      <p:sp>
-        <p:nvSpPr>
-          <p:cNvPr id="2" name="TextBox 1"/>
-          <p:cNvSpPr txBox="1"/>
-          <p:nvPr/>
-        </p:nvSpPr>
-        <p:spPr>
-          <a:xfrm>
-            <a:off x="548640" y="320040"/>
-            <a:ext cx="11091672" cy="457200"/>
-          </a:xfrm>
-          <a:prstGeom prst="rect">
-            <a:avLst/>
-          </a:prstGeom>
-          <a:noFill/>
-        </p:spPr>
-        <p:txBody>
-          <a:bodyPr wrap="square">
-            <a:spAutoFit/>
-          </a:bodyPr>
-          <a:lstStyle/>
-          <a:p>
-            <a:r>
-              <a:rPr sz="2000" b="0" i="0">
-                <a:solidFill>
-                  <a:srgbClr val="595959"/>
-                </a:solidFill>
-                <a:latin typeface="Calibri"/>
-              </a:rPr>
-              <a:t>MCQ 12</a:t>
-            </a:r>
-          </a:p>
-        </p:txBody>
-      </p:sp>
-      <p:sp>
-        <p:nvSpPr>
-          <p:cNvPr id="3" name="TextBox 2"/>
-          <p:cNvSpPr txBox="1"/>
-          <p:nvPr/>
-        </p:nvSpPr>
-        <p:spPr>
-          <a:xfrm>
-            <a:off x="548640" y="731520"/>
-            <a:ext cx="11091672" cy="777240"/>
-          </a:xfrm>
-          <a:prstGeom prst="rect">
-            <a:avLst/>
-          </a:prstGeom>
-          <a:noFill/>
-        </p:spPr>
-        <p:txBody>
-          <a:bodyPr wrap="square">
-            <a:spAutoFit/>
-          </a:bodyPr>
-          <a:lstStyle/>
-          <a:p>
-            <a:r>
-              <a:rPr sz="3600" b="1" i="0">
-                <a:solidFill>
-                  <a:srgbClr val="000000"/>
-                </a:solidFill>
-                <a:latin typeface="Calibri"/>
-              </a:rPr>
-              <a:t>A is the price of risk</a:t>
-            </a:r>
-          </a:p>
-        </p:txBody>
-      </p:sp>
-      <p:sp>
-        <p:nvSpPr>
-          <p:cNvPr id="4" name="TextBox 3"/>
-          <p:cNvSpPr txBox="1"/>
-          <p:nvPr/>
-        </p:nvSpPr>
-        <p:spPr>
-          <a:xfrm>
-            <a:off x="548640" y="1828800"/>
-            <a:ext cx="11091672" cy="3931920"/>
-          </a:xfrm>
-          <a:prstGeom prst="rect">
-            <a:avLst/>
-          </a:prstGeom>
-          <a:noFill/>
-        </p:spPr>
-        <p:txBody>
-          <a:bodyPr wrap="square">
-            <a:spAutoFit/>
-          </a:bodyPr>
-          <a:lstStyle/>
-          <a:p>
-            <a:pPr marL="411480" indent="-411480">
-              <a:spcAft>
-                <a:spcPts val="2400"/>
-              </a:spcAft>
-              <a:buFont typeface="Arial"/>
-              <a:buChar char="•"/>
-            </a:pPr>
-            <a:r>
-              <a:rPr sz="2800">
-                <a:solidFill>
-                  <a:srgbClr val="000000"/>
-                </a:solidFill>
-                <a:latin typeface="Calibri"/>
-              </a:rPr>
-              <a:t>U = E(rp) − (A/2)σp²: A sets the penalty on variance</a:t>
-            </a:r>
-          </a:p>
-          <a:p>
-            <a:pPr marL="411480" indent="-411480">
-              <a:spcAft>
-                <a:spcPts val="2400"/>
-              </a:spcAft>
-              <a:buFont typeface="Arial"/>
-              <a:buChar char="•"/>
-            </a:pPr>
-            <a:r>
-              <a:rPr sz="2800">
-                <a:solidFill>
-                  <a:srgbClr val="000000"/>
-                </a:solidFill>
-                <a:latin typeface="Calibri"/>
-              </a:rPr>
-              <a:t>Higher A makes each unit of variance cost more utility</a:t>
-            </a:r>
-          </a:p>
-          <a:p>
-            <a:pPr marL="411480" indent="-411480">
-              <a:spcAft>
-                <a:spcPts val="2400"/>
-              </a:spcAft>
-              <a:buFont typeface="Arial"/>
-              <a:buChar char="•"/>
-            </a:pPr>
-            <a:r>
-              <a:rPr sz="2800">
-                <a:solidFill>
-                  <a:srgbClr val="000000"/>
-                </a:solidFill>
-                <a:latin typeface="Calibri"/>
-              </a:rPr>
-              <a:t>Solver gives up some return to cut risk</a:t>
-            </a:r>
-          </a:p>
-        </p:txBody>
-      </p:sp>
-      <p:sp>
-        <p:nvSpPr>
-          <p:cNvPr id="5" name="TextBox 4"/>
-          <p:cNvSpPr txBox="1"/>
-          <p:nvPr/>
-        </p:nvSpPr>
-        <p:spPr>
-          <a:xfrm>
-            <a:off x="548640" y="6263640"/>
-            <a:ext cx="8229600" cy="411480"/>
-          </a:xfrm>
-          <a:prstGeom prst="rect">
-            <a:avLst/>
-          </a:prstGeom>
-          <a:noFill/>
-        </p:spPr>
-        <p:txBody>
-          <a:bodyPr wrap="square">
-            <a:spAutoFit/>
-          </a:bodyPr>
-          <a:lstStyle/>
-          <a:p>
-            <a:r>
-              <a:rPr sz="2200" b="0" i="0">
-                <a:solidFill>
-                  <a:srgbClr val="000000"/>
-                </a:solidFill>
-                <a:latin typeface="Calibri"/>
-              </a:rPr>
-              <a:t>Sheet: Sec 3A - 5-Stock Demo</a:t>
-            </a:r>
-          </a:p>
-        </p:txBody>
-      </p:sp>
-      <p:sp>
-        <p:nvSpPr>
-          <p:cNvPr id="6" name="TextBox 5"/>
-          <p:cNvSpPr txBox="1"/>
-          <p:nvPr/>
-        </p:nvSpPr>
-        <p:spPr>
-          <a:xfrm>
-            <a:off x="9326880" y="6263640"/>
-            <a:ext cx="2313432" cy="411480"/>
-          </a:xfrm>
-          <a:prstGeom prst="rect">
-            <a:avLst/>
-          </a:prstGeom>
-          <a:noFill/>
-        </p:spPr>
-        <p:txBody>
-          <a:bodyPr wrap="square">
-            <a:spAutoFit/>
-          </a:bodyPr>
-          <a:lstStyle/>
-          <a:p>
-            <a:pPr algn="r"/>
-            <a:r>
-              <a:rPr sz="2200" b="0" i="0">
-                <a:solidFill>
-                  <a:srgbClr val="000000"/>
-                </a:solidFill>
-                <a:latin typeface="Calibri"/>
-              </a:rPr>
-              <a:t>Row 203</a:t>
-            </a:r>
-          </a:p>
-        </p:txBody>
-      </p:sp>
-    </p:spTree>
-  </p:cSld>
-  <p:clrMapOvr>
-    <a:masterClrMapping/>
-  </p:clrMapOvr>
-</p:sld>
-</file>
-
-<file path=ppt/slides/slide13.xml><?xml version="1.0" encoding="utf-8"?>
-<p:sld xmlns:a="http://schemas.openxmlformats.org/drawingml/2006/main" xmlns:p="http://schemas.openxmlformats.org/presentationml/2006/main" xmlns:r="http://schemas.openxmlformats.org/officeDocument/2006/relationships">
-  <p:cSld>
-    <p:spTree>
-      <p:nvGrpSpPr>
-        <p:cNvPr id="1" name=""/>
-        <p:cNvGrpSpPr/>
-        <p:nvPr/>
-      </p:nvGrpSpPr>
-      <p:grpSpPr/>
-      <p:sp>
-        <p:nvSpPr>
-          <p:cNvPr id="2" name="TextBox 1"/>
-          <p:cNvSpPr txBox="1"/>
-          <p:nvPr/>
-        </p:nvSpPr>
-        <p:spPr>
-          <a:xfrm>
-            <a:off x="548640" y="320040"/>
-            <a:ext cx="11091672" cy="457200"/>
-          </a:xfrm>
-          <a:prstGeom prst="rect">
-            <a:avLst/>
-          </a:prstGeom>
-          <a:noFill/>
-        </p:spPr>
-        <p:txBody>
-          <a:bodyPr wrap="square">
-            <a:spAutoFit/>
-          </a:bodyPr>
-          <a:lstStyle/>
-          <a:p>
-            <a:r>
-              <a:rPr sz="2000" b="0" i="0">
-                <a:solidFill>
-                  <a:srgbClr val="595959"/>
-                </a:solidFill>
-                <a:latin typeface="Calibri"/>
-              </a:rPr>
-              <a:t>T/F 13</a:t>
-            </a:r>
-          </a:p>
-        </p:txBody>
-      </p:sp>
-      <p:sp>
-        <p:nvSpPr>
-          <p:cNvPr id="3" name="TextBox 2"/>
-          <p:cNvSpPr txBox="1"/>
-          <p:nvPr/>
-        </p:nvSpPr>
-        <p:spPr>
-          <a:xfrm>
-            <a:off x="548640" y="731520"/>
-            <a:ext cx="11091672" cy="777240"/>
-          </a:xfrm>
-          <a:prstGeom prst="rect">
-            <a:avLst/>
-          </a:prstGeom>
-          <a:noFill/>
-        </p:spPr>
-        <p:txBody>
-          <a:bodyPr wrap="square">
-            <a:spAutoFit/>
-          </a:bodyPr>
-          <a:lstStyle/>
-          <a:p>
-            <a:r>
-              <a:rPr sz="3600" b="1" i="0">
-                <a:solidFill>
-                  <a:srgbClr val="000000"/>
-                </a:solidFill>
-                <a:latin typeface="Calibri"/>
-              </a:rPr>
-              <a:t>The bottom half of the curve</a:t>
-            </a:r>
-          </a:p>
-        </p:txBody>
-      </p:sp>
-      <p:sp>
-        <p:nvSpPr>
-          <p:cNvPr id="4" name="TextBox 3"/>
-          <p:cNvSpPr txBox="1"/>
-          <p:nvPr/>
-        </p:nvSpPr>
-        <p:spPr>
-          <a:xfrm>
-            <a:off x="548640" y="1828800"/>
-            <a:ext cx="11091672" cy="3931920"/>
-          </a:xfrm>
-          <a:prstGeom prst="rect">
-            <a:avLst/>
-          </a:prstGeom>
-          <a:noFill/>
-        </p:spPr>
-        <p:txBody>
-          <a:bodyPr wrap="square">
-            <a:spAutoFit/>
-          </a:bodyPr>
-          <a:lstStyle/>
-          <a:p>
-            <a:pPr marL="411480" indent="-411480">
-              <a:spcAft>
-                <a:spcPts val="2400"/>
-              </a:spcAft>
-              <a:buFont typeface="Arial"/>
-              <a:buChar char="•"/>
-            </a:pPr>
-            <a:r>
-              <a:rPr sz="2800">
-                <a:solidFill>
-                  <a:srgbClr val="000000"/>
-                </a:solidFill>
-                <a:latin typeface="Calibri"/>
-              </a:rPr>
-              <a:t>Below G, the minimum-variance curve bends back</a:t>
-            </a:r>
-          </a:p>
-          <a:p>
-            <a:pPr marL="411480" indent="-411480">
-              <a:spcAft>
-                <a:spcPts val="2400"/>
-              </a:spcAft>
-              <a:buFont typeface="Arial"/>
-              <a:buChar char="•"/>
-            </a:pPr>
-            <a:r>
-              <a:rPr sz="2800">
-                <a:solidFill>
-                  <a:srgbClr val="000000"/>
-                </a:solidFill>
-                <a:latin typeface="Calibri"/>
-              </a:rPr>
-              <a:t>Draw a vertical line: one σp, two possible returns</a:t>
-            </a:r>
-          </a:p>
-          <a:p>
-            <a:pPr marL="411480" indent="-411480">
-              <a:spcAft>
-                <a:spcPts val="2400"/>
-              </a:spcAft>
-              <a:buFont typeface="Arial"/>
-              <a:buChar char="•"/>
-            </a:pPr>
-            <a:r>
-              <a:rPr sz="2800">
-                <a:solidFill>
-                  <a:srgbClr val="000000"/>
-                </a:solidFill>
-                <a:latin typeface="Calibri"/>
-              </a:rPr>
-              <a:t>That is why the chart plots only the upper branch</a:t>
-            </a:r>
-          </a:p>
-        </p:txBody>
-      </p:sp>
-      <p:sp>
-        <p:nvSpPr>
-          <p:cNvPr id="5" name="TextBox 4"/>
-          <p:cNvSpPr txBox="1"/>
-          <p:nvPr/>
-        </p:nvSpPr>
-        <p:spPr>
-          <a:xfrm>
-            <a:off x="548640" y="6263640"/>
-            <a:ext cx="8229600" cy="411480"/>
-          </a:xfrm>
-          <a:prstGeom prst="rect">
-            <a:avLst/>
-          </a:prstGeom>
-          <a:noFill/>
-        </p:spPr>
-        <p:txBody>
-          <a:bodyPr wrap="square">
-            <a:spAutoFit/>
-          </a:bodyPr>
-          <a:lstStyle/>
-          <a:p>
-            <a:r>
-              <a:rPr sz="2200" b="0" i="0">
-                <a:solidFill>
-                  <a:srgbClr val="000000"/>
-                </a:solidFill>
-                <a:latin typeface="Calibri"/>
-              </a:rPr>
-              <a:t>Sheet: Sec 3A - 5-Stock Demo</a:t>
-            </a:r>
-          </a:p>
-        </p:txBody>
-      </p:sp>
-      <p:sp>
-        <p:nvSpPr>
-          <p:cNvPr id="6" name="TextBox 5"/>
-          <p:cNvSpPr txBox="1"/>
-          <p:nvPr/>
-        </p:nvSpPr>
-        <p:spPr>
-          <a:xfrm>
-            <a:off x="9326880" y="6263640"/>
-            <a:ext cx="2313432" cy="411480"/>
-          </a:xfrm>
-          <a:prstGeom prst="rect">
-            <a:avLst/>
-          </a:prstGeom>
-          <a:noFill/>
-        </p:spPr>
-        <p:txBody>
-          <a:bodyPr wrap="square">
-            <a:spAutoFit/>
-          </a:bodyPr>
-          <a:lstStyle/>
-          <a:p>
-            <a:pPr algn="r"/>
-            <a:r>
-              <a:rPr sz="2200" b="0" i="0">
-                <a:solidFill>
-                  <a:srgbClr val="000000"/>
-                </a:solidFill>
-                <a:latin typeface="Calibri"/>
-              </a:rPr>
-              <a:t>Row 210</a:t>
             </a:r>
           </a:p>
         </p:txBody>
@@ -4268,7 +3501,75 @@
         </p:nvSpPr>
         <p:spPr>
           <a:xfrm>
-            <a:off x="548640" y="320040"/>
+            <a:off x="548640" y="274320"/>
+            <a:ext cx="11091672" cy="365760"/>
+          </a:xfrm>
+          <a:prstGeom prst="rect">
+            <a:avLst/>
+          </a:prstGeom>
+          <a:noFill/>
+        </p:spPr>
+        <p:txBody>
+          <a:bodyPr wrap="square">
+            <a:spAutoFit/>
+          </a:bodyPr>
+          <a:lstStyle/>
+          <a:p>
+            <a:r>
+              <a:rPr sz="1600" b="0" i="0">
+                <a:solidFill>
+                  <a:srgbClr val="595959"/>
+                </a:solidFill>
+                <a:latin typeface="Calibri"/>
+              </a:rPr>
+              <a:t>T/F 2</a:t>
+            </a:r>
+          </a:p>
+        </p:txBody>
+      </p:sp>
+      <p:sp>
+        <p:nvSpPr>
+          <p:cNvPr id="3" name="TextBox 2"/>
+          <p:cNvSpPr txBox="1"/>
+          <p:nvPr/>
+        </p:nvSpPr>
+        <p:spPr>
+          <a:xfrm>
+            <a:off x="548640" y="594360"/>
+            <a:ext cx="11091672" cy="640080"/>
+          </a:xfrm>
+          <a:prstGeom prst="rect">
+            <a:avLst/>
+          </a:prstGeom>
+          <a:noFill/>
+        </p:spPr>
+        <p:txBody>
+          <a:bodyPr wrap="square">
+            <a:spAutoFit/>
+          </a:bodyPr>
+          <a:lstStyle/>
+          <a:p>
+            <a:r>
+              <a:rPr sz="3000" b="1" i="0">
+                <a:solidFill>
+                  <a:srgbClr val="000000"/>
+                </a:solidFill>
+                <a:latin typeface="Calibri"/>
+              </a:rPr>
+              <a:t>Short Sales: Asymmetric Payoffs and Unlimited Liability</a:t>
+            </a:r>
+          </a:p>
+        </p:txBody>
+      </p:sp>
+      <p:sp>
+        <p:nvSpPr>
+          <p:cNvPr id="4" name="TextBox 3"/>
+          <p:cNvSpPr txBox="1"/>
+          <p:nvPr/>
+        </p:nvSpPr>
+        <p:spPr>
+          <a:xfrm>
+            <a:off x="548640" y="1234440"/>
             <a:ext cx="11091672" cy="457200"/>
           </a:xfrm>
           <a:prstGeom prst="rect">
@@ -4283,27 +3584,27 @@
           <a:lstStyle/>
           <a:p>
             <a:r>
-              <a:rPr sz="2000" b="0" i="0">
+              <a:rPr sz="1800" b="0" i="1">
                 <a:solidFill>
                   <a:srgbClr val="595959"/>
                 </a:solidFill>
                 <a:latin typeface="Calibri"/>
               </a:rPr>
-              <a:t>T/F 2</a:t>
-            </a:r>
-          </a:p>
-        </p:txBody>
-      </p:sp>
-      <p:sp>
-        <p:nvSpPr>
-          <p:cNvPr id="3" name="TextBox 2"/>
+              <a:t>A short position reverses the payoff of a long position, including the bound on losses.</a:t>
+            </a:r>
+          </a:p>
+        </p:txBody>
+      </p:sp>
+      <p:sp>
+        <p:nvSpPr>
+          <p:cNvPr id="5" name="TextBox 4"/>
           <p:cNvSpPr txBox="1"/>
           <p:nvPr/>
         </p:nvSpPr>
         <p:spPr>
           <a:xfrm>
-            <a:off x="548640" y="731520"/>
-            <a:ext cx="11091672" cy="777240"/>
+            <a:off x="548640" y="1920240"/>
+            <a:ext cx="7223760" cy="4206240"/>
           </a:xfrm>
           <a:prstGeom prst="rect">
             <a:avLst/>
@@ -4316,98 +3617,201 @@
           </a:bodyPr>
           <a:lstStyle/>
           <a:p>
-            <a:r>
-              <a:rPr sz="3600" b="1" i="0">
+            <a:pPr marL="274320" indent="-274320">
+              <a:spcAft>
+                <a:spcPts val="1400"/>
+              </a:spcAft>
+              <a:buFont typeface="Arial"/>
+              <a:buChar char="•"/>
+            </a:pPr>
+            <a:r>
+              <a:rPr sz="1700">
                 <a:solidFill>
                   <a:srgbClr val="000000"/>
                 </a:solidFill>
                 <a:latin typeface="Calibri"/>
               </a:rPr>
-              <a:t>Short losses have no ceiling</a:t>
-            </a:r>
-          </a:p>
-        </p:txBody>
-      </p:sp>
-      <p:sp>
-        <p:nvSpPr>
-          <p:cNvPr id="4" name="TextBox 3"/>
-          <p:cNvSpPr txBox="1"/>
+              <a:t>Mechanics: the investor borrows shares from a broker, sells them at P₀, and must later repurchase them at P₁ to cover the position, paying any dividends to the lender in the interim.</a:t>
+            </a:r>
+          </a:p>
+          <a:p>
+            <a:pPr marL="274320" indent="-274320">
+              <a:spcAft>
+                <a:spcPts val="1400"/>
+              </a:spcAft>
+              <a:buFont typeface="Arial"/>
+              <a:buChar char="•"/>
+            </a:pPr>
+            <a:r>
+              <a:rPr sz="1700">
+                <a:solidFill>
+                  <a:srgbClr val="000000"/>
+                </a:solidFill>
+                <a:latin typeface="Calibri"/>
+              </a:rPr>
+              <a:t>A long position has limited liability, because P₁ ≥ 0 caps the loss at the initial investment. A short position's maximum gain is P₀, but its loss, P₁ − P₀, has no upper bound because P₁ has none.</a:t>
+            </a:r>
+          </a:p>
+          <a:p>
+            <a:pPr marL="274320" indent="-274320">
+              <a:spcAft>
+                <a:spcPts val="1400"/>
+              </a:spcAft>
+              <a:buFont typeface="Arial"/>
+              <a:buChar char="•"/>
+            </a:pPr>
+            <a:r>
+              <a:rPr sz="1700">
+                <a:solidFill>
+                  <a:srgbClr val="000000"/>
+                </a:solidFill>
+                <a:latin typeface="Calibri"/>
+              </a:rPr>
+              <a:t>Short sellers must post margin (the sale proceeds plus initial margin). A rising price erodes equity in the account and can trigger a margin call or forced covering (a short squeeze).</a:t>
+            </a:r>
+          </a:p>
+        </p:txBody>
+      </p:sp>
+      <p:sp>
+        <p:nvSpPr>
+          <p:cNvPr id="6" name="Rectangle 5"/>
+          <p:cNvSpPr/>
           <p:nvPr/>
         </p:nvSpPr>
         <p:spPr>
           <a:xfrm>
-            <a:off x="548640" y="1828800"/>
-            <a:ext cx="11091672" cy="3931920"/>
+            <a:off x="8092440" y="1920240"/>
+            <a:ext cx="3547872" cy="2514600"/>
           </a:xfrm>
           <a:prstGeom prst="rect">
             <a:avLst/>
           </a:prstGeom>
-          <a:noFill/>
+          <a:solidFill>
+            <a:srgbClr val="F2F2F2"/>
+          </a:solidFill>
+          <a:ln>
+            <a:noFill/>
+          </a:ln>
+          <a:effectLst/>
         </p:spPr>
-        <p:txBody>
-          <a:bodyPr wrap="square">
-            <a:spAutoFit/>
-          </a:bodyPr>
-          <a:lstStyle/>
-          <a:p>
-            <a:pPr marL="411480" indent="-411480">
+        <p:style>
+          <a:lnRef idx="1">
+            <a:schemeClr val="accent1"/>
+          </a:lnRef>
+          <a:fillRef idx="3">
+            <a:schemeClr val="accent1"/>
+          </a:fillRef>
+          <a:effectRef idx="2">
+            <a:schemeClr val="accent1"/>
+          </a:effectRef>
+          <a:fontRef idx="minor">
+            <a:schemeClr val="lt1"/>
+          </a:fontRef>
+        </p:style>
+        <p:txBody>
+          <a:bodyPr rtlCol="0" anchor="t" wrap="square" lIns="182880" rIns="182880" tIns="182880"/>
+          <a:lstStyle/>
+          <a:p>
+            <a:pPr algn="l">
               <a:spcAft>
-                <a:spcPts val="2400"/>
+                <a:spcPts val="1000"/>
               </a:spcAft>
-              <a:buFont typeface="Arial"/>
-              <a:buChar char="•"/>
             </a:pPr>
             <a:r>
-              <a:rPr sz="2800">
+              <a:rPr sz="1600" b="1">
                 <a:solidFill>
                   <a:srgbClr val="000000"/>
                 </a:solidFill>
                 <a:latin typeface="Calibri"/>
               </a:rPr>
-              <a:t>Long: the price can only fall to $0, so you lose at most what you paid</a:t>
-            </a:r>
-          </a:p>
-          <a:p>
-            <a:pPr marL="411480" indent="-411480">
+              <a:t>Formal statement</a:t>
+            </a:r>
+          </a:p>
+          <a:p>
+            <a:pPr>
               <a:spcAft>
-                <a:spcPts val="2400"/>
+                <a:spcPts val="600"/>
               </a:spcAft>
-              <a:buFont typeface="Arial"/>
-              <a:buChar char="•"/>
             </a:pPr>
             <a:r>
-              <a:rPr sz="2800">
+              <a:rPr sz="1500">
                 <a:solidFill>
                   <a:srgbClr val="000000"/>
                 </a:solidFill>
-                <a:latin typeface="Calibri"/>
+                <a:latin typeface="Cambria"/>
               </a:rPr>
-              <a:t>Short: you must buy the shares back later, and prices have no upper limit</a:t>
-            </a:r>
-          </a:p>
-          <a:p>
-            <a:pPr marL="411480" indent="-411480">
+              <a:t>Long:   Π = P₁ − P₀   ⇒  Π ≥ −P₀</a:t>
+            </a:r>
+          </a:p>
+          <a:p>
+            <a:pPr>
               <a:spcAft>
-                <a:spcPts val="2400"/>
+                <a:spcPts val="600"/>
               </a:spcAft>
-              <a:buFont typeface="Arial"/>
-              <a:buChar char="•"/>
             </a:pPr>
             <a:r>
-              <a:rPr sz="2800">
+              <a:rPr sz="1500">
                 <a:solidFill>
                   <a:srgbClr val="000000"/>
                 </a:solidFill>
-                <a:latin typeface="Calibri"/>
+                <a:latin typeface="Cambria"/>
               </a:rPr>
-              <a:t>The higher the price climbs, the bigger the loss</a:t>
-            </a:r>
-          </a:p>
-        </p:txBody>
-      </p:sp>
-      <p:sp>
-        <p:nvSpPr>
-          <p:cNvPr id="5" name="TextBox 4"/>
+              <a:t>Short:  Π = P₀ − P₁ − D  ⇒  Π ≤ P₀</a:t>
+            </a:r>
+          </a:p>
+          <a:p>
+            <a:pPr>
+              <a:spcAft>
+                <a:spcPts val="600"/>
+              </a:spcAft>
+            </a:pPr>
+            <a:r>
+              <a:rPr sz="1500">
+                <a:solidFill>
+                  <a:srgbClr val="000000"/>
+                </a:solidFill>
+                <a:latin typeface="Cambria"/>
+              </a:rPr>
+              <a:t>P₁ ∈ [0, ∞)</a:t>
+            </a:r>
+          </a:p>
+          <a:p>
+            <a:pPr>
+              <a:spcAft>
+                <a:spcPts val="600"/>
+              </a:spcAft>
+            </a:pPr>
+            <a:r>
+              <a:rPr sz="1500">
+                <a:solidFill>
+                  <a:srgbClr val="000000"/>
+                </a:solidFill>
+                <a:latin typeface="Cambria"/>
+              </a:rPr>
+              <a:t>⇒ long loss bounded,</a:t>
+            </a:r>
+          </a:p>
+          <a:p>
+            <a:pPr>
+              <a:spcAft>
+                <a:spcPts val="600"/>
+              </a:spcAft>
+            </a:pPr>
+            <a:r>
+              <a:rPr sz="1500">
+                <a:solidFill>
+                  <a:srgbClr val="000000"/>
+                </a:solidFill>
+                <a:latin typeface="Cambria"/>
+              </a:rPr>
+              <a:t>    short loss unbounded</a:t>
+            </a:r>
+          </a:p>
+        </p:txBody>
+      </p:sp>
+      <p:sp>
+        <p:nvSpPr>
+          <p:cNvPr id="7" name="TextBox 6"/>
           <p:cNvSpPr txBox="1"/>
           <p:nvPr/>
         </p:nvSpPr>
@@ -4428,7 +3832,7 @@
           <a:lstStyle/>
           <a:p>
             <a:r>
-              <a:rPr sz="2200" b="0" i="0">
+              <a:rPr sz="1400" b="0" i="0">
                 <a:solidFill>
                   <a:srgbClr val="000000"/>
                 </a:solidFill>
@@ -4441,7 +3845,7 @@
       </p:sp>
       <p:sp>
         <p:nvSpPr>
-          <p:cNvPr id="6" name="TextBox 5"/>
+          <p:cNvPr id="8" name="TextBox 7"/>
           <p:cNvSpPr txBox="1"/>
           <p:nvPr/>
         </p:nvSpPr>
@@ -4463,7 +3867,7 @@
           <a:p>
             <a:pPr algn="r"/>
             <a:r>
-              <a:rPr sz="2200" b="0" i="0">
+              <a:rPr sz="1400" b="0" i="0">
                 <a:solidFill>
                   <a:srgbClr val="000000"/>
                 </a:solidFill>
@@ -4500,7 +3904,75 @@
         </p:nvSpPr>
         <p:spPr>
           <a:xfrm>
-            <a:off x="548640" y="320040"/>
+            <a:off x="548640" y="274320"/>
+            <a:ext cx="11091672" cy="365760"/>
+          </a:xfrm>
+          <a:prstGeom prst="rect">
+            <a:avLst/>
+          </a:prstGeom>
+          <a:noFill/>
+        </p:spPr>
+        <p:txBody>
+          <a:bodyPr wrap="square">
+            <a:spAutoFit/>
+          </a:bodyPr>
+          <a:lstStyle/>
+          <a:p>
+            <a:r>
+              <a:rPr sz="1600" b="0" i="0">
+                <a:solidFill>
+                  <a:srgbClr val="595959"/>
+                </a:solidFill>
+                <a:latin typeface="Calibri"/>
+              </a:rPr>
+              <a:t>T/F 3</a:t>
+            </a:r>
+          </a:p>
+        </p:txBody>
+      </p:sp>
+      <p:sp>
+        <p:nvSpPr>
+          <p:cNvPr id="3" name="TextBox 2"/>
+          <p:cNvSpPr txBox="1"/>
+          <p:nvPr/>
+        </p:nvSpPr>
+        <p:spPr>
+          <a:xfrm>
+            <a:off x="548640" y="594360"/>
+            <a:ext cx="11091672" cy="640080"/>
+          </a:xfrm>
+          <a:prstGeom prst="rect">
+            <a:avLst/>
+          </a:prstGeom>
+          <a:noFill/>
+        </p:spPr>
+        <p:txBody>
+          <a:bodyPr wrap="square">
+            <a:spAutoFit/>
+          </a:bodyPr>
+          <a:lstStyle/>
+          <a:p>
+            <a:r>
+              <a:rPr sz="3000" b="1" i="0">
+                <a:solidFill>
+                  <a:srgbClr val="000000"/>
+                </a:solidFill>
+                <a:latin typeface="Calibri"/>
+              </a:rPr>
+              <a:t>Estimation Risk: Ex Ante Optimality vs. Ex Post Performance</a:t>
+            </a:r>
+          </a:p>
+        </p:txBody>
+      </p:sp>
+      <p:sp>
+        <p:nvSpPr>
+          <p:cNvPr id="4" name="TextBox 3"/>
+          <p:cNvSpPr txBox="1"/>
+          <p:nvPr/>
+        </p:nvSpPr>
+        <p:spPr>
+          <a:xfrm>
+            <a:off x="548640" y="1234440"/>
             <a:ext cx="11091672" cy="457200"/>
           </a:xfrm>
           <a:prstGeom prst="rect">
@@ -4515,27 +3987,27 @@
           <a:lstStyle/>
           <a:p>
             <a:r>
-              <a:rPr sz="2000" b="0" i="0">
+              <a:rPr sz="1800" b="0" i="1">
                 <a:solidFill>
                   <a:srgbClr val="595959"/>
                 </a:solidFill>
                 <a:latin typeface="Calibri"/>
               </a:rPr>
-              <a:t>T/F 3</a:t>
-            </a:r>
-          </a:p>
-        </p:txBody>
-      </p:sp>
-      <p:sp>
-        <p:nvSpPr>
-          <p:cNvPr id="3" name="TextBox 2"/>
+              <a:t>Mean-variance weights are optimal only with respect to the inputs used to compute them.</a:t>
+            </a:r>
+          </a:p>
+        </p:txBody>
+      </p:sp>
+      <p:sp>
+        <p:nvSpPr>
+          <p:cNvPr id="5" name="TextBox 4"/>
           <p:cNvSpPr txBox="1"/>
           <p:nvPr/>
         </p:nvSpPr>
         <p:spPr>
           <a:xfrm>
-            <a:off x="548640" y="731520"/>
-            <a:ext cx="11091672" cy="777240"/>
+            <a:off x="548640" y="1920240"/>
+            <a:ext cx="7223760" cy="4206240"/>
           </a:xfrm>
           <a:prstGeom prst="rect">
             <a:avLst/>
@@ -4548,98 +4020,201 @@
           </a:bodyPr>
           <a:lstStyle/>
           <a:p>
-            <a:r>
-              <a:rPr sz="3600" b="1" i="0">
+            <a:pPr marL="274320" indent="-274320">
+              <a:spcAft>
+                <a:spcPts val="1400"/>
+              </a:spcAft>
+              <a:buFont typeface="Arial"/>
+              <a:buChar char="•"/>
+            </a:pPr>
+            <a:r>
+              <a:rPr sz="1700">
                 <a:solidFill>
                   <a:srgbClr val="000000"/>
                 </a:solidFill>
                 <a:latin typeface="Calibri"/>
               </a:rPr>
-              <a:t>Past data is not the future</a:t>
-            </a:r>
-          </a:p>
-        </p:txBody>
-      </p:sp>
-      <p:sp>
-        <p:nvSpPr>
-          <p:cNvPr id="4" name="TextBox 3"/>
-          <p:cNvSpPr txBox="1"/>
+              <a:t>The Markowitz model assumes the true expected returns μ and covariance matrix Σ are known. In practice, Solver uses sample estimates of μ and Σ from 60 monthly observations and treats them as exact.</a:t>
+            </a:r>
+          </a:p>
+          <a:p>
+            <a:pPr marL="274320" indent="-274320">
+              <a:spcAft>
+                <a:spcPts val="1400"/>
+              </a:spcAft>
+              <a:buFont typeface="Arial"/>
+              <a:buChar char="•"/>
+            </a:pPr>
+            <a:r>
+              <a:rPr sz="1700">
+                <a:solidFill>
+                  <a:srgbClr val="000000"/>
+                </a:solidFill>
+                <a:latin typeface="Calibri"/>
+              </a:rPr>
+              <a:t>Expected returns are estimated with low precision: the standard error of a sample mean is s/√T. In addition, return distributions are not stationary, so means, volatilities, and correlations shift over time.</a:t>
+            </a:r>
+          </a:p>
+          <a:p>
+            <a:pPr marL="274320" indent="-274320">
+              <a:spcAft>
+                <a:spcPts val="1400"/>
+              </a:spcAft>
+              <a:buFont typeface="Arial"/>
+              <a:buChar char="•"/>
+            </a:pPr>
+            <a:r>
+              <a:rPr sz="1700">
+                <a:solidFill>
+                  <a:srgbClr val="000000"/>
+                </a:solidFill>
+                <a:latin typeface="Calibri"/>
+              </a:rPr>
+              <a:t>The optimizer magnifies estimation error by overweighting assets whose means are overestimated or whose risks are underestimated. This produces extreme or corner weights (95% AGG in Step 8; ±100%+ positions in Step 10).</a:t>
+            </a:r>
+          </a:p>
+        </p:txBody>
+      </p:sp>
+      <p:sp>
+        <p:nvSpPr>
+          <p:cNvPr id="6" name="Rectangle 5"/>
+          <p:cNvSpPr/>
           <p:nvPr/>
         </p:nvSpPr>
         <p:spPr>
           <a:xfrm>
-            <a:off x="548640" y="1828800"/>
-            <a:ext cx="11091672" cy="3931920"/>
+            <a:off x="8092440" y="1920240"/>
+            <a:ext cx="3547872" cy="2514600"/>
           </a:xfrm>
           <a:prstGeom prst="rect">
             <a:avLst/>
           </a:prstGeom>
-          <a:noFill/>
+          <a:solidFill>
+            <a:srgbClr val="F2F2F2"/>
+          </a:solidFill>
+          <a:ln>
+            <a:noFill/>
+          </a:ln>
+          <a:effectLst/>
         </p:spPr>
-        <p:txBody>
-          <a:bodyPr wrap="square">
-            <a:spAutoFit/>
-          </a:bodyPr>
-          <a:lstStyle/>
-          <a:p>
-            <a:pPr marL="411480" indent="-411480">
+        <p:style>
+          <a:lnRef idx="1">
+            <a:schemeClr val="accent1"/>
+          </a:lnRef>
+          <a:fillRef idx="3">
+            <a:schemeClr val="accent1"/>
+          </a:fillRef>
+          <a:effectRef idx="2">
+            <a:schemeClr val="accent1"/>
+          </a:effectRef>
+          <a:fontRef idx="minor">
+            <a:schemeClr val="lt1"/>
+          </a:fontRef>
+        </p:style>
+        <p:txBody>
+          <a:bodyPr rtlCol="0" anchor="t" wrap="square" lIns="182880" rIns="182880" tIns="182880"/>
+          <a:lstStyle/>
+          <a:p>
+            <a:pPr algn="l">
               <a:spcAft>
-                <a:spcPts val="2400"/>
+                <a:spcPts val="1000"/>
               </a:spcAft>
-              <a:buFont typeface="Arial"/>
-              <a:buChar char="•"/>
             </a:pPr>
             <a:r>
-              <a:rPr sz="2800">
+              <a:rPr sz="1600" b="1">
                 <a:solidFill>
                   <a:srgbClr val="000000"/>
                 </a:solidFill>
                 <a:latin typeface="Calibri"/>
               </a:rPr>
-              <a:t>Solver's weights are best only for the 60 months of data it was given</a:t>
-            </a:r>
-          </a:p>
-          <a:p>
-            <a:pPr marL="411480" indent="-411480">
+              <a:t>Formal statement</a:t>
+            </a:r>
+          </a:p>
+          <a:p>
+            <a:pPr>
               <a:spcAft>
-                <a:spcPts val="2400"/>
+                <a:spcPts val="600"/>
               </a:spcAft>
-              <a:buFont typeface="Arial"/>
-              <a:buChar char="•"/>
             </a:pPr>
             <a:r>
-              <a:rPr sz="2800">
+              <a:rPr sz="1500">
                 <a:solidFill>
                   <a:srgbClr val="000000"/>
                 </a:solidFill>
-                <a:latin typeface="Calibri"/>
+                <a:latin typeface="Cambria"/>
               </a:rPr>
-              <a:t>Means, volatilities and correlations change over time</a:t>
-            </a:r>
-          </a:p>
-          <a:p>
-            <a:pPr marL="411480" indent="-411480">
+              <a:t>w* = argmax f(μ̂, Σ̂), not f(μ, Σ)</a:t>
+            </a:r>
+          </a:p>
+          <a:p>
+            <a:pPr>
               <a:spcAft>
-                <a:spcPts val="2400"/>
+                <a:spcPts val="600"/>
               </a:spcAft>
-              <a:buFont typeface="Arial"/>
-              <a:buChar char="•"/>
             </a:pPr>
             <a:r>
-              <a:rPr sz="2800">
+              <a:rPr sz="1500">
                 <a:solidFill>
                   <a:srgbClr val="000000"/>
                 </a:solidFill>
-                <a:latin typeface="Calibri"/>
+                <a:latin typeface="Cambria"/>
               </a:rPr>
-              <a:t>Small errors in the inputs can swing the weights a lot</a:t>
-            </a:r>
-          </a:p>
-        </p:txBody>
-      </p:sp>
-      <p:sp>
-        <p:nvSpPr>
-          <p:cNvPr id="5" name="TextBox 4"/>
+              <a:t>SE(r̄) = s / √T</a:t>
+            </a:r>
+          </a:p>
+          <a:p>
+            <a:pPr>
+              <a:spcAft>
+                <a:spcPts val="600"/>
+              </a:spcAft>
+            </a:pPr>
+            <a:r>
+              <a:rPr sz="1500">
+                <a:solidFill>
+                  <a:srgbClr val="000000"/>
+                </a:solidFill>
+                <a:latin typeface="Cambria"/>
+              </a:rPr>
+              <a:t>AAPL: s = 7.11%/mo, T = 60</a:t>
+            </a:r>
+          </a:p>
+          <a:p>
+            <a:pPr>
+              <a:spcAft>
+                <a:spcPts val="600"/>
+              </a:spcAft>
+            </a:pPr>
+            <a:r>
+              <a:rPr sz="1500">
+                <a:solidFill>
+                  <a:srgbClr val="000000"/>
+                </a:solidFill>
+                <a:latin typeface="Cambria"/>
+              </a:rPr>
+              <a:t>SE ≈ 0.92%/mo ≈ 11.0%/yr</a:t>
+            </a:r>
+          </a:p>
+          <a:p>
+            <a:pPr>
+              <a:spcAft>
+                <a:spcPts val="600"/>
+              </a:spcAft>
+            </a:pPr>
+            <a:r>
+              <a:rPr sz="1500">
+                <a:solidFill>
+                  <a:srgbClr val="000000"/>
+                </a:solidFill>
+                <a:latin typeface="Cambria"/>
+              </a:rPr>
+              <a:t>vs. sample mean ≈ 17.1%/yr</a:t>
+            </a:r>
+          </a:p>
+        </p:txBody>
+      </p:sp>
+      <p:sp>
+        <p:nvSpPr>
+          <p:cNvPr id="7" name="TextBox 6"/>
           <p:cNvSpPr txBox="1"/>
           <p:nvPr/>
         </p:nvSpPr>
@@ -4660,7 +4235,7 @@
           <a:lstStyle/>
           <a:p>
             <a:r>
-              <a:rPr sz="2200" b="0" i="0">
+              <a:rPr sz="1400" b="0" i="0">
                 <a:solidFill>
                   <a:srgbClr val="000000"/>
                 </a:solidFill>
@@ -4673,7 +4248,7 @@
       </p:sp>
       <p:sp>
         <p:nvSpPr>
-          <p:cNvPr id="6" name="TextBox 5"/>
+          <p:cNvPr id="8" name="TextBox 7"/>
           <p:cNvSpPr txBox="1"/>
           <p:nvPr/>
         </p:nvSpPr>
@@ -4695,1405 +4270,13 @@
           <a:p>
             <a:pPr algn="r"/>
             <a:r>
-              <a:rPr sz="2200" b="0" i="0">
+              <a:rPr sz="1400" b="0" i="0">
                 <a:solidFill>
                   <a:srgbClr val="000000"/>
                 </a:solidFill>
                 <a:latin typeface="Calibri"/>
               </a:rPr>
               <a:t>Row 130</a:t>
-            </a:r>
-          </a:p>
-        </p:txBody>
-      </p:sp>
-    </p:spTree>
-  </p:cSld>
-  <p:clrMapOvr>
-    <a:masterClrMapping/>
-  </p:clrMapOvr>
-</p:sld>
-</file>
-
-<file path=ppt/slides/slide4.xml><?xml version="1.0" encoding="utf-8"?>
-<p:sld xmlns:a="http://schemas.openxmlformats.org/drawingml/2006/main" xmlns:p="http://schemas.openxmlformats.org/presentationml/2006/main" xmlns:r="http://schemas.openxmlformats.org/officeDocument/2006/relationships">
-  <p:cSld>
-    <p:spTree>
-      <p:nvGrpSpPr>
-        <p:cNvPr id="1" name=""/>
-        <p:cNvGrpSpPr/>
-        <p:nvPr/>
-      </p:nvGrpSpPr>
-      <p:grpSpPr/>
-      <p:sp>
-        <p:nvSpPr>
-          <p:cNvPr id="2" name="TextBox 1"/>
-          <p:cNvSpPr txBox="1"/>
-          <p:nvPr/>
-        </p:nvSpPr>
-        <p:spPr>
-          <a:xfrm>
-            <a:off x="548640" y="320040"/>
-            <a:ext cx="11091672" cy="457200"/>
-          </a:xfrm>
-          <a:prstGeom prst="rect">
-            <a:avLst/>
-          </a:prstGeom>
-          <a:noFill/>
-        </p:spPr>
-        <p:txBody>
-          <a:bodyPr wrap="square">
-            <a:spAutoFit/>
-          </a:bodyPr>
-          <a:lstStyle/>
-          <a:p>
-            <a:r>
-              <a:rPr sz="2000" b="0" i="0">
-                <a:solidFill>
-                  <a:srgbClr val="595959"/>
-                </a:solidFill>
-                <a:latin typeface="Calibri"/>
-              </a:rPr>
-              <a:t>T/F 4</a:t>
-            </a:r>
-          </a:p>
-        </p:txBody>
-      </p:sp>
-      <p:sp>
-        <p:nvSpPr>
-          <p:cNvPr id="3" name="TextBox 2"/>
-          <p:cNvSpPr txBox="1"/>
-          <p:nvPr/>
-        </p:nvSpPr>
-        <p:spPr>
-          <a:xfrm>
-            <a:off x="548640" y="731520"/>
-            <a:ext cx="11091672" cy="777240"/>
-          </a:xfrm>
-          <a:prstGeom prst="rect">
-            <a:avLst/>
-          </a:prstGeom>
-          <a:noFill/>
-        </p:spPr>
-        <p:txBody>
-          <a:bodyPr wrap="square">
-            <a:spAutoFit/>
-          </a:bodyPr>
-          <a:lstStyle/>
-          <a:p>
-            <a:r>
-              <a:rPr sz="3600" b="1" i="0">
-                <a:solidFill>
-                  <a:srgbClr val="000000"/>
-                </a:solidFill>
-                <a:latin typeface="Calibri"/>
-              </a:rPr>
-              <a:t>Why the utility portfolio is efficient</a:t>
-            </a:r>
-          </a:p>
-        </p:txBody>
-      </p:sp>
-      <p:sp>
-        <p:nvSpPr>
-          <p:cNvPr id="4" name="TextBox 3"/>
-          <p:cNvSpPr txBox="1"/>
-          <p:nvPr/>
-        </p:nvSpPr>
-        <p:spPr>
-          <a:xfrm>
-            <a:off x="548640" y="1828800"/>
-            <a:ext cx="11091672" cy="3931920"/>
-          </a:xfrm>
-          <a:prstGeom prst="rect">
-            <a:avLst/>
-          </a:prstGeom>
-          <a:noFill/>
-        </p:spPr>
-        <p:txBody>
-          <a:bodyPr wrap="square">
-            <a:spAutoFit/>
-          </a:bodyPr>
-          <a:lstStyle/>
-          <a:p>
-            <a:pPr marL="411480" indent="-411480">
-              <a:spcAft>
-                <a:spcPts val="2400"/>
-              </a:spcAft>
-              <a:buFont typeface="Arial"/>
-              <a:buChar char="•"/>
-            </a:pPr>
-            <a:r>
-              <a:rPr sz="2800">
-                <a:solidFill>
-                  <a:srgbClr val="000000"/>
-                </a:solidFill>
-                <a:latin typeface="Calibri"/>
-              </a:rPr>
-              <a:t>Utility rewards return and penalizes variance</a:t>
-            </a:r>
-          </a:p>
-          <a:p>
-            <a:pPr marL="411480" indent="-411480">
-              <a:spcAft>
-                <a:spcPts val="2400"/>
-              </a:spcAft>
-              <a:buFont typeface="Arial"/>
-              <a:buChar char="•"/>
-            </a:pPr>
-            <a:r>
-              <a:rPr sz="2800">
-                <a:solidFill>
-                  <a:srgbClr val="000000"/>
-                </a:solidFill>
-                <a:latin typeface="Calibri"/>
-              </a:rPr>
-              <a:t>A lower-risk portfolio with the same return would have higher utility</a:t>
-            </a:r>
-          </a:p>
-          <a:p>
-            <a:pPr marL="411480" indent="-411480">
-              <a:spcAft>
-                <a:spcPts val="2400"/>
-              </a:spcAft>
-              <a:buFont typeface="Arial"/>
-              <a:buChar char="•"/>
-            </a:pPr>
-            <a:r>
-              <a:rPr sz="2800">
-                <a:solidFill>
-                  <a:srgbClr val="000000"/>
-                </a:solidFill>
-                <a:latin typeface="Calibri"/>
-              </a:rPr>
-              <a:t>Step 11 tests this: compare σp in B105 and B120</a:t>
-            </a:r>
-          </a:p>
-        </p:txBody>
-      </p:sp>
-      <p:sp>
-        <p:nvSpPr>
-          <p:cNvPr id="5" name="TextBox 4"/>
-          <p:cNvSpPr txBox="1"/>
-          <p:nvPr/>
-        </p:nvSpPr>
-        <p:spPr>
-          <a:xfrm>
-            <a:off x="548640" y="6263640"/>
-            <a:ext cx="8229600" cy="411480"/>
-          </a:xfrm>
-          <a:prstGeom prst="rect">
-            <a:avLst/>
-          </a:prstGeom>
-          <a:noFill/>
-        </p:spPr>
-        <p:txBody>
-          <a:bodyPr wrap="square">
-            <a:spAutoFit/>
-          </a:bodyPr>
-          <a:lstStyle/>
-          <a:p>
-            <a:r>
-              <a:rPr sz="2200" b="0" i="0">
-                <a:solidFill>
-                  <a:srgbClr val="000000"/>
-                </a:solidFill>
-                <a:latin typeface="Calibri"/>
-              </a:rPr>
-              <a:t>Sheet: Sec 3A - 5-Stock Demo</a:t>
-            </a:r>
-          </a:p>
-        </p:txBody>
-      </p:sp>
-      <p:sp>
-        <p:nvSpPr>
-          <p:cNvPr id="6" name="TextBox 5"/>
-          <p:cNvSpPr txBox="1"/>
-          <p:nvPr/>
-        </p:nvSpPr>
-        <p:spPr>
-          <a:xfrm>
-            <a:off x="9326880" y="6263640"/>
-            <a:ext cx="2313432" cy="411480"/>
-          </a:xfrm>
-          <a:prstGeom prst="rect">
-            <a:avLst/>
-          </a:prstGeom>
-          <a:noFill/>
-        </p:spPr>
-        <p:txBody>
-          <a:bodyPr wrap="square">
-            <a:spAutoFit/>
-          </a:bodyPr>
-          <a:lstStyle/>
-          <a:p>
-            <a:pPr algn="r"/>
-            <a:r>
-              <a:rPr sz="2200" b="0" i="0">
-                <a:solidFill>
-                  <a:srgbClr val="000000"/>
-                </a:solidFill>
-                <a:latin typeface="Calibri"/>
-              </a:rPr>
-              <a:t>Row 133</a:t>
-            </a:r>
-          </a:p>
-        </p:txBody>
-      </p:sp>
-    </p:spTree>
-  </p:cSld>
-  <p:clrMapOvr>
-    <a:masterClrMapping/>
-  </p:clrMapOvr>
-</p:sld>
-</file>
-
-<file path=ppt/slides/slide5.xml><?xml version="1.0" encoding="utf-8"?>
-<p:sld xmlns:a="http://schemas.openxmlformats.org/drawingml/2006/main" xmlns:p="http://schemas.openxmlformats.org/presentationml/2006/main" xmlns:r="http://schemas.openxmlformats.org/officeDocument/2006/relationships">
-  <p:cSld>
-    <p:spTree>
-      <p:nvGrpSpPr>
-        <p:cNvPr id="1" name=""/>
-        <p:cNvGrpSpPr/>
-        <p:nvPr/>
-      </p:nvGrpSpPr>
-      <p:grpSpPr/>
-      <p:sp>
-        <p:nvSpPr>
-          <p:cNvPr id="2" name="TextBox 1"/>
-          <p:cNvSpPr txBox="1"/>
-          <p:nvPr/>
-        </p:nvSpPr>
-        <p:spPr>
-          <a:xfrm>
-            <a:off x="548640" y="320040"/>
-            <a:ext cx="11091672" cy="457200"/>
-          </a:xfrm>
-          <a:prstGeom prst="rect">
-            <a:avLst/>
-          </a:prstGeom>
-          <a:noFill/>
-        </p:spPr>
-        <p:txBody>
-          <a:bodyPr wrap="square">
-            <a:spAutoFit/>
-          </a:bodyPr>
-          <a:lstStyle/>
-          <a:p>
-            <a:r>
-              <a:rPr sz="2000" b="0" i="0">
-                <a:solidFill>
-                  <a:srgbClr val="595959"/>
-                </a:solidFill>
-                <a:latin typeface="Calibri"/>
-              </a:rPr>
-              <a:t>MCQ 5</a:t>
-            </a:r>
-          </a:p>
-        </p:txBody>
-      </p:sp>
-      <p:sp>
-        <p:nvSpPr>
-          <p:cNvPr id="3" name="TextBox 2"/>
-          <p:cNvSpPr txBox="1"/>
-          <p:nvPr/>
-        </p:nvSpPr>
-        <p:spPr>
-          <a:xfrm>
-            <a:off x="548640" y="731520"/>
-            <a:ext cx="11091672" cy="777240"/>
-          </a:xfrm>
-          <a:prstGeom prst="rect">
-            <a:avLst/>
-          </a:prstGeom>
-          <a:noFill/>
-        </p:spPr>
-        <p:txBody>
-          <a:bodyPr wrap="square">
-            <a:spAutoFit/>
-          </a:bodyPr>
-          <a:lstStyle/>
-          <a:p>
-            <a:r>
-              <a:rPr sz="3600" b="1" i="0">
-                <a:solidFill>
-                  <a:srgbClr val="000000"/>
-                </a:solidFill>
-                <a:latin typeface="Calibri"/>
-              </a:rPr>
-              <a:t>What equal weighting ignores</a:t>
-            </a:r>
-          </a:p>
-        </p:txBody>
-      </p:sp>
-      <p:sp>
-        <p:nvSpPr>
-          <p:cNvPr id="4" name="TextBox 3"/>
-          <p:cNvSpPr txBox="1"/>
-          <p:nvPr/>
-        </p:nvSpPr>
-        <p:spPr>
-          <a:xfrm>
-            <a:off x="548640" y="1828800"/>
-            <a:ext cx="11091672" cy="3931920"/>
-          </a:xfrm>
-          <a:prstGeom prst="rect">
-            <a:avLst/>
-          </a:prstGeom>
-          <a:noFill/>
-        </p:spPr>
-        <p:txBody>
-          <a:bodyPr wrap="square">
-            <a:spAutoFit/>
-          </a:bodyPr>
-          <a:lstStyle/>
-          <a:p>
-            <a:pPr marL="411480" indent="-411480">
-              <a:spcAft>
-                <a:spcPts val="2400"/>
-              </a:spcAft>
-              <a:buFont typeface="Arial"/>
-              <a:buChar char="•"/>
-            </a:pPr>
-            <a:r>
-              <a:rPr sz="2800">
-                <a:solidFill>
-                  <a:srgbClr val="000000"/>
-                </a:solidFill>
-                <a:latin typeface="Calibri"/>
-              </a:rPr>
-              <a:t>20% each is chosen without looking at the data</a:t>
-            </a:r>
-          </a:p>
-          <a:p>
-            <a:pPr marL="411480" indent="-411480">
-              <a:spcAft>
-                <a:spcPts val="2400"/>
-              </a:spcAft>
-              <a:buFont typeface="Arial"/>
-              <a:buChar char="•"/>
-            </a:pPr>
-            <a:r>
-              <a:rPr sz="2800">
-                <a:solidFill>
-                  <a:srgbClr val="000000"/>
-                </a:solidFill>
-                <a:latin typeface="Calibri"/>
-              </a:rPr>
-              <a:t>The optimizer uses Σ: which assets move together and which diversify</a:t>
-            </a:r>
-          </a:p>
-          <a:p>
-            <a:pPr marL="411480" indent="-411480">
-              <a:spcAft>
-                <a:spcPts val="2400"/>
-              </a:spcAft>
-              <a:buFont typeface="Arial"/>
-              <a:buChar char="•"/>
-            </a:pPr>
-            <a:r>
-              <a:rPr sz="2800">
-                <a:solidFill>
-                  <a:srgbClr val="000000"/>
-                </a:solidFill>
-                <a:latin typeface="Calibri"/>
-              </a:rPr>
-              <a:t>Using that information cuts risk at the same return (Step 7)</a:t>
-            </a:r>
-          </a:p>
-        </p:txBody>
-      </p:sp>
-      <p:sp>
-        <p:nvSpPr>
-          <p:cNvPr id="5" name="TextBox 4"/>
-          <p:cNvSpPr txBox="1"/>
-          <p:nvPr/>
-        </p:nvSpPr>
-        <p:spPr>
-          <a:xfrm>
-            <a:off x="548640" y="6263640"/>
-            <a:ext cx="8229600" cy="411480"/>
-          </a:xfrm>
-          <a:prstGeom prst="rect">
-            <a:avLst/>
-          </a:prstGeom>
-          <a:noFill/>
-        </p:spPr>
-        <p:txBody>
-          <a:bodyPr wrap="square">
-            <a:spAutoFit/>
-          </a:bodyPr>
-          <a:lstStyle/>
-          <a:p>
-            <a:r>
-              <a:rPr sz="2200" b="0" i="0">
-                <a:solidFill>
-                  <a:srgbClr val="000000"/>
-                </a:solidFill>
-                <a:latin typeface="Calibri"/>
-              </a:rPr>
-              <a:t>Sheet: Sec 3A - 5-Stock Demo</a:t>
-            </a:r>
-          </a:p>
-        </p:txBody>
-      </p:sp>
-      <p:sp>
-        <p:nvSpPr>
-          <p:cNvPr id="6" name="TextBox 5"/>
-          <p:cNvSpPr txBox="1"/>
-          <p:nvPr/>
-        </p:nvSpPr>
-        <p:spPr>
-          <a:xfrm>
-            <a:off x="9326880" y="6263640"/>
-            <a:ext cx="2313432" cy="411480"/>
-          </a:xfrm>
-          <a:prstGeom prst="rect">
-            <a:avLst/>
-          </a:prstGeom>
-          <a:noFill/>
-        </p:spPr>
-        <p:txBody>
-          <a:bodyPr wrap="square">
-            <a:spAutoFit/>
-          </a:bodyPr>
-          <a:lstStyle/>
-          <a:p>
-            <a:pPr algn="r"/>
-            <a:r>
-              <a:rPr sz="2200" b="0" i="0">
-                <a:solidFill>
-                  <a:srgbClr val="000000"/>
-                </a:solidFill>
-                <a:latin typeface="Calibri"/>
-              </a:rPr>
-              <a:t>Row 136</a:t>
-            </a:r>
-          </a:p>
-        </p:txBody>
-      </p:sp>
-    </p:spTree>
-  </p:cSld>
-  <p:clrMapOvr>
-    <a:masterClrMapping/>
-  </p:clrMapOvr>
-</p:sld>
-</file>
-
-<file path=ppt/slides/slide6.xml><?xml version="1.0" encoding="utf-8"?>
-<p:sld xmlns:a="http://schemas.openxmlformats.org/drawingml/2006/main" xmlns:p="http://schemas.openxmlformats.org/presentationml/2006/main" xmlns:r="http://schemas.openxmlformats.org/officeDocument/2006/relationships">
-  <p:cSld>
-    <p:spTree>
-      <p:nvGrpSpPr>
-        <p:cNvPr id="1" name=""/>
-        <p:cNvGrpSpPr/>
-        <p:nvPr/>
-      </p:nvGrpSpPr>
-      <p:grpSpPr/>
-      <p:sp>
-        <p:nvSpPr>
-          <p:cNvPr id="2" name="TextBox 1"/>
-          <p:cNvSpPr txBox="1"/>
-          <p:nvPr/>
-        </p:nvSpPr>
-        <p:spPr>
-          <a:xfrm>
-            <a:off x="548640" y="320040"/>
-            <a:ext cx="11091672" cy="457200"/>
-          </a:xfrm>
-          <a:prstGeom prst="rect">
-            <a:avLst/>
-          </a:prstGeom>
-          <a:noFill/>
-        </p:spPr>
-        <p:txBody>
-          <a:bodyPr wrap="square">
-            <a:spAutoFit/>
-          </a:bodyPr>
-          <a:lstStyle/>
-          <a:p>
-            <a:r>
-              <a:rPr sz="2000" b="0" i="0">
-                <a:solidFill>
-                  <a:srgbClr val="595959"/>
-                </a:solidFill>
-                <a:latin typeface="Calibri"/>
-              </a:rPr>
-              <a:t>MCQ 6</a:t>
-            </a:r>
-          </a:p>
-        </p:txBody>
-      </p:sp>
-      <p:sp>
-        <p:nvSpPr>
-          <p:cNvPr id="3" name="TextBox 2"/>
-          <p:cNvSpPr txBox="1"/>
-          <p:nvPr/>
-        </p:nvSpPr>
-        <p:spPr>
-          <a:xfrm>
-            <a:off x="548640" y="731520"/>
-            <a:ext cx="11091672" cy="777240"/>
-          </a:xfrm>
-          <a:prstGeom prst="rect">
-            <a:avLst/>
-          </a:prstGeom>
-          <a:noFill/>
-        </p:spPr>
-        <p:txBody>
-          <a:bodyPr wrap="square">
-            <a:spAutoFit/>
-          </a:bodyPr>
-          <a:lstStyle/>
-          <a:p>
-            <a:r>
-              <a:rPr sz="3600" b="1" i="0">
-                <a:solidFill>
-                  <a:srgbClr val="000000"/>
-                </a:solidFill>
-                <a:latin typeface="Calibri"/>
-              </a:rPr>
-              <a:t>Losing a diversifier</a:t>
-            </a:r>
-          </a:p>
-        </p:txBody>
-      </p:sp>
-      <p:sp>
-        <p:nvSpPr>
-          <p:cNvPr id="4" name="TextBox 3"/>
-          <p:cNvSpPr txBox="1"/>
-          <p:nvPr/>
-        </p:nvSpPr>
-        <p:spPr>
-          <a:xfrm>
-            <a:off x="548640" y="1828800"/>
-            <a:ext cx="11091672" cy="3931920"/>
-          </a:xfrm>
-          <a:prstGeom prst="rect">
-            <a:avLst/>
-          </a:prstGeom>
-          <a:noFill/>
-        </p:spPr>
-        <p:txBody>
-          <a:bodyPr wrap="square">
-            <a:spAutoFit/>
-          </a:bodyPr>
-          <a:lstStyle/>
-          <a:p>
-            <a:pPr marL="411480" indent="-411480">
-              <a:spcAft>
-                <a:spcPts val="2400"/>
-              </a:spcAft>
-              <a:buFont typeface="Arial"/>
-              <a:buChar char="•"/>
-            </a:pPr>
-            <a:r>
-              <a:rPr sz="2800">
-                <a:solidFill>
-                  <a:srgbClr val="000000"/>
-                </a:solidFill>
-                <a:latin typeface="Calibri"/>
-              </a:rPr>
-              <a:t>AGG has low volatility and low correlation with the stocks</a:t>
-            </a:r>
-          </a:p>
-          <a:p>
-            <a:pPr marL="411480" indent="-411480">
-              <a:spcAft>
-                <a:spcPts val="2400"/>
-              </a:spcAft>
-              <a:buFont typeface="Arial"/>
-              <a:buChar char="•"/>
-            </a:pPr>
-            <a:r>
-              <a:rPr sz="2800">
-                <a:solidFill>
-                  <a:srgbClr val="000000"/>
-                </a:solidFill>
-                <a:latin typeface="Calibri"/>
-              </a:rPr>
-              <a:t>Removing an asset shrinks the menu of possible portfolios</a:t>
-            </a:r>
-          </a:p>
-          <a:p>
-            <a:pPr marL="411480" indent="-411480">
-              <a:spcAft>
-                <a:spcPts val="2400"/>
-              </a:spcAft>
-              <a:buFont typeface="Arial"/>
-              <a:buChar char="•"/>
-            </a:pPr>
-            <a:r>
-              <a:rPr sz="2800">
-                <a:solidFill>
-                  <a:srgbClr val="000000"/>
-                </a:solidFill>
-                <a:latin typeface="Calibri"/>
-              </a:rPr>
-              <a:t>Ask: can a smaller menu ever offer lower risk at the same return?</a:t>
-            </a:r>
-          </a:p>
-        </p:txBody>
-      </p:sp>
-      <p:sp>
-        <p:nvSpPr>
-          <p:cNvPr id="5" name="TextBox 4"/>
-          <p:cNvSpPr txBox="1"/>
-          <p:nvPr/>
-        </p:nvSpPr>
-        <p:spPr>
-          <a:xfrm>
-            <a:off x="548640" y="6263640"/>
-            <a:ext cx="8229600" cy="411480"/>
-          </a:xfrm>
-          <a:prstGeom prst="rect">
-            <a:avLst/>
-          </a:prstGeom>
-          <a:noFill/>
-        </p:spPr>
-        <p:txBody>
-          <a:bodyPr wrap="square">
-            <a:spAutoFit/>
-          </a:bodyPr>
-          <a:lstStyle/>
-          <a:p>
-            <a:r>
-              <a:rPr sz="2200" b="0" i="0">
-                <a:solidFill>
-                  <a:srgbClr val="000000"/>
-                </a:solidFill>
-                <a:latin typeface="Calibri"/>
-              </a:rPr>
-              <a:t>Sheet: Sec 3A - 5-Stock Demo</a:t>
-            </a:r>
-          </a:p>
-        </p:txBody>
-      </p:sp>
-      <p:sp>
-        <p:nvSpPr>
-          <p:cNvPr id="6" name="TextBox 5"/>
-          <p:cNvSpPr txBox="1"/>
-          <p:nvPr/>
-        </p:nvSpPr>
-        <p:spPr>
-          <a:xfrm>
-            <a:off x="9326880" y="6263640"/>
-            <a:ext cx="2313432" cy="411480"/>
-          </a:xfrm>
-          <a:prstGeom prst="rect">
-            <a:avLst/>
-          </a:prstGeom>
-          <a:noFill/>
-        </p:spPr>
-        <p:txBody>
-          <a:bodyPr wrap="square">
-            <a:spAutoFit/>
-          </a:bodyPr>
-          <a:lstStyle/>
-          <a:p>
-            <a:pPr algn="r"/>
-            <a:r>
-              <a:rPr sz="2200" b="0" i="0">
-                <a:solidFill>
-                  <a:srgbClr val="000000"/>
-                </a:solidFill>
-                <a:latin typeface="Calibri"/>
-              </a:rPr>
-              <a:t>Row 143</a:t>
-            </a:r>
-          </a:p>
-        </p:txBody>
-      </p:sp>
-    </p:spTree>
-  </p:cSld>
-  <p:clrMapOvr>
-    <a:masterClrMapping/>
-  </p:clrMapOvr>
-</p:sld>
-</file>
-
-<file path=ppt/slides/slide7.xml><?xml version="1.0" encoding="utf-8"?>
-<p:sld xmlns:a="http://schemas.openxmlformats.org/drawingml/2006/main" xmlns:p="http://schemas.openxmlformats.org/presentationml/2006/main" xmlns:r="http://schemas.openxmlformats.org/officeDocument/2006/relationships">
-  <p:cSld>
-    <p:spTree>
-      <p:nvGrpSpPr>
-        <p:cNvPr id="1" name=""/>
-        <p:cNvGrpSpPr/>
-        <p:nvPr/>
-      </p:nvGrpSpPr>
-      <p:grpSpPr/>
-      <p:sp>
-        <p:nvSpPr>
-          <p:cNvPr id="2" name="TextBox 1"/>
-          <p:cNvSpPr txBox="1"/>
-          <p:nvPr/>
-        </p:nvSpPr>
-        <p:spPr>
-          <a:xfrm>
-            <a:off x="548640" y="320040"/>
-            <a:ext cx="11091672" cy="457200"/>
-          </a:xfrm>
-          <a:prstGeom prst="rect">
-            <a:avLst/>
-          </a:prstGeom>
-          <a:noFill/>
-        </p:spPr>
-        <p:txBody>
-          <a:bodyPr wrap="square">
-            <a:spAutoFit/>
-          </a:bodyPr>
-          <a:lstStyle/>
-          <a:p>
-            <a:r>
-              <a:rPr sz="2000" b="0" i="0">
-                <a:solidFill>
-                  <a:srgbClr val="595959"/>
-                </a:solidFill>
-                <a:latin typeface="Calibri"/>
-              </a:rPr>
-              <a:t>MCQ 7</a:t>
-            </a:r>
-          </a:p>
-        </p:txBody>
-      </p:sp>
-      <p:sp>
-        <p:nvSpPr>
-          <p:cNvPr id="3" name="TextBox 2"/>
-          <p:cNvSpPr txBox="1"/>
-          <p:nvPr/>
-        </p:nvSpPr>
-        <p:spPr>
-          <a:xfrm>
-            <a:off x="548640" y="731520"/>
-            <a:ext cx="11091672" cy="777240"/>
-          </a:xfrm>
-          <a:prstGeom prst="rect">
-            <a:avLst/>
-          </a:prstGeom>
-          <a:noFill/>
-        </p:spPr>
-        <p:txBody>
-          <a:bodyPr wrap="square">
-            <a:spAutoFit/>
-          </a:bodyPr>
-          <a:lstStyle/>
-          <a:p>
-            <a:r>
-              <a:rPr sz="3600" b="1" i="0">
-                <a:solidFill>
-                  <a:srgbClr val="000000"/>
-                </a:solidFill>
-                <a:latin typeface="Calibri"/>
-              </a:rPr>
-              <a:t>The steepest line from rf</a:t>
-            </a:r>
-          </a:p>
-        </p:txBody>
-      </p:sp>
-      <p:sp>
-        <p:nvSpPr>
-          <p:cNvPr id="4" name="TextBox 3"/>
-          <p:cNvSpPr txBox="1"/>
-          <p:nvPr/>
-        </p:nvSpPr>
-        <p:spPr>
-          <a:xfrm>
-            <a:off x="548640" y="1828800"/>
-            <a:ext cx="11091672" cy="3931920"/>
-          </a:xfrm>
-          <a:prstGeom prst="rect">
-            <a:avLst/>
-          </a:prstGeom>
-          <a:noFill/>
-        </p:spPr>
-        <p:txBody>
-          <a:bodyPr wrap="square">
-            <a:spAutoFit/>
-          </a:bodyPr>
-          <a:lstStyle/>
-          <a:p>
-            <a:pPr marL="411480" indent="-411480">
-              <a:spcAft>
-                <a:spcPts val="2400"/>
-              </a:spcAft>
-              <a:buFont typeface="Arial"/>
-              <a:buChar char="•"/>
-            </a:pPr>
-            <a:r>
-              <a:rPr sz="2800">
-                <a:solidFill>
-                  <a:srgbClr val="000000"/>
-                </a:solidFill>
-                <a:latin typeface="Calibri"/>
-              </a:rPr>
-              <a:t>A line from rf to any portfolio has slope = its Sharpe ratio</a:t>
-            </a:r>
-          </a:p>
-          <a:p>
-            <a:pPr marL="411480" indent="-411480">
-              <a:spcAft>
-                <a:spcPts val="2400"/>
-              </a:spcAft>
-              <a:buFont typeface="Arial"/>
-              <a:buChar char="•"/>
-            </a:pPr>
-            <a:r>
-              <a:rPr sz="2800">
-                <a:solidFill>
-                  <a:srgbClr val="000000"/>
-                </a:solidFill>
-                <a:latin typeface="Calibri"/>
-              </a:rPr>
-              <a:t>Rotate the line upward until it just touches the frontier</a:t>
-            </a:r>
-          </a:p>
-          <a:p>
-            <a:pPr marL="411480" indent="-411480">
-              <a:spcAft>
-                <a:spcPts val="2400"/>
-              </a:spcAft>
-              <a:buFont typeface="Arial"/>
-              <a:buChar char="•"/>
-            </a:pPr>
-            <a:r>
-              <a:rPr sz="2800">
-                <a:solidFill>
-                  <a:srgbClr val="000000"/>
-                </a:solidFill>
-                <a:latin typeface="Calibri"/>
-              </a:rPr>
-              <a:t>That touching point gives the steepest line you can reach</a:t>
-            </a:r>
-          </a:p>
-        </p:txBody>
-      </p:sp>
-      <p:sp>
-        <p:nvSpPr>
-          <p:cNvPr id="5" name="TextBox 4"/>
-          <p:cNvSpPr txBox="1"/>
-          <p:nvPr/>
-        </p:nvSpPr>
-        <p:spPr>
-          <a:xfrm>
-            <a:off x="548640" y="6263640"/>
-            <a:ext cx="8229600" cy="411480"/>
-          </a:xfrm>
-          <a:prstGeom prst="rect">
-            <a:avLst/>
-          </a:prstGeom>
-          <a:noFill/>
-        </p:spPr>
-        <p:txBody>
-          <a:bodyPr wrap="square">
-            <a:spAutoFit/>
-          </a:bodyPr>
-          <a:lstStyle/>
-          <a:p>
-            <a:r>
-              <a:rPr sz="2200" b="0" i="0">
-                <a:solidFill>
-                  <a:srgbClr val="000000"/>
-                </a:solidFill>
-                <a:latin typeface="Calibri"/>
-              </a:rPr>
-              <a:t>Sheet: Sec 3A - 5-Stock Demo</a:t>
-            </a:r>
-          </a:p>
-        </p:txBody>
-      </p:sp>
-      <p:sp>
-        <p:nvSpPr>
-          <p:cNvPr id="6" name="TextBox 5"/>
-          <p:cNvSpPr txBox="1"/>
-          <p:nvPr/>
-        </p:nvSpPr>
-        <p:spPr>
-          <a:xfrm>
-            <a:off x="9326880" y="6263640"/>
-            <a:ext cx="2313432" cy="411480"/>
-          </a:xfrm>
-          <a:prstGeom prst="rect">
-            <a:avLst/>
-          </a:prstGeom>
-          <a:noFill/>
-        </p:spPr>
-        <p:txBody>
-          <a:bodyPr wrap="square">
-            <a:spAutoFit/>
-          </a:bodyPr>
-          <a:lstStyle/>
-          <a:p>
-            <a:pPr algn="r"/>
-            <a:r>
-              <a:rPr sz="2200" b="0" i="0">
-                <a:solidFill>
-                  <a:srgbClr val="000000"/>
-                </a:solidFill>
-                <a:latin typeface="Calibri"/>
-              </a:rPr>
-              <a:t>Row 180</a:t>
-            </a:r>
-          </a:p>
-        </p:txBody>
-      </p:sp>
-    </p:spTree>
-  </p:cSld>
-  <p:clrMapOvr>
-    <a:masterClrMapping/>
-  </p:clrMapOvr>
-</p:sld>
-</file>
-
-<file path=ppt/slides/slide8.xml><?xml version="1.0" encoding="utf-8"?>
-<p:sld xmlns:a="http://schemas.openxmlformats.org/drawingml/2006/main" xmlns:p="http://schemas.openxmlformats.org/presentationml/2006/main" xmlns:r="http://schemas.openxmlformats.org/officeDocument/2006/relationships">
-  <p:cSld>
-    <p:spTree>
-      <p:nvGrpSpPr>
-        <p:cNvPr id="1" name=""/>
-        <p:cNvGrpSpPr/>
-        <p:nvPr/>
-      </p:nvGrpSpPr>
-      <p:grpSpPr/>
-      <p:sp>
-        <p:nvSpPr>
-          <p:cNvPr id="2" name="TextBox 1"/>
-          <p:cNvSpPr txBox="1"/>
-          <p:nvPr/>
-        </p:nvSpPr>
-        <p:spPr>
-          <a:xfrm>
-            <a:off x="548640" y="320040"/>
-            <a:ext cx="11091672" cy="457200"/>
-          </a:xfrm>
-          <a:prstGeom prst="rect">
-            <a:avLst/>
-          </a:prstGeom>
-          <a:noFill/>
-        </p:spPr>
-        <p:txBody>
-          <a:bodyPr wrap="square">
-            <a:spAutoFit/>
-          </a:bodyPr>
-          <a:lstStyle/>
-          <a:p>
-            <a:r>
-              <a:rPr sz="2000" b="0" i="0">
-                <a:solidFill>
-                  <a:srgbClr val="595959"/>
-                </a:solidFill>
-                <a:latin typeface="Calibri"/>
-              </a:rPr>
-              <a:t>T/F 8</a:t>
-            </a:r>
-          </a:p>
-        </p:txBody>
-      </p:sp>
-      <p:sp>
-        <p:nvSpPr>
-          <p:cNvPr id="3" name="TextBox 2"/>
-          <p:cNvSpPr txBox="1"/>
-          <p:nvPr/>
-        </p:nvSpPr>
-        <p:spPr>
-          <a:xfrm>
-            <a:off x="548640" y="731520"/>
-            <a:ext cx="11091672" cy="777240"/>
-          </a:xfrm>
-          <a:prstGeom prst="rect">
-            <a:avLst/>
-          </a:prstGeom>
-          <a:noFill/>
-        </p:spPr>
-        <p:txBody>
-          <a:bodyPr wrap="square">
-            <a:spAutoFit/>
-          </a:bodyPr>
-          <a:lstStyle/>
-          <a:p>
-            <a:r>
-              <a:rPr sz="3600" b="1" i="0">
-                <a:solidFill>
-                  <a:srgbClr val="000000"/>
-                </a:solidFill>
-                <a:latin typeface="Calibri"/>
-              </a:rPr>
-              <a:t>Reading a zero weight</a:t>
-            </a:r>
-          </a:p>
-        </p:txBody>
-      </p:sp>
-      <p:sp>
-        <p:nvSpPr>
-          <p:cNvPr id="4" name="TextBox 3"/>
-          <p:cNvSpPr txBox="1"/>
-          <p:nvPr/>
-        </p:nvSpPr>
-        <p:spPr>
-          <a:xfrm>
-            <a:off x="548640" y="1828800"/>
-            <a:ext cx="11091672" cy="3931920"/>
-          </a:xfrm>
-          <a:prstGeom prst="rect">
-            <a:avLst/>
-          </a:prstGeom>
-          <a:noFill/>
-        </p:spPr>
-        <p:txBody>
-          <a:bodyPr wrap="square">
-            <a:spAutoFit/>
-          </a:bodyPr>
-          <a:lstStyle/>
-          <a:p>
-            <a:pPr marL="411480" indent="-411480">
-              <a:spcAft>
-                <a:spcPts val="2400"/>
-              </a:spcAft>
-              <a:buFont typeface="Arial"/>
-              <a:buChar char="•"/>
-            </a:pPr>
-            <a:r>
-              <a:rPr sz="2800">
-                <a:solidFill>
-                  <a:srgbClr val="000000"/>
-                </a:solidFill>
-                <a:latin typeface="Calibri"/>
-              </a:rPr>
-              <a:t>At the optimum, Solver has already tried adding more of each asset</a:t>
-            </a:r>
-          </a:p>
-          <a:p>
-            <a:pPr marL="411480" indent="-411480">
-              <a:spcAft>
-                <a:spcPts val="2400"/>
-              </a:spcAft>
-              <a:buFont typeface="Arial"/>
-              <a:buChar char="•"/>
-            </a:pPr>
-            <a:r>
-              <a:rPr sz="2800">
-                <a:solidFill>
-                  <a:srgbClr val="000000"/>
-                </a:solidFill>
-                <a:latin typeface="Calibri"/>
-              </a:rPr>
-              <a:t>It keeps a weight at 0 only if adding some would not help the objective</a:t>
-            </a:r>
-          </a:p>
-          <a:p>
-            <a:pPr marL="411480" indent="-411480">
-              <a:spcAft>
-                <a:spcPts val="2400"/>
-              </a:spcAft>
-              <a:buFont typeface="Arial"/>
-              <a:buChar char="•"/>
-            </a:pPr>
-            <a:r>
-              <a:rPr sz="2800">
-                <a:solidFill>
-                  <a:srgbClr val="000000"/>
-                </a:solidFill>
-                <a:latin typeface="Calibri"/>
-              </a:rPr>
-              <a:t>Here the objective is the Sharpe ratio, with no shorting</a:t>
-            </a:r>
-          </a:p>
-        </p:txBody>
-      </p:sp>
-      <p:sp>
-        <p:nvSpPr>
-          <p:cNvPr id="5" name="TextBox 4"/>
-          <p:cNvSpPr txBox="1"/>
-          <p:nvPr/>
-        </p:nvSpPr>
-        <p:spPr>
-          <a:xfrm>
-            <a:off x="548640" y="6263640"/>
-            <a:ext cx="8229600" cy="411480"/>
-          </a:xfrm>
-          <a:prstGeom prst="rect">
-            <a:avLst/>
-          </a:prstGeom>
-          <a:noFill/>
-        </p:spPr>
-        <p:txBody>
-          <a:bodyPr wrap="square">
-            <a:spAutoFit/>
-          </a:bodyPr>
-          <a:lstStyle/>
-          <a:p>
-            <a:r>
-              <a:rPr sz="2200" b="0" i="0">
-                <a:solidFill>
-                  <a:srgbClr val="000000"/>
-                </a:solidFill>
-                <a:latin typeface="Calibri"/>
-              </a:rPr>
-              <a:t>Sheet: Sec 3A - 5-Stock Demo</a:t>
-            </a:r>
-          </a:p>
-        </p:txBody>
-      </p:sp>
-      <p:sp>
-        <p:nvSpPr>
-          <p:cNvPr id="6" name="TextBox 5"/>
-          <p:cNvSpPr txBox="1"/>
-          <p:nvPr/>
-        </p:nvSpPr>
-        <p:spPr>
-          <a:xfrm>
-            <a:off x="9326880" y="6263640"/>
-            <a:ext cx="2313432" cy="411480"/>
-          </a:xfrm>
-          <a:prstGeom prst="rect">
-            <a:avLst/>
-          </a:prstGeom>
-          <a:noFill/>
-        </p:spPr>
-        <p:txBody>
-          <a:bodyPr wrap="square">
-            <a:spAutoFit/>
-          </a:bodyPr>
-          <a:lstStyle/>
-          <a:p>
-            <a:pPr algn="r"/>
-            <a:r>
-              <a:rPr sz="2200" b="0" i="0">
-                <a:solidFill>
-                  <a:srgbClr val="000000"/>
-                </a:solidFill>
-                <a:latin typeface="Calibri"/>
-              </a:rPr>
-              <a:t>Row 187</a:t>
-            </a:r>
-          </a:p>
-        </p:txBody>
-      </p:sp>
-    </p:spTree>
-  </p:cSld>
-  <p:clrMapOvr>
-    <a:masterClrMapping/>
-  </p:clrMapOvr>
-</p:sld>
-</file>
-
-<file path=ppt/slides/slide9.xml><?xml version="1.0" encoding="utf-8"?>
-<p:sld xmlns:a="http://schemas.openxmlformats.org/drawingml/2006/main" xmlns:p="http://schemas.openxmlformats.org/presentationml/2006/main" xmlns:r="http://schemas.openxmlformats.org/officeDocument/2006/relationships">
-  <p:cSld>
-    <p:spTree>
-      <p:nvGrpSpPr>
-        <p:cNvPr id="1" name=""/>
-        <p:cNvGrpSpPr/>
-        <p:nvPr/>
-      </p:nvGrpSpPr>
-      <p:grpSpPr/>
-      <p:sp>
-        <p:nvSpPr>
-          <p:cNvPr id="2" name="TextBox 1"/>
-          <p:cNvSpPr txBox="1"/>
-          <p:nvPr/>
-        </p:nvSpPr>
-        <p:spPr>
-          <a:xfrm>
-            <a:off x="548640" y="320040"/>
-            <a:ext cx="11091672" cy="457200"/>
-          </a:xfrm>
-          <a:prstGeom prst="rect">
-            <a:avLst/>
-          </a:prstGeom>
-          <a:noFill/>
-        </p:spPr>
-        <p:txBody>
-          <a:bodyPr wrap="square">
-            <a:spAutoFit/>
-          </a:bodyPr>
-          <a:lstStyle/>
-          <a:p>
-            <a:r>
-              <a:rPr sz="2000" b="0" i="0">
-                <a:solidFill>
-                  <a:srgbClr val="595959"/>
-                </a:solidFill>
-                <a:latin typeface="Calibri"/>
-              </a:rPr>
-              <a:t>MCQ 9</a:t>
-            </a:r>
-          </a:p>
-        </p:txBody>
-      </p:sp>
-      <p:sp>
-        <p:nvSpPr>
-          <p:cNvPr id="3" name="TextBox 2"/>
-          <p:cNvSpPr txBox="1"/>
-          <p:nvPr/>
-        </p:nvSpPr>
-        <p:spPr>
-          <a:xfrm>
-            <a:off x="548640" y="731520"/>
-            <a:ext cx="11091672" cy="777240"/>
-          </a:xfrm>
-          <a:prstGeom prst="rect">
-            <a:avLst/>
-          </a:prstGeom>
-          <a:noFill/>
-        </p:spPr>
-        <p:txBody>
-          <a:bodyPr wrap="square">
-            <a:spAutoFit/>
-          </a:bodyPr>
-          <a:lstStyle/>
-          <a:p>
-            <a:r>
-              <a:rPr sz="3600" b="1" i="0">
-                <a:solidFill>
-                  <a:srgbClr val="000000"/>
-                </a:solidFill>
-                <a:latin typeface="Calibri"/>
-              </a:rPr>
-              <a:t>Same return, different risk</a:t>
-            </a:r>
-          </a:p>
-        </p:txBody>
-      </p:sp>
-      <p:sp>
-        <p:nvSpPr>
-          <p:cNvPr id="4" name="TextBox 3"/>
-          <p:cNvSpPr txBox="1"/>
-          <p:nvPr/>
-        </p:nvSpPr>
-        <p:spPr>
-          <a:xfrm>
-            <a:off x="548640" y="1828800"/>
-            <a:ext cx="11091672" cy="3931920"/>
-          </a:xfrm>
-          <a:prstGeom prst="rect">
-            <a:avLst/>
-          </a:prstGeom>
-          <a:noFill/>
-        </p:spPr>
-        <p:txBody>
-          <a:bodyPr wrap="square">
-            <a:spAutoFit/>
-          </a:bodyPr>
-          <a:lstStyle/>
-          <a:p>
-            <a:pPr marL="411480" indent="-411480">
-              <a:spcAft>
-                <a:spcPts val="2400"/>
-              </a:spcAft>
-              <a:buFont typeface="Arial"/>
-              <a:buChar char="•"/>
-            </a:pPr>
-            <a:r>
-              <a:rPr sz="2800">
-                <a:solidFill>
-                  <a:srgbClr val="000000"/>
-                </a:solidFill>
-                <a:latin typeface="Calibri"/>
-              </a:rPr>
-              <a:t>Return depends only on the weighted average of the means</a:t>
-            </a:r>
-          </a:p>
-          <a:p>
-            <a:pPr marL="411480" indent="-411480">
-              <a:spcAft>
-                <a:spcPts val="2400"/>
-              </a:spcAft>
-              <a:buFont typeface="Arial"/>
-              <a:buChar char="•"/>
-            </a:pPr>
-            <a:r>
-              <a:rPr sz="2800">
-                <a:solidFill>
-                  <a:srgbClr val="000000"/>
-                </a:solidFill>
-                <a:latin typeface="Calibri"/>
-              </a:rPr>
-              <a:t>Risk also depends on how the assets move together (Σ)</a:t>
-            </a:r>
-          </a:p>
-          <a:p>
-            <a:pPr marL="411480" indent="-411480">
-              <a:spcAft>
-                <a:spcPts val="2400"/>
-              </a:spcAft>
-              <a:buFont typeface="Arial"/>
-              <a:buChar char="•"/>
-            </a:pPr>
-            <a:r>
-              <a:rPr sz="2800">
-                <a:solidFill>
-                  <a:srgbClr val="000000"/>
-                </a:solidFill>
-                <a:latin typeface="Calibri"/>
-              </a:rPr>
-              <a:t>Compare σp in Step 6 (B50) and Step 7 (B63) at the same return</a:t>
-            </a:r>
-          </a:p>
-        </p:txBody>
-      </p:sp>
-      <p:sp>
-        <p:nvSpPr>
-          <p:cNvPr id="5" name="TextBox 4"/>
-          <p:cNvSpPr txBox="1"/>
-          <p:nvPr/>
-        </p:nvSpPr>
-        <p:spPr>
-          <a:xfrm>
-            <a:off x="548640" y="6263640"/>
-            <a:ext cx="8229600" cy="411480"/>
-          </a:xfrm>
-          <a:prstGeom prst="rect">
-            <a:avLst/>
-          </a:prstGeom>
-          <a:noFill/>
-        </p:spPr>
-        <p:txBody>
-          <a:bodyPr wrap="square">
-            <a:spAutoFit/>
-          </a:bodyPr>
-          <a:lstStyle/>
-          <a:p>
-            <a:r>
-              <a:rPr sz="2200" b="0" i="0">
-                <a:solidFill>
-                  <a:srgbClr val="000000"/>
-                </a:solidFill>
-                <a:latin typeface="Calibri"/>
-              </a:rPr>
-              <a:t>Sheet: Sec 3A - 5-Stock Demo</a:t>
-            </a:r>
-          </a:p>
-        </p:txBody>
-      </p:sp>
-      <p:sp>
-        <p:nvSpPr>
-          <p:cNvPr id="6" name="TextBox 5"/>
-          <p:cNvSpPr txBox="1"/>
-          <p:nvPr/>
-        </p:nvSpPr>
-        <p:spPr>
-          <a:xfrm>
-            <a:off x="9326880" y="6263640"/>
-            <a:ext cx="2313432" cy="411480"/>
-          </a:xfrm>
-          <a:prstGeom prst="rect">
-            <a:avLst/>
-          </a:prstGeom>
-          <a:noFill/>
-        </p:spPr>
-        <p:txBody>
-          <a:bodyPr wrap="square">
-            <a:spAutoFit/>
-          </a:bodyPr>
-          <a:lstStyle/>
-          <a:p>
-            <a:pPr algn="r"/>
-            <a:r>
-              <a:rPr sz="2200" b="0" i="0">
-                <a:solidFill>
-                  <a:srgbClr val="000000"/>
-                </a:solidFill>
-                <a:latin typeface="Calibri"/>
-              </a:rPr>
-              <a:t>Row 190</a:t>
             </a:r>
           </a:p>
         </p:txBody>

</xml_diff>

<commit_message>
Build full 13-slide deck for Sec 3A 5-Stock Demo questions (rows 124-211)
Co-Authored-By: Claude Opus 5.5 <noreply@anthropic.com>
Claude-Session: https://claude.ai/code/session_012Yma3oVhULpXzSWwtpL6B6
</commit_message>
<xml_diff>
--- a/Sec3A_5-Stock_Demo_Concept_Slides.pptx
+++ b/Sec3A_5-Stock_Demo_Concept_Slides.pptx
@@ -8,6 +8,16 @@
     <p:sldId id="256" r:id="rId7"/>
     <p:sldId id="257" r:id="rId8"/>
     <p:sldId id="258" r:id="rId9"/>
+    <p:sldId id="259" r:id="rId10"/>
+    <p:sldId id="260" r:id="rId11"/>
+    <p:sldId id="261" r:id="rId12"/>
+    <p:sldId id="262" r:id="rId13"/>
+    <p:sldId id="263" r:id="rId14"/>
+    <p:sldId id="264" r:id="rId15"/>
+    <p:sldId id="265" r:id="rId16"/>
+    <p:sldId id="266" r:id="rId17"/>
+    <p:sldId id="267" r:id="rId18"/>
+    <p:sldId id="268" r:id="rId19"/>
   </p:sldIdLst>
   <p:sldSz cx="12191695" cy="6858000" type="screen4x3"/>
   <p:notesSz cx="6858000" cy="9144000"/>
@@ -3119,7 +3129,7 @@
                 </a:solidFill>
                 <a:latin typeface="Calibri"/>
               </a:rPr>
-              <a:t>T/F 1</a:t>
+              <a:t>Question 1</a:t>
             </a:r>
           </a:p>
         </p:txBody>
@@ -3153,7 +3163,7 @@
                 </a:solidFill>
                 <a:latin typeface="Calibri"/>
               </a:rPr>
-              <a:t>Portfolio Constraints and the Investment Opportunity Set</a:t>
+              <a:t>Does Allowing Short Selling Worsen the Best Portfolio?</a:t>
             </a:r>
           </a:p>
         </p:txBody>
@@ -3166,7 +3176,7 @@
         </p:nvSpPr>
         <p:spPr>
           <a:xfrm>
-            <a:off x="548640" y="1234440"/>
+            <a:off x="548640" y="1280160"/>
             <a:ext cx="11091672" cy="457200"/>
           </a:xfrm>
           <a:prstGeom prst="rect">
@@ -3181,13 +3191,22 @@
           <a:lstStyle/>
           <a:p>
             <a:r>
-              <a:rPr sz="1800" b="0" i="1">
-                <a:solidFill>
-                  <a:srgbClr val="595959"/>
-                </a:solidFill>
-                <a:latin typeface="Calibri"/>
-              </a:rPr>
-              <a:t>Relaxing a constraint enlarges the feasible set, so the optimum cannot deteriorate.</a:t>
+              <a:rPr sz="2000" b="1" i="0">
+                <a:solidFill>
+                  <a:srgbClr val="1F3A5F"/>
+                </a:solidFill>
+                <a:latin typeface="Calibri"/>
+              </a:rPr>
+              <a:t>Answer: </a:t>
+            </a:r>
+            <a:r>
+              <a:rPr sz="2000" b="0" i="0">
+                <a:solidFill>
+                  <a:srgbClr val="1F3A5F"/>
+                </a:solidFill>
+                <a:latin typeface="Calibri"/>
+              </a:rPr>
+              <a:t>True — the best achievable tradeoff cannot get worse.</a:t>
             </a:r>
           </a:p>
         </p:txBody>
@@ -3200,8 +3219,8 @@
         </p:nvSpPr>
         <p:spPr>
           <a:xfrm>
-            <a:off x="548640" y="1920240"/>
-            <a:ext cx="7223760" cy="4206240"/>
+            <a:off x="548640" y="2011680"/>
+            <a:ext cx="11091672" cy="2743200"/>
           </a:xfrm>
           <a:prstGeom prst="rect">
             <a:avLst/>
@@ -3222,13 +3241,13 @@
               <a:buChar char="•"/>
             </a:pPr>
             <a:r>
-              <a:rPr sz="1700">
-                <a:solidFill>
-                  <a:srgbClr val="000000"/>
-                </a:solidFill>
-                <a:latin typeface="Calibri"/>
-              </a:rPr>
-              <a:t>The investment opportunity set is the set of all attainable (σp, E[rp]) combinations. The no-short-sale constraint (wᵢ ≥ 0) restricts it to a subset of the set available when weights may be negative.</a:t>
+              <a:rPr sz="2000" b="0" i="0">
+                <a:solidFill>
+                  <a:srgbClr val="000000"/>
+                </a:solidFill>
+                <a:latin typeface="Calibri"/>
+              </a:rPr>
+              <a:t>Allowing negative weights expands the feasible set of portfolios.</a:t>
             </a:r>
           </a:p>
           <a:p>
@@ -3240,13 +3259,13 @@
               <a:buChar char="•"/>
             </a:pPr>
             <a:r>
-              <a:rPr sz="1700">
-                <a:solidFill>
-                  <a:srgbClr val="000000"/>
-                </a:solidFill>
-                <a:latin typeface="Calibri"/>
-              </a:rPr>
-              <a:t>Every portfolio feasible under the constraint remains feasible without it. Hence, at each target E[rp], the minimum attainable σp is weakly lower when short sales are permitted, and the maximum attainable Sharpe ratio is weakly higher.</a:t>
+              <a:rPr sz="2000" b="0" i="0">
+                <a:solidFill>
+                  <a:srgbClr val="000000"/>
+                </a:solidFill>
+                <a:latin typeface="Calibri"/>
+              </a:rPr>
+              <a:t>Every no-shorting portfolio remains available: permission to short is not an obligation.</a:t>
             </a:r>
           </a:p>
           <a:p>
@@ -3258,13 +3277,13 @@
               <a:buChar char="•"/>
             </a:pPr>
             <a:r>
-              <a:rPr sz="1700">
-                <a:solidFill>
-                  <a:srgbClr val="000000"/>
-                </a:solidFill>
-                <a:latin typeface="Calibri"/>
-              </a:rPr>
-              <a:t>The improvement is strict only when the constraint is binding. In Steps 7–9, several weights sit at the zero bound (e.g., VNQ in Steps 7 and 9); in Step 10, the optimizer exploits negative weights.</a:t>
+              <a:rPr sz="2000" b="0" i="0">
+                <a:solidFill>
+                  <a:srgbClr val="000000"/>
+                </a:solidFill>
+                <a:latin typeface="Calibri"/>
+              </a:rPr>
+              <a:t>The best tradeoff therefore improves or stays unchanged, holding other assumptions and costs fixed.</a:t>
             </a:r>
           </a:p>
         </p:txBody>
@@ -3277,14 +3296,14 @@
         </p:nvSpPr>
         <p:spPr>
           <a:xfrm>
-            <a:off x="8092440" y="1920240"/>
-            <a:ext cx="3547872" cy="2514600"/>
+            <a:off x="548640" y="4983480"/>
+            <a:ext cx="11091672" cy="914400"/>
           </a:xfrm>
           <a:prstGeom prst="rect">
             <a:avLst/>
           </a:prstGeom>
           <a:solidFill>
-            <a:srgbClr val="F2F2F2"/>
+            <a:srgbClr val="E9EEF4"/>
           </a:solidFill>
           <a:ln>
             <a:noFill/>
@@ -3306,102 +3325,27 @@
           </a:fontRef>
         </p:style>
         <p:txBody>
-          <a:bodyPr rtlCol="0" anchor="t" wrap="square" lIns="182880" rIns="182880" tIns="182880"/>
-          <a:lstStyle/>
-          <a:p>
-            <a:pPr algn="l">
-              <a:spcAft>
-                <a:spcPts val="1000"/>
-              </a:spcAft>
-            </a:pPr>
-            <a:r>
-              <a:rPr sz="1600" b="1">
-                <a:solidFill>
-                  <a:srgbClr val="000000"/>
-                </a:solidFill>
-                <a:latin typeface="Calibri"/>
-              </a:rPr>
-              <a:t>Formal statement</a:t>
-            </a:r>
-          </a:p>
-          <a:p>
-            <a:pPr>
-              <a:spcAft>
-                <a:spcPts val="600"/>
-              </a:spcAft>
-            </a:pPr>
-            <a:r>
-              <a:rPr sz="1500">
-                <a:solidFill>
-                  <a:srgbClr val="000000"/>
-                </a:solidFill>
-                <a:latin typeface="Cambria"/>
-              </a:rPr>
-              <a:t>F_NS = { w : Σwᵢ = 1,  wᵢ ≥ 0 }</a:t>
-            </a:r>
-          </a:p>
-          <a:p>
-            <a:pPr>
-              <a:spcAft>
-                <a:spcPts val="600"/>
-              </a:spcAft>
-            </a:pPr>
-            <a:r>
-              <a:rPr sz="1500">
-                <a:solidFill>
-                  <a:srgbClr val="000000"/>
-                </a:solidFill>
-                <a:latin typeface="Cambria"/>
-              </a:rPr>
-              <a:t>F_S  = { w : Σwᵢ = 1 }</a:t>
-            </a:r>
-          </a:p>
-          <a:p>
-            <a:pPr>
-              <a:spcAft>
-                <a:spcPts val="600"/>
-              </a:spcAft>
-            </a:pPr>
-            <a:r>
-              <a:rPr sz="1500">
-                <a:solidFill>
-                  <a:srgbClr val="000000"/>
-                </a:solidFill>
-                <a:latin typeface="Cambria"/>
-              </a:rPr>
-              <a:t>F_NS ⊆ F_S  ⇒</a:t>
-            </a:r>
-          </a:p>
-          <a:p>
-            <a:pPr>
-              <a:spcAft>
-                <a:spcPts val="600"/>
-              </a:spcAft>
-            </a:pPr>
-            <a:r>
-              <a:rPr sz="1500">
-                <a:solidFill>
-                  <a:srgbClr val="000000"/>
-                </a:solidFill>
-                <a:latin typeface="Cambria"/>
-              </a:rPr>
-              <a:t>min σp(m | F_S) ≤ min σp(m | F_NS)</a:t>
-            </a:r>
-          </a:p>
-          <a:p>
-            <a:pPr>
-              <a:spcAft>
-                <a:spcPts val="600"/>
-              </a:spcAft>
-            </a:pPr>
-            <a:r>
-              <a:rPr sz="1500">
-                <a:solidFill>
-                  <a:srgbClr val="000000"/>
-                </a:solidFill>
-                <a:latin typeface="Cambria"/>
-              </a:rPr>
-              <a:t>max Sp(F_S) ≥ max Sp(F_NS)</a:t>
+          <a:bodyPr rtlCol="0" anchor="ctr" wrap="square" lIns="228600" rIns="228600"/>
+          <a:lstStyle/>
+          <a:p>
+            <a:pPr algn="l"/>
+            <a:r>
+              <a:rPr sz="2000" b="1" i="0">
+                <a:solidFill>
+                  <a:srgbClr val="1F3A5F"/>
+                </a:solidFill>
+                <a:latin typeface="Calibri"/>
+              </a:rPr>
+              <a:t>Takeaway: </a:t>
+            </a:r>
+            <a:r>
+              <a:rPr sz="2000" b="0" i="0">
+                <a:solidFill>
+                  <a:srgbClr val="000000"/>
+                </a:solidFill>
+                <a:latin typeface="Calibri"/>
+              </a:rPr>
+              <a:t>More choices cannot worsen the best available choice.</a:t>
             </a:r>
           </a:p>
         </p:txBody>
@@ -3415,7 +3359,7 @@
         <p:spPr>
           <a:xfrm>
             <a:off x="548640" y="6263640"/>
-            <a:ext cx="8229600" cy="411480"/>
+            <a:ext cx="6400800" cy="411480"/>
           </a:xfrm>
           <a:prstGeom prst="rect">
             <a:avLst/>
@@ -3431,7 +3375,7 @@
             <a:r>
               <a:rPr sz="1400" b="0" i="0">
                 <a:solidFill>
-                  <a:srgbClr val="000000"/>
+                  <a:srgbClr val="595959"/>
                 </a:solidFill>
                 <a:latin typeface="Calibri"/>
               </a:rPr>
@@ -3448,8 +3392,8 @@
         </p:nvSpPr>
         <p:spPr>
           <a:xfrm>
-            <a:off x="9326880" y="6263640"/>
-            <a:ext cx="2313432" cy="411480"/>
+            <a:off x="7040880" y="6263640"/>
+            <a:ext cx="4599432" cy="411480"/>
           </a:xfrm>
           <a:prstGeom prst="rect">
             <a:avLst/>
@@ -3466,11 +3410,1521 @@
             <a:r>
               <a:rPr sz="1400" b="0" i="0">
                 <a:solidFill>
-                  <a:srgbClr val="000000"/>
-                </a:solidFill>
-                <a:latin typeface="Calibri"/>
-              </a:rPr>
-              <a:t>Row 124</a:t>
+                  <a:srgbClr val="595959"/>
+                </a:solidFill>
+                <a:latin typeface="Calibri"/>
+              </a:rPr>
+              <a:t>Cells A124</a:t>
+            </a:r>
+          </a:p>
+        </p:txBody>
+      </p:sp>
+    </p:spTree>
+  </p:cSld>
+  <p:clrMapOvr>
+    <a:masterClrMapping/>
+  </p:clrMapOvr>
+</p:sld>
+</file>
+
+<file path=ppt/slides/slide10.xml><?xml version="1.0" encoding="utf-8"?>
+<p:sld xmlns:a="http://schemas.openxmlformats.org/drawingml/2006/main" xmlns:p="http://schemas.openxmlformats.org/presentationml/2006/main" xmlns:r="http://schemas.openxmlformats.org/officeDocument/2006/relationships">
+  <p:cSld>
+    <p:spTree>
+      <p:nvGrpSpPr>
+        <p:cNvPr id="1" name=""/>
+        <p:cNvGrpSpPr/>
+        <p:nvPr/>
+      </p:nvGrpSpPr>
+      <p:grpSpPr/>
+      <p:sp>
+        <p:nvSpPr>
+          <p:cNvPr id="2" name="TextBox 1"/>
+          <p:cNvSpPr txBox="1"/>
+          <p:nvPr/>
+        </p:nvSpPr>
+        <p:spPr>
+          <a:xfrm>
+            <a:off x="548640" y="274320"/>
+            <a:ext cx="11091672" cy="365760"/>
+          </a:xfrm>
+          <a:prstGeom prst="rect">
+            <a:avLst/>
+          </a:prstGeom>
+          <a:noFill/>
+        </p:spPr>
+        <p:txBody>
+          <a:bodyPr wrap="square">
+            <a:spAutoFit/>
+          </a:bodyPr>
+          <a:lstStyle/>
+          <a:p>
+            <a:r>
+              <a:rPr sz="1600" b="0" i="0">
+                <a:solidFill>
+                  <a:srgbClr val="595959"/>
+                </a:solidFill>
+                <a:latin typeface="Calibri"/>
+              </a:rPr>
+              <a:t>Question 10</a:t>
+            </a:r>
+          </a:p>
+        </p:txBody>
+      </p:sp>
+      <p:sp>
+        <p:nvSpPr>
+          <p:cNvPr id="3" name="TextBox 2"/>
+          <p:cNvSpPr txBox="1"/>
+          <p:nvPr/>
+        </p:nvSpPr>
+        <p:spPr>
+          <a:xfrm>
+            <a:off x="548640" y="594360"/>
+            <a:ext cx="11091672" cy="640080"/>
+          </a:xfrm>
+          <a:prstGeom prst="rect">
+            <a:avLst/>
+          </a:prstGeom>
+          <a:noFill/>
+        </p:spPr>
+        <p:txBody>
+          <a:bodyPr wrap="square">
+            <a:spAutoFit/>
+          </a:bodyPr>
+          <a:lstStyle/>
+          <a:p>
+            <a:r>
+              <a:rPr sz="3000" b="1" i="0">
+                <a:solidFill>
+                  <a:srgbClr val="000000"/>
+                </a:solidFill>
+                <a:latin typeface="Calibri"/>
+              </a:rPr>
+              <a:t>Does Minimum Variance Mean Maximum Sharpe?</a:t>
+            </a:r>
+          </a:p>
+        </p:txBody>
+      </p:sp>
+      <p:sp>
+        <p:nvSpPr>
+          <p:cNvPr id="4" name="TextBox 3"/>
+          <p:cNvSpPr txBox="1"/>
+          <p:nvPr/>
+        </p:nvSpPr>
+        <p:spPr>
+          <a:xfrm>
+            <a:off x="548640" y="1280160"/>
+            <a:ext cx="11091672" cy="457200"/>
+          </a:xfrm>
+          <a:prstGeom prst="rect">
+            <a:avLst/>
+          </a:prstGeom>
+          <a:noFill/>
+        </p:spPr>
+        <p:txBody>
+          <a:bodyPr wrap="square">
+            <a:spAutoFit/>
+          </a:bodyPr>
+          <a:lstStyle/>
+          <a:p>
+            <a:r>
+              <a:rPr sz="2000" b="1" i="0">
+                <a:solidFill>
+                  <a:srgbClr val="1F3A5F"/>
+                </a:solidFill>
+                <a:latin typeface="Calibri"/>
+              </a:rPr>
+              <a:t>Answer: </a:t>
+            </a:r>
+            <a:r>
+              <a:rPr sz="2000" b="0" i="0">
+                <a:solidFill>
+                  <a:srgbClr val="1F3A5F"/>
+                </a:solidFill>
+                <a:latin typeface="Calibri"/>
+              </a:rPr>
+              <a:t>False — these are different objectives.</a:t>
+            </a:r>
+          </a:p>
+        </p:txBody>
+      </p:sp>
+      <p:sp>
+        <p:nvSpPr>
+          <p:cNvPr id="5" name="TextBox 4"/>
+          <p:cNvSpPr txBox="1"/>
+          <p:nvPr/>
+        </p:nvSpPr>
+        <p:spPr>
+          <a:xfrm>
+            <a:off x="548640" y="2011680"/>
+            <a:ext cx="11091672" cy="2743200"/>
+          </a:xfrm>
+          <a:prstGeom prst="rect">
+            <a:avLst/>
+          </a:prstGeom>
+          <a:noFill/>
+        </p:spPr>
+        <p:txBody>
+          <a:bodyPr wrap="square">
+            <a:spAutoFit/>
+          </a:bodyPr>
+          <a:lstStyle/>
+          <a:p>
+            <a:pPr marL="274320" indent="-274320">
+              <a:spcAft>
+                <a:spcPts val="1400"/>
+              </a:spcAft>
+              <a:buFont typeface="Arial"/>
+              <a:buChar char="•"/>
+            </a:pPr>
+            <a:r>
+              <a:rPr sz="2000" b="0" i="0">
+                <a:solidFill>
+                  <a:srgbClr val="000000"/>
+                </a:solidFill>
+                <a:latin typeface="Calibri"/>
+              </a:rPr>
+              <a:t>The global minimum-variance portfolio minimizes volatility across feasible portfolios.</a:t>
+            </a:r>
+          </a:p>
+          <a:p>
+            <a:pPr marL="274320" indent="-274320">
+              <a:spcAft>
+                <a:spcPts val="1400"/>
+              </a:spcAft>
+              <a:buFont typeface="Arial"/>
+              <a:buChar char="•"/>
+            </a:pPr>
+            <a:r>
+              <a:rPr sz="2000" b="0" i="0">
+                <a:solidFill>
+                  <a:srgbClr val="000000"/>
+                </a:solidFill>
+                <a:latin typeface="Calibri"/>
+              </a:rPr>
+              <a:t>The maximum Sharpe portfolio maximizes </a:t>
+            </a:r>
+            <a:r>
+              <a:rPr sz="2000" b="1" i="0">
+                <a:solidFill>
+                  <a:srgbClr val="000000"/>
+                </a:solidFill>
+                <a:latin typeface="Calibri"/>
+              </a:rPr>
+              <a:t>expected excess return divided by volatility</a:t>
+            </a:r>
+            <a:r>
+              <a:rPr sz="2000" b="0" i="0">
+                <a:solidFill>
+                  <a:srgbClr val="000000"/>
+                </a:solidFill>
+                <a:latin typeface="Calibri"/>
+              </a:rPr>
+              <a:t>.</a:t>
+            </a:r>
+          </a:p>
+          <a:p>
+            <a:pPr marL="274320" indent="-274320">
+              <a:spcAft>
+                <a:spcPts val="1400"/>
+              </a:spcAft>
+              <a:buFont typeface="Arial"/>
+              <a:buChar char="•"/>
+            </a:pPr>
+            <a:r>
+              <a:rPr sz="2000" b="0" i="0">
+                <a:solidFill>
+                  <a:srgbClr val="000000"/>
+                </a:solidFill>
+                <a:latin typeface="Calibri"/>
+              </a:rPr>
+              <a:t>A lower-volatility portfolio can have a lower Sharpe ratio if its excess return is too small (Step 8: E[R</a:t>
+            </a:r>
+            <a:r>
+              <a:rPr sz="2000" b="0" i="0" baseline="-25000">
+                <a:solidFill>
+                  <a:srgbClr val="000000"/>
+                </a:solidFill>
+                <a:latin typeface="Calibri"/>
+              </a:rPr>
+              <a:t>p</a:t>
+            </a:r>
+            <a:r>
+              <a:rPr sz="2000" b="0" i="0">
+                <a:solidFill>
+                  <a:srgbClr val="000000"/>
+                </a:solidFill>
+                <a:latin typeface="Calibri"/>
+              </a:rPr>
+              <a:t>] = 1.10% &lt; R</a:t>
+            </a:r>
+            <a:r>
+              <a:rPr sz="2000" b="0" i="0" baseline="-25000">
+                <a:solidFill>
+                  <a:srgbClr val="000000"/>
+                </a:solidFill>
+                <a:latin typeface="Calibri"/>
+              </a:rPr>
+              <a:t>f</a:t>
+            </a:r>
+            <a:r>
+              <a:rPr sz="2000" b="0" i="0">
+                <a:solidFill>
+                  <a:srgbClr val="000000"/>
+                </a:solidFill>
+                <a:latin typeface="Calibri"/>
+              </a:rPr>
+              <a:t> = 3%, Sharpe ≈ −0.30; Step 9: Sharpe ≈ 1.15).</a:t>
+            </a:r>
+          </a:p>
+        </p:txBody>
+      </p:sp>
+      <p:sp>
+        <p:nvSpPr>
+          <p:cNvPr id="6" name="Rectangle 5"/>
+          <p:cNvSpPr/>
+          <p:nvPr/>
+        </p:nvSpPr>
+        <p:spPr>
+          <a:xfrm>
+            <a:off x="548640" y="4983480"/>
+            <a:ext cx="11091672" cy="914400"/>
+          </a:xfrm>
+          <a:prstGeom prst="rect">
+            <a:avLst/>
+          </a:prstGeom>
+          <a:solidFill>
+            <a:srgbClr val="E9EEF4"/>
+          </a:solidFill>
+          <a:ln>
+            <a:noFill/>
+          </a:ln>
+          <a:effectLst/>
+        </p:spPr>
+        <p:style>
+          <a:lnRef idx="1">
+            <a:schemeClr val="accent1"/>
+          </a:lnRef>
+          <a:fillRef idx="3">
+            <a:schemeClr val="accent1"/>
+          </a:fillRef>
+          <a:effectRef idx="2">
+            <a:schemeClr val="accent1"/>
+          </a:effectRef>
+          <a:fontRef idx="minor">
+            <a:schemeClr val="lt1"/>
+          </a:fontRef>
+        </p:style>
+        <p:txBody>
+          <a:bodyPr rtlCol="0" anchor="ctr" wrap="square" lIns="228600" rIns="228600"/>
+          <a:lstStyle/>
+          <a:p>
+            <a:pPr algn="l"/>
+            <a:r>
+              <a:rPr sz="2000" b="1" i="0">
+                <a:solidFill>
+                  <a:srgbClr val="1F3A5F"/>
+                </a:solidFill>
+                <a:latin typeface="Calibri"/>
+              </a:rPr>
+              <a:t>Takeaway: </a:t>
+            </a:r>
+            <a:r>
+              <a:rPr sz="2000" b="0" i="0">
+                <a:solidFill>
+                  <a:srgbClr val="000000"/>
+                </a:solidFill>
+                <a:latin typeface="Calibri"/>
+              </a:rPr>
+              <a:t>Lowest risk does not necessarily mean best risk-adjusted return.</a:t>
+            </a:r>
+          </a:p>
+        </p:txBody>
+      </p:sp>
+      <p:sp>
+        <p:nvSpPr>
+          <p:cNvPr id="7" name="TextBox 6"/>
+          <p:cNvSpPr txBox="1"/>
+          <p:nvPr/>
+        </p:nvSpPr>
+        <p:spPr>
+          <a:xfrm>
+            <a:off x="548640" y="6263640"/>
+            <a:ext cx="6400800" cy="411480"/>
+          </a:xfrm>
+          <a:prstGeom prst="rect">
+            <a:avLst/>
+          </a:prstGeom>
+          <a:noFill/>
+        </p:spPr>
+        <p:txBody>
+          <a:bodyPr wrap="square">
+            <a:spAutoFit/>
+          </a:bodyPr>
+          <a:lstStyle/>
+          <a:p>
+            <a:r>
+              <a:rPr sz="1400" b="0" i="0">
+                <a:solidFill>
+                  <a:srgbClr val="595959"/>
+                </a:solidFill>
+                <a:latin typeface="Calibri"/>
+              </a:rPr>
+              <a:t>Sheet: Sec 3A - 5-Stock Demo</a:t>
+            </a:r>
+          </a:p>
+        </p:txBody>
+      </p:sp>
+      <p:sp>
+        <p:nvSpPr>
+          <p:cNvPr id="8" name="TextBox 7"/>
+          <p:cNvSpPr txBox="1"/>
+          <p:nvPr/>
+        </p:nvSpPr>
+        <p:spPr>
+          <a:xfrm>
+            <a:off x="7040880" y="6263640"/>
+            <a:ext cx="4599432" cy="411480"/>
+          </a:xfrm>
+          <a:prstGeom prst="rect">
+            <a:avLst/>
+          </a:prstGeom>
+          <a:noFill/>
+        </p:spPr>
+        <p:txBody>
+          <a:bodyPr wrap="square">
+            <a:spAutoFit/>
+          </a:bodyPr>
+          <a:lstStyle/>
+          <a:p>
+            <a:pPr algn="r"/>
+            <a:r>
+              <a:rPr sz="1400" b="0" i="0">
+                <a:solidFill>
+                  <a:srgbClr val="595959"/>
+                </a:solidFill>
+                <a:latin typeface="Calibri"/>
+              </a:rPr>
+              <a:t>Cells A197</a:t>
+            </a:r>
+          </a:p>
+        </p:txBody>
+      </p:sp>
+    </p:spTree>
+  </p:cSld>
+  <p:clrMapOvr>
+    <a:masterClrMapping/>
+  </p:clrMapOvr>
+</p:sld>
+</file>
+
+<file path=ppt/slides/slide11.xml><?xml version="1.0" encoding="utf-8"?>
+<p:sld xmlns:a="http://schemas.openxmlformats.org/drawingml/2006/main" xmlns:p="http://schemas.openxmlformats.org/presentationml/2006/main" xmlns:r="http://schemas.openxmlformats.org/officeDocument/2006/relationships">
+  <p:cSld>
+    <p:spTree>
+      <p:nvGrpSpPr>
+        <p:cNvPr id="1" name=""/>
+        <p:cNvGrpSpPr/>
+        <p:nvPr/>
+      </p:nvGrpSpPr>
+      <p:grpSpPr/>
+      <p:sp>
+        <p:nvSpPr>
+          <p:cNvPr id="2" name="TextBox 1"/>
+          <p:cNvSpPr txBox="1"/>
+          <p:nvPr/>
+        </p:nvSpPr>
+        <p:spPr>
+          <a:xfrm>
+            <a:off x="548640" y="274320"/>
+            <a:ext cx="11091672" cy="365760"/>
+          </a:xfrm>
+          <a:prstGeom prst="rect">
+            <a:avLst/>
+          </a:prstGeom>
+          <a:noFill/>
+        </p:spPr>
+        <p:txBody>
+          <a:bodyPr wrap="square">
+            <a:spAutoFit/>
+          </a:bodyPr>
+          <a:lstStyle/>
+          <a:p>
+            <a:r>
+              <a:rPr sz="1600" b="0" i="0">
+                <a:solidFill>
+                  <a:srgbClr val="595959"/>
+                </a:solidFill>
+                <a:latin typeface="Calibri"/>
+              </a:rPr>
+              <a:t>Question 11</a:t>
+            </a:r>
+          </a:p>
+        </p:txBody>
+      </p:sp>
+      <p:sp>
+        <p:nvSpPr>
+          <p:cNvPr id="3" name="TextBox 2"/>
+          <p:cNvSpPr txBox="1"/>
+          <p:nvPr/>
+        </p:nvSpPr>
+        <p:spPr>
+          <a:xfrm>
+            <a:off x="548640" y="594360"/>
+            <a:ext cx="11091672" cy="640080"/>
+          </a:xfrm>
+          <a:prstGeom prst="rect">
+            <a:avLst/>
+          </a:prstGeom>
+          <a:noFill/>
+        </p:spPr>
+        <p:txBody>
+          <a:bodyPr wrap="square">
+            <a:spAutoFit/>
+          </a:bodyPr>
+          <a:lstStyle/>
+          <a:p>
+            <a:r>
+              <a:rPr sz="3000" b="1" i="0">
+                <a:solidFill>
+                  <a:srgbClr val="000000"/>
+                </a:solidFill>
+                <a:latin typeface="Calibri"/>
+              </a:rPr>
+              <a:t>What Does a −119% VNQ Weight Mean?</a:t>
+            </a:r>
+          </a:p>
+        </p:txBody>
+      </p:sp>
+      <p:sp>
+        <p:nvSpPr>
+          <p:cNvPr id="4" name="TextBox 3"/>
+          <p:cNvSpPr txBox="1"/>
+          <p:nvPr/>
+        </p:nvSpPr>
+        <p:spPr>
+          <a:xfrm>
+            <a:off x="548640" y="1280160"/>
+            <a:ext cx="11091672" cy="457200"/>
+          </a:xfrm>
+          <a:prstGeom prst="rect">
+            <a:avLst/>
+          </a:prstGeom>
+          <a:noFill/>
+        </p:spPr>
+        <p:txBody>
+          <a:bodyPr wrap="square">
+            <a:spAutoFit/>
+          </a:bodyPr>
+          <a:lstStyle/>
+          <a:p>
+            <a:r>
+              <a:rPr sz="2000" b="1" i="0">
+                <a:solidFill>
+                  <a:srgbClr val="1F3A5F"/>
+                </a:solidFill>
+                <a:latin typeface="Calibri"/>
+              </a:rPr>
+              <a:t>Answer: </a:t>
+            </a:r>
+            <a:r>
+              <a:rPr sz="2000" b="0" i="0">
+                <a:solidFill>
+                  <a:srgbClr val="1F3A5F"/>
+                </a:solidFill>
+                <a:latin typeface="Calibri"/>
+              </a:rPr>
+              <a:t>True — the short position equals approximately 119% of net portfolio value.</a:t>
+            </a:r>
+          </a:p>
+        </p:txBody>
+      </p:sp>
+      <p:sp>
+        <p:nvSpPr>
+          <p:cNvPr id="5" name="TextBox 4"/>
+          <p:cNvSpPr txBox="1"/>
+          <p:nvPr/>
+        </p:nvSpPr>
+        <p:spPr>
+          <a:xfrm>
+            <a:off x="548640" y="2011680"/>
+            <a:ext cx="11091672" cy="2743200"/>
+          </a:xfrm>
+          <a:prstGeom prst="rect">
+            <a:avLst/>
+          </a:prstGeom>
+          <a:noFill/>
+        </p:spPr>
+        <p:txBody>
+          <a:bodyPr wrap="square">
+            <a:spAutoFit/>
+          </a:bodyPr>
+          <a:lstStyle/>
+          <a:p>
+            <a:pPr marL="274320" indent="-274320">
+              <a:spcAft>
+                <a:spcPts val="1400"/>
+              </a:spcAft>
+              <a:buFont typeface="Arial"/>
+              <a:buChar char="•"/>
+            </a:pPr>
+            <a:r>
+              <a:rPr sz="2000" b="0" i="0">
+                <a:solidFill>
+                  <a:srgbClr val="000000"/>
+                </a:solidFill>
+                <a:latin typeface="Calibri"/>
+              </a:rPr>
+              <a:t>With </a:t>
+            </a:r>
+            <a:r>
+              <a:rPr sz="2000" b="1" i="0">
+                <a:solidFill>
+                  <a:srgbClr val="000000"/>
+                </a:solidFill>
+                <a:latin typeface="Calibri"/>
+              </a:rPr>
+              <a:t>$100 of net portfolio value</a:t>
+            </a:r>
+            <a:r>
+              <a:rPr sz="2000" b="0" i="0">
+                <a:solidFill>
+                  <a:srgbClr val="000000"/>
+                </a:solidFill>
+                <a:latin typeface="Calibri"/>
+              </a:rPr>
+              <a:t>, a −119% weight represents approximately </a:t>
+            </a:r>
+            <a:r>
+              <a:rPr sz="2000" b="1" i="0">
+                <a:solidFill>
+                  <a:srgbClr val="000000"/>
+                </a:solidFill>
+                <a:latin typeface="Calibri"/>
+              </a:rPr>
+              <a:t>$119 of VNQ sold short</a:t>
+            </a:r>
+            <a:r>
+              <a:rPr sz="2000" b="0" i="0">
+                <a:solidFill>
+                  <a:srgbClr val="000000"/>
+                </a:solidFill>
+                <a:latin typeface="Calibri"/>
+              </a:rPr>
+              <a:t>.</a:t>
+            </a:r>
+          </a:p>
+          <a:p>
+            <a:pPr marL="274320" indent="-274320">
+              <a:spcAft>
+                <a:spcPts val="1400"/>
+              </a:spcAft>
+              <a:buFont typeface="Arial"/>
+              <a:buChar char="•"/>
+            </a:pPr>
+            <a:r>
+              <a:rPr sz="2000" b="0" i="0">
+                <a:solidFill>
+                  <a:srgbClr val="000000"/>
+                </a:solidFill>
+                <a:latin typeface="Calibri"/>
+              </a:rPr>
+              <a:t>In the model, short-sale proceeds help finance long positions greater than net capital.</a:t>
+            </a:r>
+          </a:p>
+          <a:p>
+            <a:pPr marL="274320" indent="-274320">
+              <a:spcAft>
+                <a:spcPts val="1400"/>
+              </a:spcAft>
+              <a:buFont typeface="Arial"/>
+              <a:buChar char="•"/>
+            </a:pPr>
+            <a:r>
+              <a:rPr sz="2000" b="0" i="0">
+                <a:solidFill>
+                  <a:srgbClr val="000000"/>
+                </a:solidFill>
+                <a:latin typeface="Calibri"/>
+              </a:rPr>
+              <a:t>Weights can sum to 100% even when </a:t>
+            </a:r>
+            <a:r>
+              <a:rPr sz="2000" b="1" i="0">
+                <a:solidFill>
+                  <a:srgbClr val="000000"/>
+                </a:solidFill>
+                <a:latin typeface="Calibri"/>
+              </a:rPr>
+              <a:t>gross exposure</a:t>
+            </a:r>
+            <a:r>
+              <a:rPr sz="2000" b="0" i="0">
+                <a:solidFill>
+                  <a:srgbClr val="000000"/>
+                </a:solidFill>
+                <a:latin typeface="Calibri"/>
+              </a:rPr>
+              <a:t>, the sum of absolute weights, exceeds 100% (Step 10: ≈ 557%).</a:t>
+            </a:r>
+          </a:p>
+        </p:txBody>
+      </p:sp>
+      <p:sp>
+        <p:nvSpPr>
+          <p:cNvPr id="6" name="Rectangle 5"/>
+          <p:cNvSpPr/>
+          <p:nvPr/>
+        </p:nvSpPr>
+        <p:spPr>
+          <a:xfrm>
+            <a:off x="548640" y="4983480"/>
+            <a:ext cx="11091672" cy="914400"/>
+          </a:xfrm>
+          <a:prstGeom prst="rect">
+            <a:avLst/>
+          </a:prstGeom>
+          <a:solidFill>
+            <a:srgbClr val="E9EEF4"/>
+          </a:solidFill>
+          <a:ln>
+            <a:noFill/>
+          </a:ln>
+          <a:effectLst/>
+        </p:spPr>
+        <p:style>
+          <a:lnRef idx="1">
+            <a:schemeClr val="accent1"/>
+          </a:lnRef>
+          <a:fillRef idx="3">
+            <a:schemeClr val="accent1"/>
+          </a:fillRef>
+          <a:effectRef idx="2">
+            <a:schemeClr val="accent1"/>
+          </a:effectRef>
+          <a:fontRef idx="minor">
+            <a:schemeClr val="lt1"/>
+          </a:fontRef>
+        </p:style>
+        <p:txBody>
+          <a:bodyPr rtlCol="0" anchor="ctr" wrap="square" lIns="228600" rIns="228600"/>
+          <a:lstStyle/>
+          <a:p>
+            <a:pPr algn="l"/>
+            <a:r>
+              <a:rPr sz="2000" b="1" i="0">
+                <a:solidFill>
+                  <a:srgbClr val="1F3A5F"/>
+                </a:solidFill>
+                <a:latin typeface="Calibri"/>
+              </a:rPr>
+              <a:t>Takeaway: </a:t>
+            </a:r>
+            <a:r>
+              <a:rPr sz="2000" b="0" i="0">
+                <a:solidFill>
+                  <a:srgbClr val="000000"/>
+                </a:solidFill>
+                <a:latin typeface="Calibri"/>
+              </a:rPr>
+              <a:t>A fully invested portfolio can still be highly leveraged.</a:t>
+            </a:r>
+          </a:p>
+        </p:txBody>
+      </p:sp>
+      <p:sp>
+        <p:nvSpPr>
+          <p:cNvPr id="7" name="TextBox 6"/>
+          <p:cNvSpPr txBox="1"/>
+          <p:nvPr/>
+        </p:nvSpPr>
+        <p:spPr>
+          <a:xfrm>
+            <a:off x="548640" y="6263640"/>
+            <a:ext cx="6400800" cy="411480"/>
+          </a:xfrm>
+          <a:prstGeom prst="rect">
+            <a:avLst/>
+          </a:prstGeom>
+          <a:noFill/>
+        </p:spPr>
+        <p:txBody>
+          <a:bodyPr wrap="square">
+            <a:spAutoFit/>
+          </a:bodyPr>
+          <a:lstStyle/>
+          <a:p>
+            <a:r>
+              <a:rPr sz="1400" b="0" i="0">
+                <a:solidFill>
+                  <a:srgbClr val="595959"/>
+                </a:solidFill>
+                <a:latin typeface="Calibri"/>
+              </a:rPr>
+              <a:t>Sheet: Sec 3A - 5-Stock Demo</a:t>
+            </a:r>
+          </a:p>
+        </p:txBody>
+      </p:sp>
+      <p:sp>
+        <p:nvSpPr>
+          <p:cNvPr id="8" name="TextBox 7"/>
+          <p:cNvSpPr txBox="1"/>
+          <p:nvPr/>
+        </p:nvSpPr>
+        <p:spPr>
+          <a:xfrm>
+            <a:off x="7040880" y="6263640"/>
+            <a:ext cx="4599432" cy="411480"/>
+          </a:xfrm>
+          <a:prstGeom prst="rect">
+            <a:avLst/>
+          </a:prstGeom>
+          <a:noFill/>
+        </p:spPr>
+        <p:txBody>
+          <a:bodyPr wrap="square">
+            <a:spAutoFit/>
+          </a:bodyPr>
+          <a:lstStyle/>
+          <a:p>
+            <a:pPr algn="r"/>
+            <a:r>
+              <a:rPr sz="1400" b="0" i="0">
+                <a:solidFill>
+                  <a:srgbClr val="595959"/>
+                </a:solidFill>
+                <a:latin typeface="Calibri"/>
+              </a:rPr>
+              <a:t>Cells A200</a:t>
+            </a:r>
+          </a:p>
+        </p:txBody>
+      </p:sp>
+    </p:spTree>
+  </p:cSld>
+  <p:clrMapOvr>
+    <a:masterClrMapping/>
+  </p:clrMapOvr>
+</p:sld>
+</file>
+
+<file path=ppt/slides/slide12.xml><?xml version="1.0" encoding="utf-8"?>
+<p:sld xmlns:a="http://schemas.openxmlformats.org/drawingml/2006/main" xmlns:p="http://schemas.openxmlformats.org/presentationml/2006/main" xmlns:r="http://schemas.openxmlformats.org/officeDocument/2006/relationships">
+  <p:cSld>
+    <p:spTree>
+      <p:nvGrpSpPr>
+        <p:cNvPr id="1" name=""/>
+        <p:cNvGrpSpPr/>
+        <p:nvPr/>
+      </p:nvGrpSpPr>
+      <p:grpSpPr/>
+      <p:sp>
+        <p:nvSpPr>
+          <p:cNvPr id="2" name="TextBox 1"/>
+          <p:cNvSpPr txBox="1"/>
+          <p:nvPr/>
+        </p:nvSpPr>
+        <p:spPr>
+          <a:xfrm>
+            <a:off x="548640" y="274320"/>
+            <a:ext cx="11091672" cy="365760"/>
+          </a:xfrm>
+          <a:prstGeom prst="rect">
+            <a:avLst/>
+          </a:prstGeom>
+          <a:noFill/>
+        </p:spPr>
+        <p:txBody>
+          <a:bodyPr wrap="square">
+            <a:spAutoFit/>
+          </a:bodyPr>
+          <a:lstStyle/>
+          <a:p>
+            <a:r>
+              <a:rPr sz="1600" b="0" i="0">
+                <a:solidFill>
+                  <a:srgbClr val="595959"/>
+                </a:solidFill>
+                <a:latin typeface="Calibri"/>
+              </a:rPr>
+              <a:t>Question 12</a:t>
+            </a:r>
+          </a:p>
+        </p:txBody>
+      </p:sp>
+      <p:sp>
+        <p:nvSpPr>
+          <p:cNvPr id="3" name="TextBox 2"/>
+          <p:cNvSpPr txBox="1"/>
+          <p:nvPr/>
+        </p:nvSpPr>
+        <p:spPr>
+          <a:xfrm>
+            <a:off x="548640" y="594360"/>
+            <a:ext cx="11091672" cy="640080"/>
+          </a:xfrm>
+          <a:prstGeom prst="rect">
+            <a:avLst/>
+          </a:prstGeom>
+          <a:noFill/>
+        </p:spPr>
+        <p:txBody>
+          <a:bodyPr wrap="square">
+            <a:spAutoFit/>
+          </a:bodyPr>
+          <a:lstStyle/>
+          <a:p>
+            <a:r>
+              <a:rPr sz="3000" b="1" i="0">
+                <a:solidFill>
+                  <a:srgbClr val="000000"/>
+                </a:solidFill>
+                <a:latin typeface="Calibri"/>
+              </a:rPr>
+              <a:t>What Happens When Risk Aversion Rises?</a:t>
+            </a:r>
+          </a:p>
+        </p:txBody>
+      </p:sp>
+      <p:sp>
+        <p:nvSpPr>
+          <p:cNvPr id="4" name="TextBox 3"/>
+          <p:cNvSpPr txBox="1"/>
+          <p:nvPr/>
+        </p:nvSpPr>
+        <p:spPr>
+          <a:xfrm>
+            <a:off x="548640" y="1280160"/>
+            <a:ext cx="11091672" cy="457200"/>
+          </a:xfrm>
+          <a:prstGeom prst="rect">
+            <a:avLst/>
+          </a:prstGeom>
+          <a:noFill/>
+        </p:spPr>
+        <p:txBody>
+          <a:bodyPr wrap="square">
+            <a:spAutoFit/>
+          </a:bodyPr>
+          <a:lstStyle/>
+          <a:p>
+            <a:r>
+              <a:rPr sz="2000" b="1" i="0">
+                <a:solidFill>
+                  <a:srgbClr val="1F3A5F"/>
+                </a:solidFill>
+                <a:latin typeface="Calibri"/>
+              </a:rPr>
+              <a:t>Answer: </a:t>
+            </a:r>
+            <a:r>
+              <a:rPr sz="2000" b="0" i="0">
+                <a:solidFill>
+                  <a:srgbClr val="1F3A5F"/>
+                </a:solidFill>
+                <a:latin typeface="Calibri"/>
+              </a:rPr>
+              <a:t>B — optimized portfolio variance generally falls.</a:t>
+            </a:r>
+          </a:p>
+        </p:txBody>
+      </p:sp>
+      <p:sp>
+        <p:nvSpPr>
+          <p:cNvPr id="5" name="TextBox 4"/>
+          <p:cNvSpPr txBox="1"/>
+          <p:nvPr/>
+        </p:nvSpPr>
+        <p:spPr>
+          <a:xfrm>
+            <a:off x="548640" y="2011680"/>
+            <a:ext cx="11091672" cy="2743200"/>
+          </a:xfrm>
+          <a:prstGeom prst="rect">
+            <a:avLst/>
+          </a:prstGeom>
+          <a:noFill/>
+        </p:spPr>
+        <p:txBody>
+          <a:bodyPr wrap="square">
+            <a:spAutoFit/>
+          </a:bodyPr>
+          <a:lstStyle/>
+          <a:p>
+            <a:pPr marL="274320" indent="-274320">
+              <a:spcAft>
+                <a:spcPts val="1400"/>
+              </a:spcAft>
+              <a:buFont typeface="Arial"/>
+              <a:buChar char="•"/>
+            </a:pPr>
+            <a:r>
+              <a:rPr sz="2000" b="0" i="0">
+                <a:solidFill>
+                  <a:srgbClr val="000000"/>
+                </a:solidFill>
+                <a:latin typeface="Calibri"/>
+              </a:rPr>
+              <a:t>The worksheet maximizes </a:t>
+            </a:r>
+            <a:r>
+              <a:rPr sz="2000" b="1" i="0">
+                <a:solidFill>
+                  <a:srgbClr val="000000"/>
+                </a:solidFill>
+                <a:latin typeface="Calibri"/>
+              </a:rPr>
+              <a:t>U = E[R</a:t>
+            </a:r>
+            <a:r>
+              <a:rPr sz="2000" b="1" i="0" baseline="-25000">
+                <a:solidFill>
+                  <a:srgbClr val="000000"/>
+                </a:solidFill>
+                <a:latin typeface="Calibri"/>
+              </a:rPr>
+              <a:t>p</a:t>
+            </a:r>
+            <a:r>
+              <a:rPr sz="2000" b="1" i="0">
+                <a:solidFill>
+                  <a:srgbClr val="000000"/>
+                </a:solidFill>
+                <a:latin typeface="Calibri"/>
+              </a:rPr>
+              <a:t>] − (A/2)σ</a:t>
+            </a:r>
+            <a:r>
+              <a:rPr sz="2000" b="1" i="0" baseline="-25000">
+                <a:solidFill>
+                  <a:srgbClr val="000000"/>
+                </a:solidFill>
+                <a:latin typeface="Calibri"/>
+              </a:rPr>
+              <a:t>p</a:t>
+            </a:r>
+            <a:r>
+              <a:rPr sz="2000" b="1" i="0">
+                <a:solidFill>
+                  <a:srgbClr val="000000"/>
+                </a:solidFill>
+                <a:latin typeface="Calibri"/>
+              </a:rPr>
+              <a:t>²/100</a:t>
+            </a:r>
+            <a:r>
+              <a:rPr sz="2000" b="0" i="0">
+                <a:solidFill>
+                  <a:srgbClr val="000000"/>
+                </a:solidFill>
+                <a:latin typeface="Calibri"/>
+              </a:rPr>
+              <a:t>, using percentage-point returns.</a:t>
+            </a:r>
+          </a:p>
+          <a:p>
+            <a:pPr marL="274320" indent="-274320">
+              <a:spcAft>
+                <a:spcPts val="1400"/>
+              </a:spcAft>
+              <a:buFont typeface="Arial"/>
+              <a:buChar char="•"/>
+            </a:pPr>
+            <a:r>
+              <a:rPr sz="2000" b="0" i="0">
+                <a:solidFill>
+                  <a:srgbClr val="000000"/>
+                </a:solidFill>
+                <a:latin typeface="Calibri"/>
+              </a:rPr>
+              <a:t>Raising A from 4 to 8 doubles the penalty on any given variance.</a:t>
+            </a:r>
+          </a:p>
+          <a:p>
+            <a:pPr marL="274320" indent="-274320">
+              <a:spcAft>
+                <a:spcPts val="1400"/>
+              </a:spcAft>
+              <a:buFont typeface="Arial"/>
+              <a:buChar char="•"/>
+            </a:pPr>
+            <a:r>
+              <a:rPr sz="2000" b="0" i="0">
+                <a:solidFill>
+                  <a:srgbClr val="000000"/>
+                </a:solidFill>
+                <a:latin typeface="Calibri"/>
+              </a:rPr>
+              <a:t>With unchanged inputs and constraints, globally optimized variance cannot increase; it may remain unchanged.</a:t>
+            </a:r>
+          </a:p>
+        </p:txBody>
+      </p:sp>
+      <p:sp>
+        <p:nvSpPr>
+          <p:cNvPr id="6" name="Rectangle 5"/>
+          <p:cNvSpPr/>
+          <p:nvPr/>
+        </p:nvSpPr>
+        <p:spPr>
+          <a:xfrm>
+            <a:off x="548640" y="4983480"/>
+            <a:ext cx="11091672" cy="914400"/>
+          </a:xfrm>
+          <a:prstGeom prst="rect">
+            <a:avLst/>
+          </a:prstGeom>
+          <a:solidFill>
+            <a:srgbClr val="E9EEF4"/>
+          </a:solidFill>
+          <a:ln>
+            <a:noFill/>
+          </a:ln>
+          <a:effectLst/>
+        </p:spPr>
+        <p:style>
+          <a:lnRef idx="1">
+            <a:schemeClr val="accent1"/>
+          </a:lnRef>
+          <a:fillRef idx="3">
+            <a:schemeClr val="accent1"/>
+          </a:fillRef>
+          <a:effectRef idx="2">
+            <a:schemeClr val="accent1"/>
+          </a:effectRef>
+          <a:fontRef idx="minor">
+            <a:schemeClr val="lt1"/>
+          </a:fontRef>
+        </p:style>
+        <p:txBody>
+          <a:bodyPr rtlCol="0" anchor="ctr" wrap="square" lIns="228600" rIns="228600"/>
+          <a:lstStyle/>
+          <a:p>
+            <a:pPr algn="l"/>
+            <a:r>
+              <a:rPr sz="2000" b="1" i="0">
+                <a:solidFill>
+                  <a:srgbClr val="1F3A5F"/>
+                </a:solidFill>
+                <a:latin typeface="Calibri"/>
+              </a:rPr>
+              <a:t>Takeaway: </a:t>
+            </a:r>
+            <a:r>
+              <a:rPr sz="2000" b="0" i="0">
+                <a:solidFill>
+                  <a:srgbClr val="000000"/>
+                </a:solidFill>
+                <a:latin typeface="Calibri"/>
+              </a:rPr>
+              <a:t>Greater risk aversion favors lower portfolio risk—not necessarily less of every volatile asset.</a:t>
+            </a:r>
+          </a:p>
+        </p:txBody>
+      </p:sp>
+      <p:sp>
+        <p:nvSpPr>
+          <p:cNvPr id="7" name="TextBox 6"/>
+          <p:cNvSpPr txBox="1"/>
+          <p:nvPr/>
+        </p:nvSpPr>
+        <p:spPr>
+          <a:xfrm>
+            <a:off x="548640" y="6263640"/>
+            <a:ext cx="6400800" cy="411480"/>
+          </a:xfrm>
+          <a:prstGeom prst="rect">
+            <a:avLst/>
+          </a:prstGeom>
+          <a:noFill/>
+        </p:spPr>
+        <p:txBody>
+          <a:bodyPr wrap="square">
+            <a:spAutoFit/>
+          </a:bodyPr>
+          <a:lstStyle/>
+          <a:p>
+            <a:r>
+              <a:rPr sz="1400" b="0" i="0">
+                <a:solidFill>
+                  <a:srgbClr val="595959"/>
+                </a:solidFill>
+                <a:latin typeface="Calibri"/>
+              </a:rPr>
+              <a:t>Sheet: Sec 3A - 5-Stock Demo</a:t>
+            </a:r>
+          </a:p>
+        </p:txBody>
+      </p:sp>
+      <p:sp>
+        <p:nvSpPr>
+          <p:cNvPr id="8" name="TextBox 7"/>
+          <p:cNvSpPr txBox="1"/>
+          <p:nvPr/>
+        </p:nvSpPr>
+        <p:spPr>
+          <a:xfrm>
+            <a:off x="7040880" y="6263640"/>
+            <a:ext cx="4599432" cy="411480"/>
+          </a:xfrm>
+          <a:prstGeom prst="rect">
+            <a:avLst/>
+          </a:prstGeom>
+          <a:noFill/>
+        </p:spPr>
+        <p:txBody>
+          <a:bodyPr wrap="square">
+            <a:spAutoFit/>
+          </a:bodyPr>
+          <a:lstStyle/>
+          <a:p>
+            <a:pPr algn="r"/>
+            <a:r>
+              <a:rPr sz="1400" b="0" i="0">
+                <a:solidFill>
+                  <a:srgbClr val="595959"/>
+                </a:solidFill>
+                <a:latin typeface="Calibri"/>
+              </a:rPr>
+              <a:t>Cells A203:A207; A94</a:t>
+            </a:r>
+          </a:p>
+        </p:txBody>
+      </p:sp>
+    </p:spTree>
+  </p:cSld>
+  <p:clrMapOvr>
+    <a:masterClrMapping/>
+  </p:clrMapOvr>
+</p:sld>
+</file>
+
+<file path=ppt/slides/slide13.xml><?xml version="1.0" encoding="utf-8"?>
+<p:sld xmlns:a="http://schemas.openxmlformats.org/drawingml/2006/main" xmlns:p="http://schemas.openxmlformats.org/presentationml/2006/main" xmlns:r="http://schemas.openxmlformats.org/officeDocument/2006/relationships">
+  <p:cSld>
+    <p:spTree>
+      <p:nvGrpSpPr>
+        <p:cNvPr id="1" name=""/>
+        <p:cNvGrpSpPr/>
+        <p:nvPr/>
+      </p:nvGrpSpPr>
+      <p:grpSpPr/>
+      <p:sp>
+        <p:nvSpPr>
+          <p:cNvPr id="2" name="TextBox 1"/>
+          <p:cNvSpPr txBox="1"/>
+          <p:nvPr/>
+        </p:nvSpPr>
+        <p:spPr>
+          <a:xfrm>
+            <a:off x="548640" y="274320"/>
+            <a:ext cx="11091672" cy="365760"/>
+          </a:xfrm>
+          <a:prstGeom prst="rect">
+            <a:avLst/>
+          </a:prstGeom>
+          <a:noFill/>
+        </p:spPr>
+        <p:txBody>
+          <a:bodyPr wrap="square">
+            <a:spAutoFit/>
+          </a:bodyPr>
+          <a:lstStyle/>
+          <a:p>
+            <a:r>
+              <a:rPr sz="1600" b="0" i="0">
+                <a:solidFill>
+                  <a:srgbClr val="595959"/>
+                </a:solidFill>
+                <a:latin typeface="Calibri"/>
+              </a:rPr>
+              <a:t>Question 13</a:t>
+            </a:r>
+          </a:p>
+        </p:txBody>
+      </p:sp>
+      <p:sp>
+        <p:nvSpPr>
+          <p:cNvPr id="3" name="TextBox 2"/>
+          <p:cNvSpPr txBox="1"/>
+          <p:nvPr/>
+        </p:nvSpPr>
+        <p:spPr>
+          <a:xfrm>
+            <a:off x="548640" y="594360"/>
+            <a:ext cx="11091672" cy="640080"/>
+          </a:xfrm>
+          <a:prstGeom prst="rect">
+            <a:avLst/>
+          </a:prstGeom>
+          <a:noFill/>
+        </p:spPr>
+        <p:txBody>
+          <a:bodyPr wrap="square">
+            <a:spAutoFit/>
+          </a:bodyPr>
+          <a:lstStyle/>
+          <a:p>
+            <a:r>
+              <a:rPr sz="3000" b="1" i="0">
+                <a:solidFill>
+                  <a:srgbClr val="000000"/>
+                </a:solidFill>
+                <a:latin typeface="Calibri"/>
+              </a:rPr>
+              <a:t>Why Is the Lower Frontier Branch Inefficient?</a:t>
+            </a:r>
+          </a:p>
+        </p:txBody>
+      </p:sp>
+      <p:sp>
+        <p:nvSpPr>
+          <p:cNvPr id="4" name="TextBox 3"/>
+          <p:cNvSpPr txBox="1"/>
+          <p:nvPr/>
+        </p:nvSpPr>
+        <p:spPr>
+          <a:xfrm>
+            <a:off x="548640" y="1280160"/>
+            <a:ext cx="11091672" cy="457200"/>
+          </a:xfrm>
+          <a:prstGeom prst="rect">
+            <a:avLst/>
+          </a:prstGeom>
+          <a:noFill/>
+        </p:spPr>
+        <p:txBody>
+          <a:bodyPr wrap="square">
+            <a:spAutoFit/>
+          </a:bodyPr>
+          <a:lstStyle/>
+          <a:p>
+            <a:r>
+              <a:rPr sz="2000" b="1" i="0">
+                <a:solidFill>
+                  <a:srgbClr val="1F3A5F"/>
+                </a:solidFill>
+                <a:latin typeface="Calibri"/>
+              </a:rPr>
+              <a:t>Answer: </a:t>
+            </a:r>
+            <a:r>
+              <a:rPr sz="2000" b="0" i="0">
+                <a:solidFill>
+                  <a:srgbClr val="1F3A5F"/>
+                </a:solidFill>
+                <a:latin typeface="Calibri"/>
+              </a:rPr>
+              <a:t>True — lower-branch portfolios are dominated.</a:t>
+            </a:r>
+          </a:p>
+        </p:txBody>
+      </p:sp>
+      <p:sp>
+        <p:nvSpPr>
+          <p:cNvPr id="5" name="TextBox 4"/>
+          <p:cNvSpPr txBox="1"/>
+          <p:nvPr/>
+        </p:nvSpPr>
+        <p:spPr>
+          <a:xfrm>
+            <a:off x="548640" y="2011680"/>
+            <a:ext cx="11091672" cy="2743200"/>
+          </a:xfrm>
+          <a:prstGeom prst="rect">
+            <a:avLst/>
+          </a:prstGeom>
+          <a:noFill/>
+        </p:spPr>
+        <p:txBody>
+          <a:bodyPr wrap="square">
+            <a:spAutoFit/>
+          </a:bodyPr>
+          <a:lstStyle/>
+          <a:p>
+            <a:pPr marL="274320" indent="-274320">
+              <a:spcAft>
+                <a:spcPts val="1400"/>
+              </a:spcAft>
+              <a:buFont typeface="Arial"/>
+              <a:buChar char="•"/>
+            </a:pPr>
+            <a:r>
+              <a:rPr sz="2000" b="0" i="0">
+                <a:solidFill>
+                  <a:srgbClr val="000000"/>
+                </a:solidFill>
+                <a:latin typeface="Calibri"/>
+              </a:rPr>
+              <a:t>“Minimum variance for a specified return” does not automatically mean mean–variance efficient.</a:t>
+            </a:r>
+          </a:p>
+          <a:p>
+            <a:pPr marL="274320" indent="-274320">
+              <a:spcAft>
+                <a:spcPts val="1400"/>
+              </a:spcAft>
+              <a:buFont typeface="Arial"/>
+              <a:buChar char="•"/>
+            </a:pPr>
+            <a:r>
+              <a:rPr sz="2000" b="0" i="0">
+                <a:solidFill>
+                  <a:srgbClr val="000000"/>
+                </a:solidFill>
+                <a:latin typeface="Calibri"/>
+              </a:rPr>
+              <a:t>On the standard two-branch frontier, an upper-branch portfolio offers higher expected return at the same volatility.</a:t>
+            </a:r>
+          </a:p>
+          <a:p>
+            <a:pPr marL="274320" indent="-274320">
+              <a:spcAft>
+                <a:spcPts val="1400"/>
+              </a:spcAft>
+              <a:buFont typeface="Arial"/>
+              <a:buChar char="•"/>
+            </a:pPr>
+            <a:r>
+              <a:rPr sz="2000" b="0" i="0">
+                <a:solidFill>
+                  <a:srgbClr val="000000"/>
+                </a:solidFill>
+                <a:latin typeface="Calibri"/>
+              </a:rPr>
+              <a:t>The global minimum-variance portfolio also dominates lower-branch portfolios: it has higher return and lower risk.</a:t>
+            </a:r>
+          </a:p>
+        </p:txBody>
+      </p:sp>
+      <p:sp>
+        <p:nvSpPr>
+          <p:cNvPr id="6" name="Rectangle 5"/>
+          <p:cNvSpPr/>
+          <p:nvPr/>
+        </p:nvSpPr>
+        <p:spPr>
+          <a:xfrm>
+            <a:off x="548640" y="4983480"/>
+            <a:ext cx="11091672" cy="914400"/>
+          </a:xfrm>
+          <a:prstGeom prst="rect">
+            <a:avLst/>
+          </a:prstGeom>
+          <a:solidFill>
+            <a:srgbClr val="E9EEF4"/>
+          </a:solidFill>
+          <a:ln>
+            <a:noFill/>
+          </a:ln>
+          <a:effectLst/>
+        </p:spPr>
+        <p:style>
+          <a:lnRef idx="1">
+            <a:schemeClr val="accent1"/>
+          </a:lnRef>
+          <a:fillRef idx="3">
+            <a:schemeClr val="accent1"/>
+          </a:fillRef>
+          <a:effectRef idx="2">
+            <a:schemeClr val="accent1"/>
+          </a:effectRef>
+          <a:fontRef idx="minor">
+            <a:schemeClr val="lt1"/>
+          </a:fontRef>
+        </p:style>
+        <p:txBody>
+          <a:bodyPr rtlCol="0" anchor="ctr" wrap="square" lIns="228600" rIns="228600"/>
+          <a:lstStyle/>
+          <a:p>
+            <a:pPr algn="l"/>
+            <a:r>
+              <a:rPr sz="2000" b="1" i="0">
+                <a:solidFill>
+                  <a:srgbClr val="1F3A5F"/>
+                </a:solidFill>
+                <a:latin typeface="Calibri"/>
+              </a:rPr>
+              <a:t>Takeaway: </a:t>
+            </a:r>
+            <a:r>
+              <a:rPr sz="2000" b="0" i="0">
+                <a:solidFill>
+                  <a:srgbClr val="000000"/>
+                </a:solidFill>
+                <a:latin typeface="Calibri"/>
+              </a:rPr>
+              <a:t>Only the branch starting at the global minimum-variance portfolio and running upward is efficient.</a:t>
+            </a:r>
+          </a:p>
+        </p:txBody>
+      </p:sp>
+      <p:sp>
+        <p:nvSpPr>
+          <p:cNvPr id="7" name="TextBox 6"/>
+          <p:cNvSpPr txBox="1"/>
+          <p:nvPr/>
+        </p:nvSpPr>
+        <p:spPr>
+          <a:xfrm>
+            <a:off x="548640" y="6263640"/>
+            <a:ext cx="6400800" cy="411480"/>
+          </a:xfrm>
+          <a:prstGeom prst="rect">
+            <a:avLst/>
+          </a:prstGeom>
+          <a:noFill/>
+        </p:spPr>
+        <p:txBody>
+          <a:bodyPr wrap="square">
+            <a:spAutoFit/>
+          </a:bodyPr>
+          <a:lstStyle/>
+          <a:p>
+            <a:r>
+              <a:rPr sz="1400" b="0" i="0">
+                <a:solidFill>
+                  <a:srgbClr val="595959"/>
+                </a:solidFill>
+                <a:latin typeface="Calibri"/>
+              </a:rPr>
+              <a:t>Sheet: Sec 3A - 5-Stock Demo</a:t>
+            </a:r>
+          </a:p>
+        </p:txBody>
+      </p:sp>
+      <p:sp>
+        <p:nvSpPr>
+          <p:cNvPr id="8" name="TextBox 7"/>
+          <p:cNvSpPr txBox="1"/>
+          <p:nvPr/>
+        </p:nvSpPr>
+        <p:spPr>
+          <a:xfrm>
+            <a:off x="7040880" y="6263640"/>
+            <a:ext cx="4599432" cy="411480"/>
+          </a:xfrm>
+          <a:prstGeom prst="rect">
+            <a:avLst/>
+          </a:prstGeom>
+          <a:noFill/>
+        </p:spPr>
+        <p:txBody>
+          <a:bodyPr wrap="square">
+            <a:spAutoFit/>
+          </a:bodyPr>
+          <a:lstStyle/>
+          <a:p>
+            <a:pPr algn="r"/>
+            <a:r>
+              <a:rPr sz="1400" b="0" i="0">
+                <a:solidFill>
+                  <a:srgbClr val="595959"/>
+                </a:solidFill>
+                <a:latin typeface="Calibri"/>
+              </a:rPr>
+              <a:t>Cells A210</a:t>
             </a:r>
           </a:p>
         </p:txBody>
@@ -3522,7 +4976,7 @@
                 </a:solidFill>
                 <a:latin typeface="Calibri"/>
               </a:rPr>
-              <a:t>T/F 2</a:t>
+              <a:t>Question 2</a:t>
             </a:r>
           </a:p>
         </p:txBody>
@@ -3556,7 +5010,7 @@
                 </a:solidFill>
                 <a:latin typeface="Calibri"/>
               </a:rPr>
-              <a:t>Short Sales: Asymmetric Payoffs and Unlimited Liability</a:t>
+              <a:t>Are Short-Selling Losses Limited?</a:t>
             </a:r>
           </a:p>
         </p:txBody>
@@ -3569,7 +5023,7 @@
         </p:nvSpPr>
         <p:spPr>
           <a:xfrm>
-            <a:off x="548640" y="1234440"/>
+            <a:off x="548640" y="1280160"/>
             <a:ext cx="11091672" cy="457200"/>
           </a:xfrm>
           <a:prstGeom prst="rect">
@@ -3584,13 +5038,22 @@
           <a:lstStyle/>
           <a:p>
             <a:r>
-              <a:rPr sz="1800" b="0" i="1">
-                <a:solidFill>
-                  <a:srgbClr val="595959"/>
-                </a:solidFill>
-                <a:latin typeface="Calibri"/>
-              </a:rPr>
-              <a:t>A short position reverses the payoff of a long position, including the bound on losses.</a:t>
+              <a:rPr sz="2000" b="1" i="0">
+                <a:solidFill>
+                  <a:srgbClr val="1F3A5F"/>
+                </a:solidFill>
+                <a:latin typeface="Calibri"/>
+              </a:rPr>
+              <a:t>Answer: </a:t>
+            </a:r>
+            <a:r>
+              <a:rPr sz="2000" b="0" i="0">
+                <a:solidFill>
+                  <a:srgbClr val="1F3A5F"/>
+                </a:solidFill>
+                <a:latin typeface="Calibri"/>
+              </a:rPr>
+              <a:t>False — potential losses are theoretically unlimited.</a:t>
             </a:r>
           </a:p>
         </p:txBody>
@@ -3603,8 +5066,8 @@
         </p:nvSpPr>
         <p:spPr>
           <a:xfrm>
-            <a:off x="548640" y="1920240"/>
-            <a:ext cx="7223760" cy="4206240"/>
+            <a:off x="548640" y="2011680"/>
+            <a:ext cx="11091672" cy="2743200"/>
           </a:xfrm>
           <a:prstGeom prst="rect">
             <a:avLst/>
@@ -3625,13 +5088,13 @@
               <a:buChar char="•"/>
             </a:pPr>
             <a:r>
-              <a:rPr sz="1700">
-                <a:solidFill>
-                  <a:srgbClr val="000000"/>
-                </a:solidFill>
-                <a:latin typeface="Calibri"/>
-              </a:rPr>
-              <a:t>Mechanics: the investor borrows shares from a broker, sells them at P₀, and must later repurchase them at P₁ to cover the position, paying any dividends to the lender in the interim.</a:t>
+              <a:rPr sz="2000" b="0" i="0">
+                <a:solidFill>
+                  <a:srgbClr val="000000"/>
+                </a:solidFill>
+                <a:latin typeface="Calibri"/>
+              </a:rPr>
+              <a:t>Short sellers must buy back the borrowed shares to close their positions.</a:t>
             </a:r>
           </a:p>
           <a:p>
@@ -3643,13 +5106,67 @@
               <a:buChar char="•"/>
             </a:pPr>
             <a:r>
-              <a:rPr sz="1700">
-                <a:solidFill>
-                  <a:srgbClr val="000000"/>
-                </a:solidFill>
-                <a:latin typeface="Calibri"/>
-              </a:rPr>
-              <a:t>A long position has limited liability, because P₁ ≥ 0 caps the loss at the initial investment. A short position's maximum gain is P₀, but its loss, P₁ − P₀, has no upper bound because P₁ has none.</a:t>
+              <a:rPr sz="2000" b="0" i="0">
+                <a:solidFill>
+                  <a:srgbClr val="000000"/>
+                </a:solidFill>
+                <a:latin typeface="Calibri"/>
+              </a:rPr>
+              <a:t>Short at </a:t>
+            </a:r>
+            <a:r>
+              <a:rPr sz="2000" b="1" i="0">
+                <a:solidFill>
+                  <a:srgbClr val="000000"/>
+                </a:solidFill>
+                <a:latin typeface="Calibri"/>
+              </a:rPr>
+              <a:t>$50</a:t>
+            </a:r>
+            <a:r>
+              <a:rPr sz="2000" b="0" i="0">
+                <a:solidFill>
+                  <a:srgbClr val="000000"/>
+                </a:solidFill>
+                <a:latin typeface="Calibri"/>
+              </a:rPr>
+              <a:t>, repurchase at </a:t>
+            </a:r>
+            <a:r>
+              <a:rPr sz="2000" b="1" i="0">
+                <a:solidFill>
+                  <a:srgbClr val="000000"/>
+                </a:solidFill>
+                <a:latin typeface="Calibri"/>
+              </a:rPr>
+              <a:t>$100</a:t>
+            </a:r>
+            <a:r>
+              <a:rPr sz="2000" b="0" i="0">
+                <a:solidFill>
+                  <a:srgbClr val="000000"/>
+                </a:solidFill>
+                <a:latin typeface="Calibri"/>
+              </a:rPr>
+              <a:t>: lose </a:t>
+            </a:r>
+            <a:r>
+              <a:rPr sz="2000" b="1" i="0">
+                <a:solidFill>
+                  <a:srgbClr val="000000"/>
+                </a:solidFill>
+                <a:latin typeface="Calibri"/>
+              </a:rPr>
+              <a:t>$50 per share</a:t>
+            </a:r>
+            <a:r>
+              <a:rPr sz="2000" b="0" i="0">
+                <a:solidFill>
+                  <a:srgbClr val="000000"/>
+                </a:solidFill>
+                <a:latin typeface="Calibri"/>
+              </a:rPr>
+              <a:t>, excluding costs and dividends owed to the lender.</a:t>
             </a:r>
           </a:p>
           <a:p>
@@ -3661,13 +5178,13 @@
               <a:buChar char="•"/>
             </a:pPr>
             <a:r>
-              <a:rPr sz="1700">
-                <a:solidFill>
-                  <a:srgbClr val="000000"/>
-                </a:solidFill>
-                <a:latin typeface="Calibri"/>
-              </a:rPr>
-              <a:t>Short sellers must post margin (the sale proceeds plus initial margin). A rising price erodes equity in the account and can trigger a margin call or forced covering (a short squeeze).</a:t>
+              <a:rPr sz="2000" b="0" i="0">
+                <a:solidFill>
+                  <a:srgbClr val="000000"/>
+                </a:solidFill>
+                <a:latin typeface="Calibri"/>
+              </a:rPr>
+              <a:t>Because a stock price has no fixed ceiling, the potential loss has no fixed ceiling.</a:t>
             </a:r>
           </a:p>
         </p:txBody>
@@ -3680,14 +5197,14 @@
         </p:nvSpPr>
         <p:spPr>
           <a:xfrm>
-            <a:off x="8092440" y="1920240"/>
-            <a:ext cx="3547872" cy="2514600"/>
+            <a:off x="548640" y="4983480"/>
+            <a:ext cx="11091672" cy="914400"/>
           </a:xfrm>
           <a:prstGeom prst="rect">
             <a:avLst/>
           </a:prstGeom>
           <a:solidFill>
-            <a:srgbClr val="F2F2F2"/>
+            <a:srgbClr val="E9EEF4"/>
           </a:solidFill>
           <a:ln>
             <a:noFill/>
@@ -3709,102 +5226,27 @@
           </a:fontRef>
         </p:style>
         <p:txBody>
-          <a:bodyPr rtlCol="0" anchor="t" wrap="square" lIns="182880" rIns="182880" tIns="182880"/>
-          <a:lstStyle/>
-          <a:p>
-            <a:pPr algn="l">
-              <a:spcAft>
-                <a:spcPts val="1000"/>
-              </a:spcAft>
-            </a:pPr>
-            <a:r>
-              <a:rPr sz="1600" b="1">
-                <a:solidFill>
-                  <a:srgbClr val="000000"/>
-                </a:solidFill>
-                <a:latin typeface="Calibri"/>
-              </a:rPr>
-              <a:t>Formal statement</a:t>
-            </a:r>
-          </a:p>
-          <a:p>
-            <a:pPr>
-              <a:spcAft>
-                <a:spcPts val="600"/>
-              </a:spcAft>
-            </a:pPr>
-            <a:r>
-              <a:rPr sz="1500">
-                <a:solidFill>
-                  <a:srgbClr val="000000"/>
-                </a:solidFill>
-                <a:latin typeface="Cambria"/>
-              </a:rPr>
-              <a:t>Long:   Π = P₁ − P₀   ⇒  Π ≥ −P₀</a:t>
-            </a:r>
-          </a:p>
-          <a:p>
-            <a:pPr>
-              <a:spcAft>
-                <a:spcPts val="600"/>
-              </a:spcAft>
-            </a:pPr>
-            <a:r>
-              <a:rPr sz="1500">
-                <a:solidFill>
-                  <a:srgbClr val="000000"/>
-                </a:solidFill>
-                <a:latin typeface="Cambria"/>
-              </a:rPr>
-              <a:t>Short:  Π = P₀ − P₁ − D  ⇒  Π ≤ P₀</a:t>
-            </a:r>
-          </a:p>
-          <a:p>
-            <a:pPr>
-              <a:spcAft>
-                <a:spcPts val="600"/>
-              </a:spcAft>
-            </a:pPr>
-            <a:r>
-              <a:rPr sz="1500">
-                <a:solidFill>
-                  <a:srgbClr val="000000"/>
-                </a:solidFill>
-                <a:latin typeface="Cambria"/>
-              </a:rPr>
-              <a:t>P₁ ∈ [0, ∞)</a:t>
-            </a:r>
-          </a:p>
-          <a:p>
-            <a:pPr>
-              <a:spcAft>
-                <a:spcPts val="600"/>
-              </a:spcAft>
-            </a:pPr>
-            <a:r>
-              <a:rPr sz="1500">
-                <a:solidFill>
-                  <a:srgbClr val="000000"/>
-                </a:solidFill>
-                <a:latin typeface="Cambria"/>
-              </a:rPr>
-              <a:t>⇒ long loss bounded,</a:t>
-            </a:r>
-          </a:p>
-          <a:p>
-            <a:pPr>
-              <a:spcAft>
-                <a:spcPts val="600"/>
-              </a:spcAft>
-            </a:pPr>
-            <a:r>
-              <a:rPr sz="1500">
-                <a:solidFill>
-                  <a:srgbClr val="000000"/>
-                </a:solidFill>
-                <a:latin typeface="Cambria"/>
-              </a:rPr>
-              <a:t>    short loss unbounded</a:t>
+          <a:bodyPr rtlCol="0" anchor="ctr" wrap="square" lIns="228600" rIns="228600"/>
+          <a:lstStyle/>
+          <a:p>
+            <a:pPr algn="l"/>
+            <a:r>
+              <a:rPr sz="2000" b="1" i="0">
+                <a:solidFill>
+                  <a:srgbClr val="1F3A5F"/>
+                </a:solidFill>
+                <a:latin typeface="Calibri"/>
+              </a:rPr>
+              <a:t>Takeaway: </a:t>
+            </a:r>
+            <a:r>
+              <a:rPr sz="2000" b="0" i="0">
+                <a:solidFill>
+                  <a:srgbClr val="000000"/>
+                </a:solidFill>
+                <a:latin typeface="Calibri"/>
+              </a:rPr>
+              <a:t>A price floor limits the short seller’s gain—not the loss.</a:t>
             </a:r>
           </a:p>
         </p:txBody>
@@ -3818,7 +5260,7 @@
         <p:spPr>
           <a:xfrm>
             <a:off x="548640" y="6263640"/>
-            <a:ext cx="8229600" cy="411480"/>
+            <a:ext cx="6400800" cy="411480"/>
           </a:xfrm>
           <a:prstGeom prst="rect">
             <a:avLst/>
@@ -3834,7 +5276,7 @@
             <a:r>
               <a:rPr sz="1400" b="0" i="0">
                 <a:solidFill>
-                  <a:srgbClr val="000000"/>
+                  <a:srgbClr val="595959"/>
                 </a:solidFill>
                 <a:latin typeface="Calibri"/>
               </a:rPr>
@@ -3851,8 +5293,8 @@
         </p:nvSpPr>
         <p:spPr>
           <a:xfrm>
-            <a:off x="9326880" y="6263640"/>
-            <a:ext cx="2313432" cy="411480"/>
+            <a:off x="7040880" y="6263640"/>
+            <a:ext cx="4599432" cy="411480"/>
           </a:xfrm>
           <a:prstGeom prst="rect">
             <a:avLst/>
@@ -3869,11 +5311,11 @@
             <a:r>
               <a:rPr sz="1400" b="0" i="0">
                 <a:solidFill>
-                  <a:srgbClr val="000000"/>
-                </a:solidFill>
-                <a:latin typeface="Calibri"/>
-              </a:rPr>
-              <a:t>Row 127</a:t>
+                  <a:srgbClr val="595959"/>
+                </a:solidFill>
+                <a:latin typeface="Calibri"/>
+              </a:rPr>
+              <a:t>Cells A127</a:t>
             </a:r>
           </a:p>
         </p:txBody>
@@ -3925,7 +5367,7 @@
                 </a:solidFill>
                 <a:latin typeface="Calibri"/>
               </a:rPr>
-              <a:t>T/F 3</a:t>
+              <a:t>Question 3</a:t>
             </a:r>
           </a:p>
         </p:txBody>
@@ -3959,7 +5401,7 @@
                 </a:solidFill>
                 <a:latin typeface="Calibri"/>
               </a:rPr>
-              <a:t>Estimation Risk: Ex Ante Optimality vs. Ex Post Performance</a:t>
+              <a:t>Are Historical Optimal Weights Guaranteed to Work?</a:t>
             </a:r>
           </a:p>
         </p:txBody>
@@ -3972,7 +5414,7 @@
         </p:nvSpPr>
         <p:spPr>
           <a:xfrm>
-            <a:off x="548640" y="1234440"/>
+            <a:off x="548640" y="1280160"/>
             <a:ext cx="11091672" cy="457200"/>
           </a:xfrm>
           <a:prstGeom prst="rect">
@@ -3987,13 +5429,22 @@
           <a:lstStyle/>
           <a:p>
             <a:r>
-              <a:rPr sz="1800" b="0" i="1">
-                <a:solidFill>
-                  <a:srgbClr val="595959"/>
-                </a:solidFill>
-                <a:latin typeface="Calibri"/>
-              </a:rPr>
-              <a:t>Mean-variance weights are optimal only with respect to the inputs used to compute them.</a:t>
+              <a:rPr sz="2000" b="1" i="0">
+                <a:solidFill>
+                  <a:srgbClr val="1F3A5F"/>
+                </a:solidFill>
+                <a:latin typeface="Calibri"/>
+              </a:rPr>
+              <a:t>Answer: </a:t>
+            </a:r>
+            <a:r>
+              <a:rPr sz="2000" b="0" i="0">
+                <a:solidFill>
+                  <a:srgbClr val="1F3A5F"/>
+                </a:solidFill>
+                <a:latin typeface="Calibri"/>
+              </a:rPr>
+              <a:t>False — optimization is conditional on its inputs.</a:t>
             </a:r>
           </a:p>
         </p:txBody>
@@ -4006,8 +5457,8 @@
         </p:nvSpPr>
         <p:spPr>
           <a:xfrm>
-            <a:off x="548640" y="1920240"/>
-            <a:ext cx="7223760" cy="4206240"/>
+            <a:off x="548640" y="2011680"/>
+            <a:ext cx="11091672" cy="2743200"/>
           </a:xfrm>
           <a:prstGeom prst="rect">
             <a:avLst/>
@@ -4028,13 +5479,13 @@
               <a:buChar char="•"/>
             </a:pPr>
             <a:r>
-              <a:rPr sz="1700">
-                <a:solidFill>
-                  <a:srgbClr val="000000"/>
-                </a:solidFill>
-                <a:latin typeface="Calibri"/>
-              </a:rPr>
-              <a:t>The Markowitz model assumes the true expected returns μ and covariance matrix Σ are known. In practice, Solver uses sample estimates of μ and Σ from 60 monthly observations and treats them as exact.</a:t>
+              <a:rPr sz="2000" b="0" i="0">
+                <a:solidFill>
+                  <a:srgbClr val="000000"/>
+                </a:solidFill>
+                <a:latin typeface="Calibri"/>
+              </a:rPr>
+              <a:t>Historical returns, variances, and correlations are estimates of future conditions.</a:t>
             </a:r>
           </a:p>
           <a:p>
@@ -4046,13 +5497,13 @@
               <a:buChar char="•"/>
             </a:pPr>
             <a:r>
-              <a:rPr sz="1700">
-                <a:solidFill>
-                  <a:srgbClr val="000000"/>
-                </a:solidFill>
-                <a:latin typeface="Calibri"/>
-              </a:rPr>
-              <a:t>Expected returns are estimated with low precision: the standard error of a sample mean is s/√T. In addition, return distributions are not stationary, so means, volatilities, and correlations shift over time.</a:t>
+              <a:rPr sz="2000" b="0" i="0">
+                <a:solidFill>
+                  <a:srgbClr val="000000"/>
+                </a:solidFill>
+                <a:latin typeface="Calibri"/>
+              </a:rPr>
+              <a:t>Estimation error and changing relationships can make yesterday’s optimal weights unattractive tomorrow.</a:t>
             </a:r>
           </a:p>
           <a:p>
@@ -4064,13 +5515,13 @@
               <a:buChar char="•"/>
             </a:pPr>
             <a:r>
-              <a:rPr sz="1700">
-                <a:solidFill>
-                  <a:srgbClr val="000000"/>
-                </a:solidFill>
-                <a:latin typeface="Calibri"/>
-              </a:rPr>
-              <a:t>The optimizer magnifies estimation error by overweighting assets whose means are overestimated or whose risks are underestimated. This produces extreme or corner weights (95% AGG in Step 8; ±100%+ positions in Step 10).</a:t>
+              <a:rPr sz="2000" b="0" i="0">
+                <a:solidFill>
+                  <a:srgbClr val="000000"/>
+                </a:solidFill>
+                <a:latin typeface="Calibri"/>
+              </a:rPr>
+              <a:t>A mathematically correct optimization does not guarantee future investment performance.</a:t>
             </a:r>
           </a:p>
         </p:txBody>
@@ -4083,14 +5534,14 @@
         </p:nvSpPr>
         <p:spPr>
           <a:xfrm>
-            <a:off x="8092440" y="1920240"/>
-            <a:ext cx="3547872" cy="2514600"/>
+            <a:off x="548640" y="4983480"/>
+            <a:ext cx="11091672" cy="914400"/>
           </a:xfrm>
           <a:prstGeom prst="rect">
             <a:avLst/>
           </a:prstGeom>
           <a:solidFill>
-            <a:srgbClr val="F2F2F2"/>
+            <a:srgbClr val="E9EEF4"/>
           </a:solidFill>
           <a:ln>
             <a:noFill/>
@@ -4112,102 +5563,27 @@
           </a:fontRef>
         </p:style>
         <p:txBody>
-          <a:bodyPr rtlCol="0" anchor="t" wrap="square" lIns="182880" rIns="182880" tIns="182880"/>
-          <a:lstStyle/>
-          <a:p>
-            <a:pPr algn="l">
-              <a:spcAft>
-                <a:spcPts val="1000"/>
-              </a:spcAft>
-            </a:pPr>
-            <a:r>
-              <a:rPr sz="1600" b="1">
-                <a:solidFill>
-                  <a:srgbClr val="000000"/>
-                </a:solidFill>
-                <a:latin typeface="Calibri"/>
-              </a:rPr>
-              <a:t>Formal statement</a:t>
-            </a:r>
-          </a:p>
-          <a:p>
-            <a:pPr>
-              <a:spcAft>
-                <a:spcPts val="600"/>
-              </a:spcAft>
-            </a:pPr>
-            <a:r>
-              <a:rPr sz="1500">
-                <a:solidFill>
-                  <a:srgbClr val="000000"/>
-                </a:solidFill>
-                <a:latin typeface="Cambria"/>
-              </a:rPr>
-              <a:t>w* = argmax f(μ̂, Σ̂), not f(μ, Σ)</a:t>
-            </a:r>
-          </a:p>
-          <a:p>
-            <a:pPr>
-              <a:spcAft>
-                <a:spcPts val="600"/>
-              </a:spcAft>
-            </a:pPr>
-            <a:r>
-              <a:rPr sz="1500">
-                <a:solidFill>
-                  <a:srgbClr val="000000"/>
-                </a:solidFill>
-                <a:latin typeface="Cambria"/>
-              </a:rPr>
-              <a:t>SE(r̄) = s / √T</a:t>
-            </a:r>
-          </a:p>
-          <a:p>
-            <a:pPr>
-              <a:spcAft>
-                <a:spcPts val="600"/>
-              </a:spcAft>
-            </a:pPr>
-            <a:r>
-              <a:rPr sz="1500">
-                <a:solidFill>
-                  <a:srgbClr val="000000"/>
-                </a:solidFill>
-                <a:latin typeface="Cambria"/>
-              </a:rPr>
-              <a:t>AAPL: s = 7.11%/mo, T = 60</a:t>
-            </a:r>
-          </a:p>
-          <a:p>
-            <a:pPr>
-              <a:spcAft>
-                <a:spcPts val="600"/>
-              </a:spcAft>
-            </a:pPr>
-            <a:r>
-              <a:rPr sz="1500">
-                <a:solidFill>
-                  <a:srgbClr val="000000"/>
-                </a:solidFill>
-                <a:latin typeface="Cambria"/>
-              </a:rPr>
-              <a:t>SE ≈ 0.92%/mo ≈ 11.0%/yr</a:t>
-            </a:r>
-          </a:p>
-          <a:p>
-            <a:pPr>
-              <a:spcAft>
-                <a:spcPts val="600"/>
-              </a:spcAft>
-            </a:pPr>
-            <a:r>
-              <a:rPr sz="1500">
-                <a:solidFill>
-                  <a:srgbClr val="000000"/>
-                </a:solidFill>
-                <a:latin typeface="Cambria"/>
-              </a:rPr>
-              <a:t>vs. sample mean ≈ 17.1%/yr</a:t>
+          <a:bodyPr rtlCol="0" anchor="ctr" wrap="square" lIns="228600" rIns="228600"/>
+          <a:lstStyle/>
+          <a:p>
+            <a:pPr algn="l"/>
+            <a:r>
+              <a:rPr sz="2000" b="1" i="0">
+                <a:solidFill>
+                  <a:srgbClr val="1F3A5F"/>
+                </a:solidFill>
+                <a:latin typeface="Calibri"/>
+              </a:rPr>
+              <a:t>Takeaway: </a:t>
+            </a:r>
+            <a:r>
+              <a:rPr sz="2000" b="0" i="0">
+                <a:solidFill>
+                  <a:srgbClr val="000000"/>
+                </a:solidFill>
+                <a:latin typeface="Calibri"/>
+              </a:rPr>
+              <a:t>Optimal for estimated inputs is not guaranteed optimal for the future.</a:t>
             </a:r>
           </a:p>
         </p:txBody>
@@ -4221,7 +5597,7 @@
         <p:spPr>
           <a:xfrm>
             <a:off x="548640" y="6263640"/>
-            <a:ext cx="8229600" cy="411480"/>
+            <a:ext cx="6400800" cy="411480"/>
           </a:xfrm>
           <a:prstGeom prst="rect">
             <a:avLst/>
@@ -4237,7 +5613,7 @@
             <a:r>
               <a:rPr sz="1400" b="0" i="0">
                 <a:solidFill>
-                  <a:srgbClr val="000000"/>
+                  <a:srgbClr val="595959"/>
                 </a:solidFill>
                 <a:latin typeface="Calibri"/>
               </a:rPr>
@@ -4254,8 +5630,8 @@
         </p:nvSpPr>
         <p:spPr>
           <a:xfrm>
-            <a:off x="9326880" y="6263640"/>
-            <a:ext cx="2313432" cy="411480"/>
+            <a:off x="7040880" y="6263640"/>
+            <a:ext cx="4599432" cy="411480"/>
           </a:xfrm>
           <a:prstGeom prst="rect">
             <a:avLst/>
@@ -4272,11 +5648,2204 @@
             <a:r>
               <a:rPr sz="1400" b="0" i="0">
                 <a:solidFill>
-                  <a:srgbClr val="000000"/>
-                </a:solidFill>
-                <a:latin typeface="Calibri"/>
-              </a:rPr>
-              <a:t>Row 130</a:t>
+                  <a:srgbClr val="595959"/>
+                </a:solidFill>
+                <a:latin typeface="Calibri"/>
+              </a:rPr>
+              <a:t>Cells A130</a:t>
+            </a:r>
+          </a:p>
+        </p:txBody>
+      </p:sp>
+    </p:spTree>
+  </p:cSld>
+  <p:clrMapOvr>
+    <a:masterClrMapping/>
+  </p:clrMapOvr>
+</p:sld>
+</file>
+
+<file path=ppt/slides/slide4.xml><?xml version="1.0" encoding="utf-8"?>
+<p:sld xmlns:a="http://schemas.openxmlformats.org/drawingml/2006/main" xmlns:p="http://schemas.openxmlformats.org/presentationml/2006/main" xmlns:r="http://schemas.openxmlformats.org/officeDocument/2006/relationships">
+  <p:cSld>
+    <p:spTree>
+      <p:nvGrpSpPr>
+        <p:cNvPr id="1" name=""/>
+        <p:cNvGrpSpPr/>
+        <p:nvPr/>
+      </p:nvGrpSpPr>
+      <p:grpSpPr/>
+      <p:sp>
+        <p:nvSpPr>
+          <p:cNvPr id="2" name="TextBox 1"/>
+          <p:cNvSpPr txBox="1"/>
+          <p:nvPr/>
+        </p:nvSpPr>
+        <p:spPr>
+          <a:xfrm>
+            <a:off x="548640" y="274320"/>
+            <a:ext cx="11091672" cy="365760"/>
+          </a:xfrm>
+          <a:prstGeom prst="rect">
+            <a:avLst/>
+          </a:prstGeom>
+          <a:noFill/>
+        </p:spPr>
+        <p:txBody>
+          <a:bodyPr wrap="square">
+            <a:spAutoFit/>
+          </a:bodyPr>
+          <a:lstStyle/>
+          <a:p>
+            <a:r>
+              <a:rPr sz="1600" b="0" i="0">
+                <a:solidFill>
+                  <a:srgbClr val="595959"/>
+                </a:solidFill>
+                <a:latin typeface="Calibri"/>
+              </a:rPr>
+              <a:t>Question 4</a:t>
+            </a:r>
+          </a:p>
+        </p:txBody>
+      </p:sp>
+      <p:sp>
+        <p:nvSpPr>
+          <p:cNvPr id="3" name="TextBox 2"/>
+          <p:cNvSpPr txBox="1"/>
+          <p:nvPr/>
+        </p:nvSpPr>
+        <p:spPr>
+          <a:xfrm>
+            <a:off x="548640" y="594360"/>
+            <a:ext cx="11091672" cy="640080"/>
+          </a:xfrm>
+          <a:prstGeom prst="rect">
+            <a:avLst/>
+          </a:prstGeom>
+          <a:noFill/>
+        </p:spPr>
+        <p:txBody>
+          <a:bodyPr wrap="square">
+            <a:spAutoFit/>
+          </a:bodyPr>
+          <a:lstStyle/>
+          <a:p>
+            <a:r>
+              <a:rPr sz="3000" b="1" i="0">
+                <a:solidFill>
+                  <a:srgbClr val="000000"/>
+                </a:solidFill>
+                <a:latin typeface="Calibri"/>
+              </a:rPr>
+              <a:t>Is the Utility-Maximizing Portfolio Efficient?</a:t>
+            </a:r>
+          </a:p>
+        </p:txBody>
+      </p:sp>
+      <p:sp>
+        <p:nvSpPr>
+          <p:cNvPr id="4" name="TextBox 3"/>
+          <p:cNvSpPr txBox="1"/>
+          <p:nvPr/>
+        </p:nvSpPr>
+        <p:spPr>
+          <a:xfrm>
+            <a:off x="548640" y="1280160"/>
+            <a:ext cx="11091672" cy="457200"/>
+          </a:xfrm>
+          <a:prstGeom prst="rect">
+            <a:avLst/>
+          </a:prstGeom>
+          <a:noFill/>
+        </p:spPr>
+        <p:txBody>
+          <a:bodyPr wrap="square">
+            <a:spAutoFit/>
+          </a:bodyPr>
+          <a:lstStyle/>
+          <a:p>
+            <a:r>
+              <a:rPr sz="2000" b="1" i="0">
+                <a:solidFill>
+                  <a:srgbClr val="1F3A5F"/>
+                </a:solidFill>
+                <a:latin typeface="Calibri"/>
+              </a:rPr>
+              <a:t>Answer: </a:t>
+            </a:r>
+            <a:r>
+              <a:rPr sz="2000" b="0" i="0">
+                <a:solidFill>
+                  <a:srgbClr val="1F3A5F"/>
+                </a:solidFill>
+                <a:latin typeface="Calibri"/>
+              </a:rPr>
+              <a:t>True — on the frontier with shorting allowed.</a:t>
+            </a:r>
+          </a:p>
+        </p:txBody>
+      </p:sp>
+      <p:sp>
+        <p:nvSpPr>
+          <p:cNvPr id="5" name="TextBox 4"/>
+          <p:cNvSpPr txBox="1"/>
+          <p:nvPr/>
+        </p:nvSpPr>
+        <p:spPr>
+          <a:xfrm>
+            <a:off x="548640" y="2011680"/>
+            <a:ext cx="11091672" cy="2743200"/>
+          </a:xfrm>
+          <a:prstGeom prst="rect">
+            <a:avLst/>
+          </a:prstGeom>
+          <a:noFill/>
+        </p:spPr>
+        <p:txBody>
+          <a:bodyPr wrap="square">
+            <a:spAutoFit/>
+          </a:bodyPr>
+          <a:lstStyle/>
+          <a:p>
+            <a:pPr marL="274320" indent="-274320">
+              <a:spcAft>
+                <a:spcPts val="1400"/>
+              </a:spcAft>
+              <a:buFont typeface="Arial"/>
+              <a:buChar char="•"/>
+            </a:pPr>
+            <a:r>
+              <a:rPr sz="2000" b="0" i="0">
+                <a:solidFill>
+                  <a:srgbClr val="000000"/>
+                </a:solidFill>
+                <a:latin typeface="Calibri"/>
+              </a:rPr>
+              <a:t>With positive risk aversion, utility rewards expected return and penalizes variance.</a:t>
+            </a:r>
+          </a:p>
+          <a:p>
+            <a:pPr marL="274320" indent="-274320">
+              <a:spcAft>
+                <a:spcPts val="1400"/>
+              </a:spcAft>
+              <a:buFont typeface="Arial"/>
+              <a:buChar char="•"/>
+            </a:pPr>
+            <a:r>
+              <a:rPr sz="2000" b="0" i="0">
+                <a:solidFill>
+                  <a:srgbClr val="000000"/>
+                </a:solidFill>
+                <a:latin typeface="Calibri"/>
+              </a:rPr>
+              <a:t>A portfolio offering higher return with no more risk—or lower risk with no less return—would have higher utility.</a:t>
+            </a:r>
+          </a:p>
+          <a:p>
+            <a:pPr marL="274320" indent="-274320">
+              <a:spcAft>
+                <a:spcPts val="1400"/>
+              </a:spcAft>
+              <a:buFont typeface="Arial"/>
+              <a:buChar char="•"/>
+            </a:pPr>
+            <a:r>
+              <a:rPr sz="2000" b="0" i="0">
+                <a:solidFill>
+                  <a:srgbClr val="000000"/>
+                </a:solidFill>
+                <a:latin typeface="Calibri"/>
+              </a:rPr>
+              <a:t>Therefore, a global utility maximum cannot be dominated within the same feasible set (Step 11: σ</a:t>
+            </a:r>
+            <a:r>
+              <a:rPr sz="2000" b="0" i="0" baseline="-25000">
+                <a:solidFill>
+                  <a:srgbClr val="000000"/>
+                </a:solidFill>
+                <a:latin typeface="Calibri"/>
+              </a:rPr>
+              <a:t>p</a:t>
+            </a:r>
+            <a:r>
+              <a:rPr sz="2000" b="0" i="0">
+                <a:solidFill>
+                  <a:srgbClr val="000000"/>
+                </a:solidFill>
+                <a:latin typeface="Calibri"/>
+              </a:rPr>
+              <a:t> in B105 = B120).</a:t>
+            </a:r>
+          </a:p>
+        </p:txBody>
+      </p:sp>
+      <p:sp>
+        <p:nvSpPr>
+          <p:cNvPr id="6" name="Rectangle 5"/>
+          <p:cNvSpPr/>
+          <p:nvPr/>
+        </p:nvSpPr>
+        <p:spPr>
+          <a:xfrm>
+            <a:off x="548640" y="4983480"/>
+            <a:ext cx="11091672" cy="914400"/>
+          </a:xfrm>
+          <a:prstGeom prst="rect">
+            <a:avLst/>
+          </a:prstGeom>
+          <a:solidFill>
+            <a:srgbClr val="E9EEF4"/>
+          </a:solidFill>
+          <a:ln>
+            <a:noFill/>
+          </a:ln>
+          <a:effectLst/>
+        </p:spPr>
+        <p:style>
+          <a:lnRef idx="1">
+            <a:schemeClr val="accent1"/>
+          </a:lnRef>
+          <a:fillRef idx="3">
+            <a:schemeClr val="accent1"/>
+          </a:fillRef>
+          <a:effectRef idx="2">
+            <a:schemeClr val="accent1"/>
+          </a:effectRef>
+          <a:fontRef idx="minor">
+            <a:schemeClr val="lt1"/>
+          </a:fontRef>
+        </p:style>
+        <p:txBody>
+          <a:bodyPr rtlCol="0" anchor="ctr" wrap="square" lIns="228600" rIns="228600"/>
+          <a:lstStyle/>
+          <a:p>
+            <a:pPr algn="l"/>
+            <a:r>
+              <a:rPr sz="2000" b="1" i="0">
+                <a:solidFill>
+                  <a:srgbClr val="1F3A5F"/>
+                </a:solidFill>
+                <a:latin typeface="Calibri"/>
+              </a:rPr>
+              <a:t>Important: </a:t>
+            </a:r>
+            <a:r>
+              <a:rPr sz="2000" b="0" i="0">
+                <a:solidFill>
+                  <a:srgbClr val="000000"/>
+                </a:solidFill>
+                <a:latin typeface="Calibri"/>
+              </a:rPr>
+              <a:t>Step 10 uses the </a:t>
+            </a:r>
+            <a:r>
+              <a:rPr sz="2000" b="1" i="0">
+                <a:solidFill>
+                  <a:srgbClr val="000000"/>
+                </a:solidFill>
+                <a:latin typeface="Calibri"/>
+              </a:rPr>
+              <a:t>shorting-allowed frontier</a:t>
+            </a:r>
+            <a:r>
+              <a:rPr sz="2000" b="0" i="0">
+                <a:solidFill>
+                  <a:srgbClr val="000000"/>
+                </a:solidFill>
+                <a:latin typeface="Calibri"/>
+              </a:rPr>
+              <a:t>, not the no-shorting frontier plotted in Step 12.</a:t>
+            </a:r>
+          </a:p>
+        </p:txBody>
+      </p:sp>
+      <p:sp>
+        <p:nvSpPr>
+          <p:cNvPr id="7" name="TextBox 6"/>
+          <p:cNvSpPr txBox="1"/>
+          <p:nvPr/>
+        </p:nvSpPr>
+        <p:spPr>
+          <a:xfrm>
+            <a:off x="548640" y="6263640"/>
+            <a:ext cx="6400800" cy="411480"/>
+          </a:xfrm>
+          <a:prstGeom prst="rect">
+            <a:avLst/>
+          </a:prstGeom>
+          <a:noFill/>
+        </p:spPr>
+        <p:txBody>
+          <a:bodyPr wrap="square">
+            <a:spAutoFit/>
+          </a:bodyPr>
+          <a:lstStyle/>
+          <a:p>
+            <a:r>
+              <a:rPr sz="1400" b="0" i="0">
+                <a:solidFill>
+                  <a:srgbClr val="595959"/>
+                </a:solidFill>
+                <a:latin typeface="Calibri"/>
+              </a:rPr>
+              <a:t>Sheet: Sec 3A - 5-Stock Demo</a:t>
+            </a:r>
+          </a:p>
+        </p:txBody>
+      </p:sp>
+      <p:sp>
+        <p:nvSpPr>
+          <p:cNvPr id="8" name="TextBox 7"/>
+          <p:cNvSpPr txBox="1"/>
+          <p:nvPr/>
+        </p:nvSpPr>
+        <p:spPr>
+          <a:xfrm>
+            <a:off x="7040880" y="6263640"/>
+            <a:ext cx="4599432" cy="411480"/>
+          </a:xfrm>
+          <a:prstGeom prst="rect">
+            <a:avLst/>
+          </a:prstGeom>
+          <a:noFill/>
+        </p:spPr>
+        <p:txBody>
+          <a:bodyPr wrap="square">
+            <a:spAutoFit/>
+          </a:bodyPr>
+          <a:lstStyle/>
+          <a:p>
+            <a:pPr algn="r"/>
+            <a:r>
+              <a:rPr sz="1400" b="0" i="0">
+                <a:solidFill>
+                  <a:srgbClr val="595959"/>
+                </a:solidFill>
+                <a:latin typeface="Calibri"/>
+              </a:rPr>
+              <a:t>Cells A133; A93:B106</a:t>
+            </a:r>
+          </a:p>
+        </p:txBody>
+      </p:sp>
+    </p:spTree>
+  </p:cSld>
+  <p:clrMapOvr>
+    <a:masterClrMapping/>
+  </p:clrMapOvr>
+</p:sld>
+</file>
+
+<file path=ppt/slides/slide5.xml><?xml version="1.0" encoding="utf-8"?>
+<p:sld xmlns:a="http://schemas.openxmlformats.org/drawingml/2006/main" xmlns:p="http://schemas.openxmlformats.org/presentationml/2006/main" xmlns:r="http://schemas.openxmlformats.org/officeDocument/2006/relationships">
+  <p:cSld>
+    <p:spTree>
+      <p:nvGrpSpPr>
+        <p:cNvPr id="1" name=""/>
+        <p:cNvGrpSpPr/>
+        <p:nvPr/>
+      </p:nvGrpSpPr>
+      <p:grpSpPr/>
+      <p:sp>
+        <p:nvSpPr>
+          <p:cNvPr id="2" name="TextBox 1"/>
+          <p:cNvSpPr txBox="1"/>
+          <p:nvPr/>
+        </p:nvSpPr>
+        <p:spPr>
+          <a:xfrm>
+            <a:off x="548640" y="274320"/>
+            <a:ext cx="11091672" cy="365760"/>
+          </a:xfrm>
+          <a:prstGeom prst="rect">
+            <a:avLst/>
+          </a:prstGeom>
+          <a:noFill/>
+        </p:spPr>
+        <p:txBody>
+          <a:bodyPr wrap="square">
+            <a:spAutoFit/>
+          </a:bodyPr>
+          <a:lstStyle/>
+          <a:p>
+            <a:r>
+              <a:rPr sz="1600" b="0" i="0">
+                <a:solidFill>
+                  <a:srgbClr val="595959"/>
+                </a:solidFill>
+                <a:latin typeface="Calibri"/>
+              </a:rPr>
+              <a:t>Question 5</a:t>
+            </a:r>
+          </a:p>
+        </p:txBody>
+      </p:sp>
+      <p:sp>
+        <p:nvSpPr>
+          <p:cNvPr id="3" name="TextBox 2"/>
+          <p:cNvSpPr txBox="1"/>
+          <p:nvPr/>
+        </p:nvSpPr>
+        <p:spPr>
+          <a:xfrm>
+            <a:off x="548640" y="594360"/>
+            <a:ext cx="11091672" cy="640080"/>
+          </a:xfrm>
+          <a:prstGeom prst="rect">
+            <a:avLst/>
+          </a:prstGeom>
+          <a:noFill/>
+        </p:spPr>
+        <p:txBody>
+          <a:bodyPr wrap="square">
+            <a:spAutoFit/>
+          </a:bodyPr>
+          <a:lstStyle/>
+          <a:p>
+            <a:r>
+              <a:rPr sz="3000" b="1" i="0">
+                <a:solidFill>
+                  <a:srgbClr val="000000"/>
+                </a:solidFill>
+                <a:latin typeface="Calibri"/>
+              </a:rPr>
+              <a:t>Why Is Equal Weighting Inside the Frontier?</a:t>
+            </a:r>
+          </a:p>
+        </p:txBody>
+      </p:sp>
+      <p:sp>
+        <p:nvSpPr>
+          <p:cNvPr id="4" name="TextBox 3"/>
+          <p:cNvSpPr txBox="1"/>
+          <p:nvPr/>
+        </p:nvSpPr>
+        <p:spPr>
+          <a:xfrm>
+            <a:off x="548640" y="1280160"/>
+            <a:ext cx="11091672" cy="457200"/>
+          </a:xfrm>
+          <a:prstGeom prst="rect">
+            <a:avLst/>
+          </a:prstGeom>
+          <a:noFill/>
+        </p:spPr>
+        <p:txBody>
+          <a:bodyPr wrap="square">
+            <a:spAutoFit/>
+          </a:bodyPr>
+          <a:lstStyle/>
+          <a:p>
+            <a:r>
+              <a:rPr sz="2000" b="1" i="0">
+                <a:solidFill>
+                  <a:srgbClr val="1F3A5F"/>
+                </a:solidFill>
+                <a:latin typeface="Calibri"/>
+              </a:rPr>
+              <a:t>Answer: </a:t>
+            </a:r>
+            <a:r>
+              <a:rPr sz="2000" b="0" i="0">
+                <a:solidFill>
+                  <a:srgbClr val="1F3A5F"/>
+                </a:solidFill>
+                <a:latin typeface="Calibri"/>
+              </a:rPr>
+              <a:t>A — equal weighting ignores the covariance structure.</a:t>
+            </a:r>
+          </a:p>
+        </p:txBody>
+      </p:sp>
+      <p:sp>
+        <p:nvSpPr>
+          <p:cNvPr id="5" name="TextBox 4"/>
+          <p:cNvSpPr txBox="1"/>
+          <p:nvPr/>
+        </p:nvSpPr>
+        <p:spPr>
+          <a:xfrm>
+            <a:off x="548640" y="2011680"/>
+            <a:ext cx="11091672" cy="2743200"/>
+          </a:xfrm>
+          <a:prstGeom prst="rect">
+            <a:avLst/>
+          </a:prstGeom>
+          <a:noFill/>
+        </p:spPr>
+        <p:txBody>
+          <a:bodyPr wrap="square">
+            <a:spAutoFit/>
+          </a:bodyPr>
+          <a:lstStyle/>
+          <a:p>
+            <a:pPr marL="274320" indent="-274320">
+              <a:spcAft>
+                <a:spcPts val="1400"/>
+              </a:spcAft>
+              <a:buFont typeface="Arial"/>
+              <a:buChar char="•"/>
+            </a:pPr>
+            <a:r>
+              <a:rPr sz="2000" b="0" i="0">
+                <a:solidFill>
+                  <a:srgbClr val="000000"/>
+                </a:solidFill>
+                <a:latin typeface="Calibri"/>
+              </a:rPr>
+              <a:t>Equal weights do not adjust to differences in expected returns, variances, or covariances.</a:t>
+            </a:r>
+          </a:p>
+          <a:p>
+            <a:pPr marL="274320" indent="-274320">
+              <a:spcAft>
+                <a:spcPts val="1400"/>
+              </a:spcAft>
+              <a:buFont typeface="Arial"/>
+              <a:buChar char="•"/>
+            </a:pPr>
+            <a:r>
+              <a:rPr sz="2000" b="0" i="0">
+                <a:solidFill>
+                  <a:srgbClr val="000000"/>
+                </a:solidFill>
+                <a:latin typeface="Calibri"/>
+              </a:rPr>
+              <a:t>In this example, optimized weights achieve the same expected return with lower risk.</a:t>
+            </a:r>
+          </a:p>
+          <a:p>
+            <a:pPr marL="274320" indent="-274320">
+              <a:spcAft>
+                <a:spcPts val="1400"/>
+              </a:spcAft>
+              <a:buFont typeface="Arial"/>
+              <a:buChar char="•"/>
+            </a:pPr>
+            <a:r>
+              <a:rPr sz="2000" b="0" i="0">
+                <a:solidFill>
+                  <a:srgbClr val="000000"/>
+                </a:solidFill>
+                <a:latin typeface="Calibri"/>
+              </a:rPr>
+              <a:t>Equal weighting can be efficient in special cases; identical assets are not a necessary condition.</a:t>
+            </a:r>
+          </a:p>
+        </p:txBody>
+      </p:sp>
+      <p:sp>
+        <p:nvSpPr>
+          <p:cNvPr id="6" name="Rectangle 5"/>
+          <p:cNvSpPr/>
+          <p:nvPr/>
+        </p:nvSpPr>
+        <p:spPr>
+          <a:xfrm>
+            <a:off x="548640" y="4983480"/>
+            <a:ext cx="11091672" cy="914400"/>
+          </a:xfrm>
+          <a:prstGeom prst="rect">
+            <a:avLst/>
+          </a:prstGeom>
+          <a:solidFill>
+            <a:srgbClr val="E9EEF4"/>
+          </a:solidFill>
+          <a:ln>
+            <a:noFill/>
+          </a:ln>
+          <a:effectLst/>
+        </p:spPr>
+        <p:style>
+          <a:lnRef idx="1">
+            <a:schemeClr val="accent1"/>
+          </a:lnRef>
+          <a:fillRef idx="3">
+            <a:schemeClr val="accent1"/>
+          </a:fillRef>
+          <a:effectRef idx="2">
+            <a:schemeClr val="accent1"/>
+          </a:effectRef>
+          <a:fontRef idx="minor">
+            <a:schemeClr val="lt1"/>
+          </a:fontRef>
+        </p:style>
+        <p:txBody>
+          <a:bodyPr rtlCol="0" anchor="ctr" wrap="square" lIns="228600" rIns="228600"/>
+          <a:lstStyle/>
+          <a:p>
+            <a:pPr algn="l"/>
+            <a:r>
+              <a:rPr sz="2000" b="1" i="0">
+                <a:solidFill>
+                  <a:srgbClr val="1F3A5F"/>
+                </a:solidFill>
+                <a:latin typeface="Calibri"/>
+              </a:rPr>
+              <a:t>Takeaway: </a:t>
+            </a:r>
+            <a:r>
+              <a:rPr sz="2000" b="0" i="0">
+                <a:solidFill>
+                  <a:srgbClr val="000000"/>
+                </a:solidFill>
+                <a:latin typeface="Calibri"/>
+              </a:rPr>
+              <a:t>Equal allocations do not automatically produce efficient diversification.</a:t>
+            </a:r>
+          </a:p>
+        </p:txBody>
+      </p:sp>
+      <p:sp>
+        <p:nvSpPr>
+          <p:cNvPr id="7" name="TextBox 6"/>
+          <p:cNvSpPr txBox="1"/>
+          <p:nvPr/>
+        </p:nvSpPr>
+        <p:spPr>
+          <a:xfrm>
+            <a:off x="548640" y="6263640"/>
+            <a:ext cx="6400800" cy="411480"/>
+          </a:xfrm>
+          <a:prstGeom prst="rect">
+            <a:avLst/>
+          </a:prstGeom>
+          <a:noFill/>
+        </p:spPr>
+        <p:txBody>
+          <a:bodyPr wrap="square">
+            <a:spAutoFit/>
+          </a:bodyPr>
+          <a:lstStyle/>
+          <a:p>
+            <a:r>
+              <a:rPr sz="1400" b="0" i="0">
+                <a:solidFill>
+                  <a:srgbClr val="595959"/>
+                </a:solidFill>
+                <a:latin typeface="Calibri"/>
+              </a:rPr>
+              <a:t>Sheet: Sec 3A - 5-Stock Demo</a:t>
+            </a:r>
+          </a:p>
+        </p:txBody>
+      </p:sp>
+      <p:sp>
+        <p:nvSpPr>
+          <p:cNvPr id="8" name="TextBox 7"/>
+          <p:cNvSpPr txBox="1"/>
+          <p:nvPr/>
+        </p:nvSpPr>
+        <p:spPr>
+          <a:xfrm>
+            <a:off x="7040880" y="6263640"/>
+            <a:ext cx="4599432" cy="411480"/>
+          </a:xfrm>
+          <a:prstGeom prst="rect">
+            <a:avLst/>
+          </a:prstGeom>
+          <a:noFill/>
+        </p:spPr>
+        <p:txBody>
+          <a:bodyPr wrap="square">
+            <a:spAutoFit/>
+          </a:bodyPr>
+          <a:lstStyle/>
+          <a:p>
+            <a:pPr algn="r"/>
+            <a:r>
+              <a:rPr sz="1400" b="0" i="0">
+                <a:solidFill>
+                  <a:srgbClr val="595959"/>
+                </a:solidFill>
+                <a:latin typeface="Calibri"/>
+              </a:rPr>
+              <a:t>Cells A136:A140</a:t>
+            </a:r>
+          </a:p>
+        </p:txBody>
+      </p:sp>
+    </p:spTree>
+  </p:cSld>
+  <p:clrMapOvr>
+    <a:masterClrMapping/>
+  </p:clrMapOvr>
+</p:sld>
+</file>
+
+<file path=ppt/slides/slide6.xml><?xml version="1.0" encoding="utf-8"?>
+<p:sld xmlns:a="http://schemas.openxmlformats.org/drawingml/2006/main" xmlns:p="http://schemas.openxmlformats.org/presentationml/2006/main" xmlns:r="http://schemas.openxmlformats.org/officeDocument/2006/relationships">
+  <p:cSld>
+    <p:spTree>
+      <p:nvGrpSpPr>
+        <p:cNvPr id="1" name=""/>
+        <p:cNvGrpSpPr/>
+        <p:nvPr/>
+      </p:nvGrpSpPr>
+      <p:grpSpPr/>
+      <p:sp>
+        <p:nvSpPr>
+          <p:cNvPr id="2" name="TextBox 1"/>
+          <p:cNvSpPr txBox="1"/>
+          <p:nvPr/>
+        </p:nvSpPr>
+        <p:spPr>
+          <a:xfrm>
+            <a:off x="548640" y="274320"/>
+            <a:ext cx="11091672" cy="365760"/>
+          </a:xfrm>
+          <a:prstGeom prst="rect">
+            <a:avLst/>
+          </a:prstGeom>
+          <a:noFill/>
+        </p:spPr>
+        <p:txBody>
+          <a:bodyPr wrap="square">
+            <a:spAutoFit/>
+          </a:bodyPr>
+          <a:lstStyle/>
+          <a:p>
+            <a:r>
+              <a:rPr sz="1600" b="0" i="0">
+                <a:solidFill>
+                  <a:srgbClr val="595959"/>
+                </a:solidFill>
+                <a:latin typeface="Calibri"/>
+              </a:rPr>
+              <a:t>Question 6</a:t>
+            </a:r>
+          </a:p>
+        </p:txBody>
+      </p:sp>
+      <p:sp>
+        <p:nvSpPr>
+          <p:cNvPr id="3" name="TextBox 2"/>
+          <p:cNvSpPr txBox="1"/>
+          <p:nvPr/>
+        </p:nvSpPr>
+        <p:spPr>
+          <a:xfrm>
+            <a:off x="548640" y="594360"/>
+            <a:ext cx="11091672" cy="640080"/>
+          </a:xfrm>
+          <a:prstGeom prst="rect">
+            <a:avLst/>
+          </a:prstGeom>
+          <a:noFill/>
+        </p:spPr>
+        <p:txBody>
+          <a:bodyPr wrap="square">
+            <a:spAutoFit/>
+          </a:bodyPr>
+          <a:lstStyle/>
+          <a:p>
+            <a:r>
+              <a:rPr sz="3000" b="1" i="0">
+                <a:solidFill>
+                  <a:srgbClr val="000000"/>
+                </a:solidFill>
+                <a:latin typeface="Calibri"/>
+              </a:rPr>
+              <a:t>What Happens If AGG Is Removed?</a:t>
+            </a:r>
+          </a:p>
+        </p:txBody>
+      </p:sp>
+      <p:sp>
+        <p:nvSpPr>
+          <p:cNvPr id="4" name="TextBox 3"/>
+          <p:cNvSpPr txBox="1"/>
+          <p:nvPr/>
+        </p:nvSpPr>
+        <p:spPr>
+          <a:xfrm>
+            <a:off x="548640" y="1280160"/>
+            <a:ext cx="11091672" cy="457200"/>
+          </a:xfrm>
+          <a:prstGeom prst="rect">
+            <a:avLst/>
+          </a:prstGeom>
+          <a:noFill/>
+        </p:spPr>
+        <p:txBody>
+          <a:bodyPr wrap="square">
+            <a:spAutoFit/>
+          </a:bodyPr>
+          <a:lstStyle/>
+          <a:p>
+            <a:r>
+              <a:rPr sz="2000" b="1" i="0">
+                <a:solidFill>
+                  <a:srgbClr val="1F3A5F"/>
+                </a:solidFill>
+                <a:latin typeface="Calibri"/>
+              </a:rPr>
+              <a:t>Answer: </a:t>
+            </a:r>
+            <a:r>
+              <a:rPr sz="2000" b="0" i="0">
+                <a:solidFill>
+                  <a:srgbClr val="1F3A5F"/>
+                </a:solidFill>
+                <a:latin typeface="Calibri"/>
+              </a:rPr>
+              <a:t>B — opportunities most likely worsen.</a:t>
+            </a:r>
+          </a:p>
+        </p:txBody>
+      </p:sp>
+      <p:sp>
+        <p:nvSpPr>
+          <p:cNvPr id="5" name="TextBox 4"/>
+          <p:cNvSpPr txBox="1"/>
+          <p:nvPr/>
+        </p:nvSpPr>
+        <p:spPr>
+          <a:xfrm>
+            <a:off x="548640" y="2011680"/>
+            <a:ext cx="11091672" cy="2743200"/>
+          </a:xfrm>
+          <a:prstGeom prst="rect">
+            <a:avLst/>
+          </a:prstGeom>
+          <a:noFill/>
+        </p:spPr>
+        <p:txBody>
+          <a:bodyPr wrap="square">
+            <a:spAutoFit/>
+          </a:bodyPr>
+          <a:lstStyle/>
+          <a:p>
+            <a:pPr marL="274320" indent="-274320">
+              <a:spcAft>
+                <a:spcPts val="1400"/>
+              </a:spcAft>
+              <a:buFont typeface="Arial"/>
+              <a:buChar char="•"/>
+            </a:pPr>
+            <a:r>
+              <a:rPr sz="2000" b="0" i="0">
+                <a:solidFill>
+                  <a:srgbClr val="000000"/>
+                </a:solidFill>
+                <a:latin typeface="Calibri"/>
+              </a:rPr>
+              <a:t>Removing AGG is equivalent to imposing the additional constraint </a:t>
+            </a:r>
+            <a:r>
+              <a:rPr sz="2000" b="1" i="0">
+                <a:solidFill>
+                  <a:srgbClr val="000000"/>
+                </a:solidFill>
+                <a:latin typeface="Calibri"/>
+              </a:rPr>
+              <a:t>w</a:t>
+            </a:r>
+            <a:r>
+              <a:rPr sz="2000" b="1" i="0" baseline="-25000">
+                <a:solidFill>
+                  <a:srgbClr val="000000"/>
+                </a:solidFill>
+                <a:latin typeface="Calibri"/>
+              </a:rPr>
+              <a:t>AGG</a:t>
+            </a:r>
+            <a:r>
+              <a:rPr sz="2000" b="1" i="0">
+                <a:solidFill>
+                  <a:srgbClr val="000000"/>
+                </a:solidFill>
+                <a:latin typeface="Calibri"/>
+              </a:rPr>
+              <a:t> = 0</a:t>
+            </a:r>
+            <a:r>
+              <a:rPr sz="2000" b="0" i="0">
+                <a:solidFill>
+                  <a:srgbClr val="000000"/>
+                </a:solidFill>
+                <a:latin typeface="Calibri"/>
+              </a:rPr>
+              <a:t>.</a:t>
+            </a:r>
+          </a:p>
+          <a:p>
+            <a:pPr marL="274320" indent="-274320">
+              <a:spcAft>
+                <a:spcPts val="1400"/>
+              </a:spcAft>
+              <a:buFont typeface="Arial"/>
+              <a:buChar char="•"/>
+            </a:pPr>
+            <a:r>
+              <a:rPr sz="2000" b="0" i="0">
+                <a:solidFill>
+                  <a:srgbClr val="000000"/>
+                </a:solidFill>
+                <a:latin typeface="Calibri"/>
+              </a:rPr>
+              <a:t>This shrinks the feasible set, so the best attainable opportunities cannot improve.</a:t>
+            </a:r>
+          </a:p>
+          <a:p>
+            <a:pPr marL="274320" indent="-274320">
+              <a:spcAft>
+                <a:spcPts val="1400"/>
+              </a:spcAft>
+              <a:buFont typeface="Arial"/>
+              <a:buChar char="•"/>
+            </a:pPr>
+            <a:r>
+              <a:rPr sz="2000" b="0" i="0">
+                <a:solidFill>
+                  <a:srgbClr val="000000"/>
+                </a:solidFill>
+                <a:latin typeface="Calibri"/>
+              </a:rPr>
+              <a:t>Losing a low-variance diversifier may particularly weaken low-risk portfolios; the effect also depends on covariances.</a:t>
+            </a:r>
+          </a:p>
+        </p:txBody>
+      </p:sp>
+      <p:sp>
+        <p:nvSpPr>
+          <p:cNvPr id="6" name="Rectangle 5"/>
+          <p:cNvSpPr/>
+          <p:nvPr/>
+        </p:nvSpPr>
+        <p:spPr>
+          <a:xfrm>
+            <a:off x="548640" y="4983480"/>
+            <a:ext cx="11091672" cy="914400"/>
+          </a:xfrm>
+          <a:prstGeom prst="rect">
+            <a:avLst/>
+          </a:prstGeom>
+          <a:solidFill>
+            <a:srgbClr val="E9EEF4"/>
+          </a:solidFill>
+          <a:ln>
+            <a:noFill/>
+          </a:ln>
+          <a:effectLst/>
+        </p:spPr>
+        <p:style>
+          <a:lnRef idx="1">
+            <a:schemeClr val="accent1"/>
+          </a:lnRef>
+          <a:fillRef idx="3">
+            <a:schemeClr val="accent1"/>
+          </a:fillRef>
+          <a:effectRef idx="2">
+            <a:schemeClr val="accent1"/>
+          </a:effectRef>
+          <a:fontRef idx="minor">
+            <a:schemeClr val="lt1"/>
+          </a:fontRef>
+        </p:style>
+        <p:txBody>
+          <a:bodyPr rtlCol="0" anchor="ctr" wrap="square" lIns="228600" rIns="228600"/>
+          <a:lstStyle/>
+          <a:p>
+            <a:pPr algn="l"/>
+            <a:r>
+              <a:rPr sz="2000" b="1" i="0">
+                <a:solidFill>
+                  <a:srgbClr val="1F3A5F"/>
+                </a:solidFill>
+                <a:latin typeface="Calibri"/>
+              </a:rPr>
+              <a:t>Takeaway: </a:t>
+            </a:r>
+            <a:r>
+              <a:rPr sz="2000" b="0" i="0">
+                <a:solidFill>
+                  <a:srgbClr val="000000"/>
+                </a:solidFill>
+                <a:latin typeface="Calibri"/>
+              </a:rPr>
+              <a:t>The frontier may worsen or remain unchanged at some points—not necessarily shift everywhere.</a:t>
+            </a:r>
+          </a:p>
+        </p:txBody>
+      </p:sp>
+      <p:sp>
+        <p:nvSpPr>
+          <p:cNvPr id="7" name="TextBox 6"/>
+          <p:cNvSpPr txBox="1"/>
+          <p:nvPr/>
+        </p:nvSpPr>
+        <p:spPr>
+          <a:xfrm>
+            <a:off x="548640" y="6263640"/>
+            <a:ext cx="6400800" cy="411480"/>
+          </a:xfrm>
+          <a:prstGeom prst="rect">
+            <a:avLst/>
+          </a:prstGeom>
+          <a:noFill/>
+        </p:spPr>
+        <p:txBody>
+          <a:bodyPr wrap="square">
+            <a:spAutoFit/>
+          </a:bodyPr>
+          <a:lstStyle/>
+          <a:p>
+            <a:r>
+              <a:rPr sz="1400" b="0" i="0">
+                <a:solidFill>
+                  <a:srgbClr val="595959"/>
+                </a:solidFill>
+                <a:latin typeface="Calibri"/>
+              </a:rPr>
+              <a:t>Sheet: Sec 3A - 5-Stock Demo</a:t>
+            </a:r>
+          </a:p>
+        </p:txBody>
+      </p:sp>
+      <p:sp>
+        <p:nvSpPr>
+          <p:cNvPr id="8" name="TextBox 7"/>
+          <p:cNvSpPr txBox="1"/>
+          <p:nvPr/>
+        </p:nvSpPr>
+        <p:spPr>
+          <a:xfrm>
+            <a:off x="7040880" y="6263640"/>
+            <a:ext cx="4599432" cy="411480"/>
+          </a:xfrm>
+          <a:prstGeom prst="rect">
+            <a:avLst/>
+          </a:prstGeom>
+          <a:noFill/>
+        </p:spPr>
+        <p:txBody>
+          <a:bodyPr wrap="square">
+            <a:spAutoFit/>
+          </a:bodyPr>
+          <a:lstStyle/>
+          <a:p>
+            <a:pPr algn="r"/>
+            <a:r>
+              <a:rPr sz="1400" b="0" i="0">
+                <a:solidFill>
+                  <a:srgbClr val="595959"/>
+                </a:solidFill>
+                <a:latin typeface="Calibri"/>
+              </a:rPr>
+              <a:t>Cells A143:A147</a:t>
+            </a:r>
+          </a:p>
+        </p:txBody>
+      </p:sp>
+    </p:spTree>
+  </p:cSld>
+  <p:clrMapOvr>
+    <a:masterClrMapping/>
+  </p:clrMapOvr>
+</p:sld>
+</file>
+
+<file path=ppt/slides/slide7.xml><?xml version="1.0" encoding="utf-8"?>
+<p:sld xmlns:a="http://schemas.openxmlformats.org/drawingml/2006/main" xmlns:p="http://schemas.openxmlformats.org/presentationml/2006/main" xmlns:r="http://schemas.openxmlformats.org/officeDocument/2006/relationships">
+  <p:cSld>
+    <p:spTree>
+      <p:nvGrpSpPr>
+        <p:cNvPr id="1" name=""/>
+        <p:cNvGrpSpPr/>
+        <p:nvPr/>
+      </p:nvGrpSpPr>
+      <p:grpSpPr/>
+      <p:sp>
+        <p:nvSpPr>
+          <p:cNvPr id="2" name="TextBox 1"/>
+          <p:cNvSpPr txBox="1"/>
+          <p:nvPr/>
+        </p:nvSpPr>
+        <p:spPr>
+          <a:xfrm>
+            <a:off x="548640" y="274320"/>
+            <a:ext cx="11091672" cy="365760"/>
+          </a:xfrm>
+          <a:prstGeom prst="rect">
+            <a:avLst/>
+          </a:prstGeom>
+          <a:noFill/>
+        </p:spPr>
+        <p:txBody>
+          <a:bodyPr wrap="square">
+            <a:spAutoFit/>
+          </a:bodyPr>
+          <a:lstStyle/>
+          <a:p>
+            <a:r>
+              <a:rPr sz="1600" b="0" i="0">
+                <a:solidFill>
+                  <a:srgbClr val="595959"/>
+                </a:solidFill>
+                <a:latin typeface="Calibri"/>
+              </a:rPr>
+              <a:t>Question 7</a:t>
+            </a:r>
+          </a:p>
+        </p:txBody>
+      </p:sp>
+      <p:sp>
+        <p:nvSpPr>
+          <p:cNvPr id="3" name="TextBox 2"/>
+          <p:cNvSpPr txBox="1"/>
+          <p:nvPr/>
+        </p:nvSpPr>
+        <p:spPr>
+          <a:xfrm>
+            <a:off x="548640" y="594360"/>
+            <a:ext cx="11091672" cy="640080"/>
+          </a:xfrm>
+          <a:prstGeom prst="rect">
+            <a:avLst/>
+          </a:prstGeom>
+          <a:noFill/>
+        </p:spPr>
+        <p:txBody>
+          <a:bodyPr wrap="square">
+            <a:spAutoFit/>
+          </a:bodyPr>
+          <a:lstStyle/>
+          <a:p>
+            <a:r>
+              <a:rPr sz="3000" b="1" i="0">
+                <a:solidFill>
+                  <a:srgbClr val="000000"/>
+                </a:solidFill>
+                <a:latin typeface="Calibri"/>
+              </a:rPr>
+              <a:t>What Is the Tangency Portfolio?</a:t>
+            </a:r>
+          </a:p>
+        </p:txBody>
+      </p:sp>
+      <p:sp>
+        <p:nvSpPr>
+          <p:cNvPr id="4" name="TextBox 3"/>
+          <p:cNvSpPr txBox="1"/>
+          <p:nvPr/>
+        </p:nvSpPr>
+        <p:spPr>
+          <a:xfrm>
+            <a:off x="548640" y="1280160"/>
+            <a:ext cx="11091672" cy="457200"/>
+          </a:xfrm>
+          <a:prstGeom prst="rect">
+            <a:avLst/>
+          </a:prstGeom>
+          <a:noFill/>
+        </p:spPr>
+        <p:txBody>
+          <a:bodyPr wrap="square">
+            <a:spAutoFit/>
+          </a:bodyPr>
+          <a:lstStyle/>
+          <a:p>
+            <a:r>
+              <a:rPr sz="2000" b="1" i="0">
+                <a:solidFill>
+                  <a:srgbClr val="1F3A5F"/>
+                </a:solidFill>
+                <a:latin typeface="Calibri"/>
+              </a:rPr>
+              <a:t>Answer: </a:t>
+            </a:r>
+            <a:r>
+              <a:rPr sz="2000" b="0" i="0">
+                <a:solidFill>
+                  <a:srgbClr val="1F3A5F"/>
+                </a:solidFill>
+                <a:latin typeface="Calibri"/>
+              </a:rPr>
+              <a:t>C — the maximum Sharpe ratio portfolio.</a:t>
+            </a:r>
+          </a:p>
+        </p:txBody>
+      </p:sp>
+      <p:sp>
+        <p:nvSpPr>
+          <p:cNvPr id="5" name="TextBox 4"/>
+          <p:cNvSpPr txBox="1"/>
+          <p:nvPr/>
+        </p:nvSpPr>
+        <p:spPr>
+          <a:xfrm>
+            <a:off x="548640" y="2011680"/>
+            <a:ext cx="11091672" cy="2743200"/>
+          </a:xfrm>
+          <a:prstGeom prst="rect">
+            <a:avLst/>
+          </a:prstGeom>
+          <a:noFill/>
+        </p:spPr>
+        <p:txBody>
+          <a:bodyPr wrap="square">
+            <a:spAutoFit/>
+          </a:bodyPr>
+          <a:lstStyle/>
+          <a:p>
+            <a:pPr marL="274320" indent="-274320">
+              <a:spcAft>
+                <a:spcPts val="1400"/>
+              </a:spcAft>
+              <a:buFont typeface="Arial"/>
+              <a:buChar char="•"/>
+            </a:pPr>
+            <a:r>
+              <a:rPr sz="2000" b="0" i="0">
+                <a:solidFill>
+                  <a:srgbClr val="000000"/>
+                </a:solidFill>
+                <a:latin typeface="Calibri"/>
+              </a:rPr>
+              <a:t>The line from the risk-free rate to a portfolio has slope </a:t>
+            </a:r>
+            <a:r>
+              <a:rPr sz="2000" b="1" i="0">
+                <a:solidFill>
+                  <a:srgbClr val="000000"/>
+                </a:solidFill>
+                <a:latin typeface="Calibri"/>
+              </a:rPr>
+              <a:t>(E[R</a:t>
+            </a:r>
+            <a:r>
+              <a:rPr sz="2000" b="1" i="0" baseline="-25000">
+                <a:solidFill>
+                  <a:srgbClr val="000000"/>
+                </a:solidFill>
+                <a:latin typeface="Calibri"/>
+              </a:rPr>
+              <a:t>p</a:t>
+            </a:r>
+            <a:r>
+              <a:rPr sz="2000" b="1" i="0">
+                <a:solidFill>
+                  <a:srgbClr val="000000"/>
+                </a:solidFill>
+                <a:latin typeface="Calibri"/>
+              </a:rPr>
+              <a:t>] − R</a:t>
+            </a:r>
+            <a:r>
+              <a:rPr sz="2000" b="1" i="0" baseline="-25000">
+                <a:solidFill>
+                  <a:srgbClr val="000000"/>
+                </a:solidFill>
+                <a:latin typeface="Calibri"/>
+              </a:rPr>
+              <a:t>f</a:t>
+            </a:r>
+            <a:r>
+              <a:rPr sz="2000" b="1" i="0">
+                <a:solidFill>
+                  <a:srgbClr val="000000"/>
+                </a:solidFill>
+                <a:latin typeface="Calibri"/>
+              </a:rPr>
+              <a:t>) / σ</a:t>
+            </a:r>
+            <a:r>
+              <a:rPr sz="2000" b="1" i="0" baseline="-25000">
+                <a:solidFill>
+                  <a:srgbClr val="000000"/>
+                </a:solidFill>
+                <a:latin typeface="Calibri"/>
+              </a:rPr>
+              <a:t>p</a:t>
+            </a:r>
+            <a:r>
+              <a:rPr sz="2000" b="0" i="0">
+                <a:solidFill>
+                  <a:srgbClr val="000000"/>
+                </a:solidFill>
+                <a:latin typeface="Calibri"/>
+              </a:rPr>
+              <a:t>.</a:t>
+            </a:r>
+          </a:p>
+          <a:p>
+            <a:pPr marL="274320" indent="-274320">
+              <a:spcAft>
+                <a:spcPts val="1400"/>
+              </a:spcAft>
+              <a:buFont typeface="Arial"/>
+              <a:buChar char="•"/>
+            </a:pPr>
+            <a:r>
+              <a:rPr sz="2000" b="0" i="0">
+                <a:solidFill>
+                  <a:srgbClr val="000000"/>
+                </a:solidFill>
+                <a:latin typeface="Calibri"/>
+              </a:rPr>
+              <a:t>That slope is the portfolio’s Sharpe ratio: expected excess return per unit of volatility.</a:t>
+            </a:r>
+          </a:p>
+          <a:p>
+            <a:pPr marL="274320" indent="-274320">
+              <a:spcAft>
+                <a:spcPts val="1400"/>
+              </a:spcAft>
+              <a:buFont typeface="Arial"/>
+              <a:buChar char="•"/>
+            </a:pPr>
+            <a:r>
+              <a:rPr sz="2000" b="0" i="0">
+                <a:solidFill>
+                  <a:srgbClr val="000000"/>
+                </a:solidFill>
+                <a:latin typeface="Calibri"/>
+              </a:rPr>
+              <a:t>The steepest attainable line touches the frontier at the maximum Sharpe portfolio.</a:t>
+            </a:r>
+          </a:p>
+        </p:txBody>
+      </p:sp>
+      <p:sp>
+        <p:nvSpPr>
+          <p:cNvPr id="6" name="Rectangle 5"/>
+          <p:cNvSpPr/>
+          <p:nvPr/>
+        </p:nvSpPr>
+        <p:spPr>
+          <a:xfrm>
+            <a:off x="548640" y="4983480"/>
+            <a:ext cx="11091672" cy="914400"/>
+          </a:xfrm>
+          <a:prstGeom prst="rect">
+            <a:avLst/>
+          </a:prstGeom>
+          <a:solidFill>
+            <a:srgbClr val="E9EEF4"/>
+          </a:solidFill>
+          <a:ln>
+            <a:noFill/>
+          </a:ln>
+          <a:effectLst/>
+        </p:spPr>
+        <p:style>
+          <a:lnRef idx="1">
+            <a:schemeClr val="accent1"/>
+          </a:lnRef>
+          <a:fillRef idx="3">
+            <a:schemeClr val="accent1"/>
+          </a:fillRef>
+          <a:effectRef idx="2">
+            <a:schemeClr val="accent1"/>
+          </a:effectRef>
+          <a:fontRef idx="minor">
+            <a:schemeClr val="lt1"/>
+          </a:fontRef>
+        </p:style>
+        <p:txBody>
+          <a:bodyPr rtlCol="0" anchor="ctr" wrap="square" lIns="228600" rIns="228600"/>
+          <a:lstStyle/>
+          <a:p>
+            <a:pPr algn="l"/>
+            <a:r>
+              <a:rPr sz="2000" b="1" i="0">
+                <a:solidFill>
+                  <a:srgbClr val="1F3A5F"/>
+                </a:solidFill>
+                <a:latin typeface="Calibri"/>
+              </a:rPr>
+              <a:t>Takeaway: </a:t>
+            </a:r>
+            <a:r>
+              <a:rPr sz="2000" b="0" i="0">
+                <a:solidFill>
+                  <a:srgbClr val="000000"/>
+                </a:solidFill>
+                <a:latin typeface="Calibri"/>
+              </a:rPr>
+              <a:t>Tangency maximizes excess return per unit of risk—not return alone.</a:t>
+            </a:r>
+          </a:p>
+        </p:txBody>
+      </p:sp>
+      <p:sp>
+        <p:nvSpPr>
+          <p:cNvPr id="7" name="TextBox 6"/>
+          <p:cNvSpPr txBox="1"/>
+          <p:nvPr/>
+        </p:nvSpPr>
+        <p:spPr>
+          <a:xfrm>
+            <a:off x="548640" y="6263640"/>
+            <a:ext cx="6400800" cy="411480"/>
+          </a:xfrm>
+          <a:prstGeom prst="rect">
+            <a:avLst/>
+          </a:prstGeom>
+          <a:noFill/>
+        </p:spPr>
+        <p:txBody>
+          <a:bodyPr wrap="square">
+            <a:spAutoFit/>
+          </a:bodyPr>
+          <a:lstStyle/>
+          <a:p>
+            <a:r>
+              <a:rPr sz="1400" b="0" i="0">
+                <a:solidFill>
+                  <a:srgbClr val="595959"/>
+                </a:solidFill>
+                <a:latin typeface="Calibri"/>
+              </a:rPr>
+              <a:t>Sheet: Sec 3A - 5-Stock Demo</a:t>
+            </a:r>
+          </a:p>
+        </p:txBody>
+      </p:sp>
+      <p:sp>
+        <p:nvSpPr>
+          <p:cNvPr id="8" name="TextBox 7"/>
+          <p:cNvSpPr txBox="1"/>
+          <p:nvPr/>
+        </p:nvSpPr>
+        <p:spPr>
+          <a:xfrm>
+            <a:off x="7040880" y="6263640"/>
+            <a:ext cx="4599432" cy="411480"/>
+          </a:xfrm>
+          <a:prstGeom prst="rect">
+            <a:avLst/>
+          </a:prstGeom>
+          <a:noFill/>
+        </p:spPr>
+        <p:txBody>
+          <a:bodyPr wrap="square">
+            <a:spAutoFit/>
+          </a:bodyPr>
+          <a:lstStyle/>
+          <a:p>
+            <a:pPr algn="r"/>
+            <a:r>
+              <a:rPr sz="1400" b="0" i="0">
+                <a:solidFill>
+                  <a:srgbClr val="595959"/>
+                </a:solidFill>
+                <a:latin typeface="Calibri"/>
+              </a:rPr>
+              <a:t>Cells A180:A184</a:t>
+            </a:r>
+          </a:p>
+        </p:txBody>
+      </p:sp>
+    </p:spTree>
+  </p:cSld>
+  <p:clrMapOvr>
+    <a:masterClrMapping/>
+  </p:clrMapOvr>
+</p:sld>
+</file>
+
+<file path=ppt/slides/slide8.xml><?xml version="1.0" encoding="utf-8"?>
+<p:sld xmlns:a="http://schemas.openxmlformats.org/drawingml/2006/main" xmlns:p="http://schemas.openxmlformats.org/presentationml/2006/main" xmlns:r="http://schemas.openxmlformats.org/officeDocument/2006/relationships">
+  <p:cSld>
+    <p:spTree>
+      <p:nvGrpSpPr>
+        <p:cNvPr id="1" name=""/>
+        <p:cNvGrpSpPr/>
+        <p:nvPr/>
+      </p:nvGrpSpPr>
+      <p:grpSpPr/>
+      <p:sp>
+        <p:nvSpPr>
+          <p:cNvPr id="2" name="TextBox 1"/>
+          <p:cNvSpPr txBox="1"/>
+          <p:nvPr/>
+        </p:nvSpPr>
+        <p:spPr>
+          <a:xfrm>
+            <a:off x="548640" y="274320"/>
+            <a:ext cx="11091672" cy="365760"/>
+          </a:xfrm>
+          <a:prstGeom prst="rect">
+            <a:avLst/>
+          </a:prstGeom>
+          <a:noFill/>
+        </p:spPr>
+        <p:txBody>
+          <a:bodyPr wrap="square">
+            <a:spAutoFit/>
+          </a:bodyPr>
+          <a:lstStyle/>
+          <a:p>
+            <a:r>
+              <a:rPr sz="1600" b="0" i="0">
+                <a:solidFill>
+                  <a:srgbClr val="595959"/>
+                </a:solidFill>
+                <a:latin typeface="Calibri"/>
+              </a:rPr>
+              <a:t>Question 8</a:t>
+            </a:r>
+          </a:p>
+        </p:txBody>
+      </p:sp>
+      <p:sp>
+        <p:nvSpPr>
+          <p:cNvPr id="3" name="TextBox 2"/>
+          <p:cNvSpPr txBox="1"/>
+          <p:nvPr/>
+        </p:nvSpPr>
+        <p:spPr>
+          <a:xfrm>
+            <a:off x="548640" y="594360"/>
+            <a:ext cx="11091672" cy="640080"/>
+          </a:xfrm>
+          <a:prstGeom prst="rect">
+            <a:avLst/>
+          </a:prstGeom>
+          <a:noFill/>
+        </p:spPr>
+        <p:txBody>
+          <a:bodyPr wrap="square">
+            <a:spAutoFit/>
+          </a:bodyPr>
+          <a:lstStyle/>
+          <a:p>
+            <a:r>
+              <a:rPr sz="3000" b="1" i="0">
+                <a:solidFill>
+                  <a:srgbClr val="000000"/>
+                </a:solidFill>
+                <a:latin typeface="Calibri"/>
+              </a:rPr>
+              <a:t>What Does VNQ’s Zero Weight Mean?</a:t>
+            </a:r>
+          </a:p>
+        </p:txBody>
+      </p:sp>
+      <p:sp>
+        <p:nvSpPr>
+          <p:cNvPr id="4" name="TextBox 3"/>
+          <p:cNvSpPr txBox="1"/>
+          <p:nvPr/>
+        </p:nvSpPr>
+        <p:spPr>
+          <a:xfrm>
+            <a:off x="548640" y="1280160"/>
+            <a:ext cx="11091672" cy="457200"/>
+          </a:xfrm>
+          <a:prstGeom prst="rect">
+            <a:avLst/>
+          </a:prstGeom>
+          <a:noFill/>
+        </p:spPr>
+        <p:txBody>
+          <a:bodyPr wrap="square">
+            <a:spAutoFit/>
+          </a:bodyPr>
+          <a:lstStyle/>
+          <a:p>
+            <a:r>
+              <a:rPr sz="2000" b="1" i="0">
+                <a:solidFill>
+                  <a:srgbClr val="1F3A5F"/>
+                </a:solidFill>
+                <a:latin typeface="Calibri"/>
+              </a:rPr>
+              <a:t>Answer: </a:t>
+            </a:r>
+            <a:r>
+              <a:rPr sz="2000" b="0" i="0">
+                <a:solidFill>
+                  <a:srgbClr val="1F3A5F"/>
+                </a:solidFill>
+                <a:latin typeface="Calibri"/>
+              </a:rPr>
+              <a:t>True — under the estimated inputs and no-shorting constraint.</a:t>
+            </a:r>
+          </a:p>
+        </p:txBody>
+      </p:sp>
+      <p:sp>
+        <p:nvSpPr>
+          <p:cNvPr id="5" name="TextBox 4"/>
+          <p:cNvSpPr txBox="1"/>
+          <p:nvPr/>
+        </p:nvSpPr>
+        <p:spPr>
+          <a:xfrm>
+            <a:off x="548640" y="2011680"/>
+            <a:ext cx="11091672" cy="2743200"/>
+          </a:xfrm>
+          <a:prstGeom prst="rect">
+            <a:avLst/>
+          </a:prstGeom>
+          <a:noFill/>
+        </p:spPr>
+        <p:txBody>
+          <a:bodyPr wrap="square">
+            <a:spAutoFit/>
+          </a:bodyPr>
+          <a:lstStyle/>
+          <a:p>
+            <a:pPr marL="274320" indent="-274320">
+              <a:spcAft>
+                <a:spcPts val="1400"/>
+              </a:spcAft>
+              <a:buFont typeface="Arial"/>
+              <a:buChar char="•"/>
+            </a:pPr>
+            <a:r>
+              <a:rPr sz="2000" b="0" i="0">
+                <a:solidFill>
+                  <a:srgbClr val="000000"/>
+                </a:solidFill>
+                <a:latin typeface="Calibri"/>
+              </a:rPr>
+              <a:t>At the global maximum, allocating positively to VNQ cannot produce a higher Sharpe ratio.</a:t>
+            </a:r>
+          </a:p>
+          <a:p>
+            <a:pPr marL="274320" indent="-274320">
+              <a:spcAft>
+                <a:spcPts val="1400"/>
+              </a:spcAft>
+              <a:buFont typeface="Arial"/>
+              <a:buChar char="•"/>
+            </a:pPr>
+            <a:r>
+              <a:rPr sz="2000" b="0" i="0">
+                <a:solidFill>
+                  <a:srgbClr val="000000"/>
+                </a:solidFill>
+                <a:latin typeface="Calibri"/>
+              </a:rPr>
+              <a:t>Zero weight reflects VNQ’s contribution relative to the available alternatives.</a:t>
+            </a:r>
+          </a:p>
+          <a:p>
+            <a:pPr marL="274320" indent="-274320">
+              <a:spcAft>
+                <a:spcPts val="1400"/>
+              </a:spcAft>
+              <a:buFont typeface="Arial"/>
+              <a:buChar char="•"/>
+            </a:pPr>
+            <a:r>
+              <a:rPr sz="2000" b="0" i="0">
+                <a:solidFill>
+                  <a:srgbClr val="000000"/>
+                </a:solidFill>
+                <a:latin typeface="Calibri"/>
+              </a:rPr>
+              <a:t>It does </a:t>
+            </a:r>
+            <a:r>
+              <a:rPr sz="2000" b="1" i="0">
+                <a:solidFill>
+                  <a:srgbClr val="000000"/>
+                </a:solidFill>
+                <a:latin typeface="Calibri"/>
+              </a:rPr>
+              <a:t>not</a:t>
+            </a:r>
+            <a:r>
+              <a:rPr sz="2000" b="0" i="0">
+                <a:solidFill>
+                  <a:srgbClr val="000000"/>
+                </a:solidFill>
+                <a:latin typeface="Calibri"/>
+              </a:rPr>
+              <a:t> mean VNQ is always unattractive; different inputs or constraints can change its role.</a:t>
+            </a:r>
+          </a:p>
+        </p:txBody>
+      </p:sp>
+      <p:sp>
+        <p:nvSpPr>
+          <p:cNvPr id="6" name="Rectangle 5"/>
+          <p:cNvSpPr/>
+          <p:nvPr/>
+        </p:nvSpPr>
+        <p:spPr>
+          <a:xfrm>
+            <a:off x="548640" y="4983480"/>
+            <a:ext cx="11091672" cy="914400"/>
+          </a:xfrm>
+          <a:prstGeom prst="rect">
+            <a:avLst/>
+          </a:prstGeom>
+          <a:solidFill>
+            <a:srgbClr val="E9EEF4"/>
+          </a:solidFill>
+          <a:ln>
+            <a:noFill/>
+          </a:ln>
+          <a:effectLst/>
+        </p:spPr>
+        <p:style>
+          <a:lnRef idx="1">
+            <a:schemeClr val="accent1"/>
+          </a:lnRef>
+          <a:fillRef idx="3">
+            <a:schemeClr val="accent1"/>
+          </a:fillRef>
+          <a:effectRef idx="2">
+            <a:schemeClr val="accent1"/>
+          </a:effectRef>
+          <a:fontRef idx="minor">
+            <a:schemeClr val="lt1"/>
+          </a:fontRef>
+        </p:style>
+        <p:txBody>
+          <a:bodyPr rtlCol="0" anchor="ctr" wrap="square" lIns="228600" rIns="228600"/>
+          <a:lstStyle/>
+          <a:p>
+            <a:pPr algn="l"/>
+            <a:r>
+              <a:rPr sz="2000" b="1" i="0">
+                <a:solidFill>
+                  <a:srgbClr val="1F3A5F"/>
+                </a:solidFill>
+                <a:latin typeface="Calibri"/>
+              </a:rPr>
+              <a:t>Takeaway: </a:t>
+            </a:r>
+            <a:r>
+              <a:rPr sz="2000" b="0" i="0">
+                <a:solidFill>
+                  <a:srgbClr val="000000"/>
+                </a:solidFill>
+                <a:latin typeface="Calibri"/>
+              </a:rPr>
+              <a:t>A zero allocation is model-specific, not a universal judgment about an asset.</a:t>
+            </a:r>
+          </a:p>
+        </p:txBody>
+      </p:sp>
+      <p:sp>
+        <p:nvSpPr>
+          <p:cNvPr id="7" name="TextBox 6"/>
+          <p:cNvSpPr txBox="1"/>
+          <p:nvPr/>
+        </p:nvSpPr>
+        <p:spPr>
+          <a:xfrm>
+            <a:off x="548640" y="6263640"/>
+            <a:ext cx="6400800" cy="411480"/>
+          </a:xfrm>
+          <a:prstGeom prst="rect">
+            <a:avLst/>
+          </a:prstGeom>
+          <a:noFill/>
+        </p:spPr>
+        <p:txBody>
+          <a:bodyPr wrap="square">
+            <a:spAutoFit/>
+          </a:bodyPr>
+          <a:lstStyle/>
+          <a:p>
+            <a:r>
+              <a:rPr sz="1400" b="0" i="0">
+                <a:solidFill>
+                  <a:srgbClr val="595959"/>
+                </a:solidFill>
+                <a:latin typeface="Calibri"/>
+              </a:rPr>
+              <a:t>Sheet: Sec 3A - 5-Stock Demo</a:t>
+            </a:r>
+          </a:p>
+        </p:txBody>
+      </p:sp>
+      <p:sp>
+        <p:nvSpPr>
+          <p:cNvPr id="8" name="TextBox 7"/>
+          <p:cNvSpPr txBox="1"/>
+          <p:nvPr/>
+        </p:nvSpPr>
+        <p:spPr>
+          <a:xfrm>
+            <a:off x="7040880" y="6263640"/>
+            <a:ext cx="4599432" cy="411480"/>
+          </a:xfrm>
+          <a:prstGeom prst="rect">
+            <a:avLst/>
+          </a:prstGeom>
+          <a:noFill/>
+        </p:spPr>
+        <p:txBody>
+          <a:bodyPr wrap="square">
+            <a:spAutoFit/>
+          </a:bodyPr>
+          <a:lstStyle/>
+          <a:p>
+            <a:pPr algn="r"/>
+            <a:r>
+              <a:rPr sz="1400" b="0" i="0">
+                <a:solidFill>
+                  <a:srgbClr val="595959"/>
+                </a:solidFill>
+                <a:latin typeface="Calibri"/>
+              </a:rPr>
+              <a:t>Cells A187</a:t>
+            </a:r>
+          </a:p>
+        </p:txBody>
+      </p:sp>
+    </p:spTree>
+  </p:cSld>
+  <p:clrMapOvr>
+    <a:masterClrMapping/>
+  </p:clrMapOvr>
+</p:sld>
+</file>
+
+<file path=ppt/slides/slide9.xml><?xml version="1.0" encoding="utf-8"?>
+<p:sld xmlns:a="http://schemas.openxmlformats.org/drawingml/2006/main" xmlns:p="http://schemas.openxmlformats.org/presentationml/2006/main" xmlns:r="http://schemas.openxmlformats.org/officeDocument/2006/relationships">
+  <p:cSld>
+    <p:spTree>
+      <p:nvGrpSpPr>
+        <p:cNvPr id="1" name=""/>
+        <p:cNvGrpSpPr/>
+        <p:nvPr/>
+      </p:nvGrpSpPr>
+      <p:grpSpPr/>
+      <p:sp>
+        <p:nvSpPr>
+          <p:cNvPr id="2" name="TextBox 1"/>
+          <p:cNvSpPr txBox="1"/>
+          <p:nvPr/>
+        </p:nvSpPr>
+        <p:spPr>
+          <a:xfrm>
+            <a:off x="548640" y="274320"/>
+            <a:ext cx="11091672" cy="365760"/>
+          </a:xfrm>
+          <a:prstGeom prst="rect">
+            <a:avLst/>
+          </a:prstGeom>
+          <a:noFill/>
+        </p:spPr>
+        <p:txBody>
+          <a:bodyPr wrap="square">
+            <a:spAutoFit/>
+          </a:bodyPr>
+          <a:lstStyle/>
+          <a:p>
+            <a:r>
+              <a:rPr sz="1600" b="0" i="0">
+                <a:solidFill>
+                  <a:srgbClr val="595959"/>
+                </a:solidFill>
+                <a:latin typeface="Calibri"/>
+              </a:rPr>
+              <a:t>Question 9</a:t>
+            </a:r>
+          </a:p>
+        </p:txBody>
+      </p:sp>
+      <p:sp>
+        <p:nvSpPr>
+          <p:cNvPr id="3" name="TextBox 2"/>
+          <p:cNvSpPr txBox="1"/>
+          <p:nvPr/>
+        </p:nvSpPr>
+        <p:spPr>
+          <a:xfrm>
+            <a:off x="548640" y="594360"/>
+            <a:ext cx="11091672" cy="640080"/>
+          </a:xfrm>
+          <a:prstGeom prst="rect">
+            <a:avLst/>
+          </a:prstGeom>
+          <a:noFill/>
+        </p:spPr>
+        <p:txBody>
+          <a:bodyPr wrap="square">
+            <a:spAutoFit/>
+          </a:bodyPr>
+          <a:lstStyle/>
+          <a:p>
+            <a:r>
+              <a:rPr sz="3000" b="1" i="0">
+                <a:solidFill>
+                  <a:srgbClr val="000000"/>
+                </a:solidFill>
+                <a:latin typeface="Calibri"/>
+              </a:rPr>
+              <a:t>What Does Holding Expected Return Constant Demonstrate?</a:t>
+            </a:r>
+          </a:p>
+        </p:txBody>
+      </p:sp>
+      <p:sp>
+        <p:nvSpPr>
+          <p:cNvPr id="4" name="TextBox 3"/>
+          <p:cNvSpPr txBox="1"/>
+          <p:nvPr/>
+        </p:nvSpPr>
+        <p:spPr>
+          <a:xfrm>
+            <a:off x="548640" y="1280160"/>
+            <a:ext cx="11091672" cy="457200"/>
+          </a:xfrm>
+          <a:prstGeom prst="rect">
+            <a:avLst/>
+          </a:prstGeom>
+          <a:noFill/>
+        </p:spPr>
+        <p:txBody>
+          <a:bodyPr wrap="square">
+            <a:spAutoFit/>
+          </a:bodyPr>
+          <a:lstStyle/>
+          <a:p>
+            <a:r>
+              <a:rPr sz="2000" b="1" i="0">
+                <a:solidFill>
+                  <a:srgbClr val="1F3A5F"/>
+                </a:solidFill>
+                <a:latin typeface="Calibri"/>
+              </a:rPr>
+              <a:t>Answer: </a:t>
+            </a:r>
+            <a:r>
+              <a:rPr sz="2000" b="0" i="0">
+                <a:solidFill>
+                  <a:srgbClr val="1F3A5F"/>
+                </a:solidFill>
+                <a:latin typeface="Calibri"/>
+              </a:rPr>
+              <a:t>B — the same expected return can be achieved with lower risk.</a:t>
+            </a:r>
+          </a:p>
+        </p:txBody>
+      </p:sp>
+      <p:sp>
+        <p:nvSpPr>
+          <p:cNvPr id="5" name="TextBox 4"/>
+          <p:cNvSpPr txBox="1"/>
+          <p:nvPr/>
+        </p:nvSpPr>
+        <p:spPr>
+          <a:xfrm>
+            <a:off x="548640" y="2011680"/>
+            <a:ext cx="11091672" cy="2743200"/>
+          </a:xfrm>
+          <a:prstGeom prst="rect">
+            <a:avLst/>
+          </a:prstGeom>
+          <a:noFill/>
+        </p:spPr>
+        <p:txBody>
+          <a:bodyPr wrap="square">
+            <a:spAutoFit/>
+          </a:bodyPr>
+          <a:lstStyle/>
+          <a:p>
+            <a:pPr marL="274320" indent="-274320">
+              <a:spcAft>
+                <a:spcPts val="1400"/>
+              </a:spcAft>
+              <a:buFont typeface="Arial"/>
+              <a:buChar char="•"/>
+            </a:pPr>
+            <a:r>
+              <a:rPr sz="2000" b="0" i="0">
+                <a:solidFill>
+                  <a:srgbClr val="000000"/>
+                </a:solidFill>
+                <a:latin typeface="Calibri"/>
+              </a:rPr>
+              <a:t>Step 7 fixes expected return at the equal-weighted portfolio’s level (13.77%).</a:t>
+            </a:r>
+          </a:p>
+          <a:p>
+            <a:pPr marL="274320" indent="-274320">
+              <a:spcAft>
+                <a:spcPts val="1400"/>
+              </a:spcAft>
+              <a:buFont typeface="Arial"/>
+              <a:buChar char="•"/>
+            </a:pPr>
+            <a:r>
+              <a:rPr sz="2000" b="0" i="0">
+                <a:solidFill>
+                  <a:srgbClr val="000000"/>
+                </a:solidFill>
+                <a:latin typeface="Calibri"/>
+              </a:rPr>
+              <a:t>Solver changes the weights to minimize portfolio variance: σ</a:t>
+            </a:r>
+            <a:r>
+              <a:rPr sz="2000" b="0" i="0" baseline="-25000">
+                <a:solidFill>
+                  <a:srgbClr val="000000"/>
+                </a:solidFill>
+                <a:latin typeface="Calibri"/>
+              </a:rPr>
+              <a:t>p</a:t>
+            </a:r>
+            <a:r>
+              <a:rPr sz="2000" b="0" i="0">
+                <a:solidFill>
+                  <a:srgbClr val="000000"/>
+                </a:solidFill>
+                <a:latin typeface="Calibri"/>
+              </a:rPr>
+              <a:t> falls from 13.56% to 11.40%.</a:t>
+            </a:r>
+          </a:p>
+          <a:p>
+            <a:pPr marL="274320" indent="-274320">
+              <a:spcAft>
+                <a:spcPts val="1400"/>
+              </a:spcAft>
+              <a:buFont typeface="Arial"/>
+              <a:buChar char="•"/>
+            </a:pPr>
+            <a:r>
+              <a:rPr sz="2000" b="0" i="0">
+                <a:solidFill>
+                  <a:srgbClr val="000000"/>
+                </a:solidFill>
+                <a:latin typeface="Calibri"/>
+              </a:rPr>
+              <a:t>The resulting risk reduction isolates the benefit of better portfolio construction—not accepting a lower return.</a:t>
+            </a:r>
+          </a:p>
+        </p:txBody>
+      </p:sp>
+      <p:sp>
+        <p:nvSpPr>
+          <p:cNvPr id="6" name="Rectangle 5"/>
+          <p:cNvSpPr/>
+          <p:nvPr/>
+        </p:nvSpPr>
+        <p:spPr>
+          <a:xfrm>
+            <a:off x="548640" y="4983480"/>
+            <a:ext cx="11091672" cy="914400"/>
+          </a:xfrm>
+          <a:prstGeom prst="rect">
+            <a:avLst/>
+          </a:prstGeom>
+          <a:solidFill>
+            <a:srgbClr val="E9EEF4"/>
+          </a:solidFill>
+          <a:ln>
+            <a:noFill/>
+          </a:ln>
+          <a:effectLst/>
+        </p:spPr>
+        <p:style>
+          <a:lnRef idx="1">
+            <a:schemeClr val="accent1"/>
+          </a:lnRef>
+          <a:fillRef idx="3">
+            <a:schemeClr val="accent1"/>
+          </a:fillRef>
+          <a:effectRef idx="2">
+            <a:schemeClr val="accent1"/>
+          </a:effectRef>
+          <a:fontRef idx="minor">
+            <a:schemeClr val="lt1"/>
+          </a:fontRef>
+        </p:style>
+        <p:txBody>
+          <a:bodyPr rtlCol="0" anchor="ctr" wrap="square" lIns="228600" rIns="228600"/>
+          <a:lstStyle/>
+          <a:p>
+            <a:pPr algn="l"/>
+            <a:r>
+              <a:rPr sz="2000" b="1" i="0">
+                <a:solidFill>
+                  <a:srgbClr val="1F3A5F"/>
+                </a:solidFill>
+                <a:latin typeface="Calibri"/>
+              </a:rPr>
+              <a:t>Takeaway: </a:t>
+            </a:r>
+            <a:r>
+              <a:rPr sz="2000" b="0" i="0">
+                <a:solidFill>
+                  <a:srgbClr val="000000"/>
+                </a:solidFill>
+                <a:latin typeface="Calibri"/>
+              </a:rPr>
+              <a:t>Better diversification can reduce risk without reducing expected return.</a:t>
+            </a:r>
+          </a:p>
+        </p:txBody>
+      </p:sp>
+      <p:sp>
+        <p:nvSpPr>
+          <p:cNvPr id="7" name="TextBox 6"/>
+          <p:cNvSpPr txBox="1"/>
+          <p:nvPr/>
+        </p:nvSpPr>
+        <p:spPr>
+          <a:xfrm>
+            <a:off x="548640" y="6263640"/>
+            <a:ext cx="6400800" cy="411480"/>
+          </a:xfrm>
+          <a:prstGeom prst="rect">
+            <a:avLst/>
+          </a:prstGeom>
+          <a:noFill/>
+        </p:spPr>
+        <p:txBody>
+          <a:bodyPr wrap="square">
+            <a:spAutoFit/>
+          </a:bodyPr>
+          <a:lstStyle/>
+          <a:p>
+            <a:r>
+              <a:rPr sz="1400" b="0" i="0">
+                <a:solidFill>
+                  <a:srgbClr val="595959"/>
+                </a:solidFill>
+                <a:latin typeface="Calibri"/>
+              </a:rPr>
+              <a:t>Sheet: Sec 3A - 5-Stock Demo</a:t>
+            </a:r>
+          </a:p>
+        </p:txBody>
+      </p:sp>
+      <p:sp>
+        <p:nvSpPr>
+          <p:cNvPr id="8" name="TextBox 7"/>
+          <p:cNvSpPr txBox="1"/>
+          <p:nvPr/>
+        </p:nvSpPr>
+        <p:spPr>
+          <a:xfrm>
+            <a:off x="7040880" y="6263640"/>
+            <a:ext cx="4599432" cy="411480"/>
+          </a:xfrm>
+          <a:prstGeom prst="rect">
+            <a:avLst/>
+          </a:prstGeom>
+          <a:noFill/>
+        </p:spPr>
+        <p:txBody>
+          <a:bodyPr wrap="square">
+            <a:spAutoFit/>
+          </a:bodyPr>
+          <a:lstStyle/>
+          <a:p>
+            <a:pPr algn="r"/>
+            <a:r>
+              <a:rPr sz="1400" b="0" i="0">
+                <a:solidFill>
+                  <a:srgbClr val="595959"/>
+                </a:solidFill>
+                <a:latin typeface="Calibri"/>
+              </a:rPr>
+              <a:t>Cells A190:A194</a:t>
             </a:r>
           </a:p>
         </p:txBody>

</xml_diff>